<commit_message>
Add researched figures to slide 2 and the revenue model to the sponsor slide
Slide 2 now leads with public figures (15,000 festival goers and 40 percent
from other countries at the first edition, 20,000 expected for the 5th),
the festival as a sponsorship instrument worth over 1 billion FCFA, and the
story so far from 2022 to 2026, with a sources line. The sponsor slide
carries the revenue model. Race Weekend is off the track record. Research
notes and sources are in research-slide-2.md.

Co-Authored-By: Claude Opus 5.5 <noreply@anthropic.com>
Claude-Session: https://claude.ai/code/session_01YTg2S2E4e7prUd2maqTatG
</commit_message>
<xml_diff>
--- a/proposition-deck/AToure Mother Africa Festival Proposal.pptx
+++ b/proposition-deck/AToure Mother Africa Festival Proposal.pptx
@@ -117,41 +117,41 @@
   <p:extLst>
     <p:ext uri="{521415D9-36F7-43E2-AB2F-B90AF26B5E84}">
       <p14:sectionLst xmlns:p14="http://schemas.microsoft.com/office/powerpoint/2010/main">
-        <p14:section name="Opening" id="{aa8baa7d-8338-22a5-99e6-4e24a1b377b5}">
+        <p14:section name="Opening" id="{04354458-7b03-ce9b-95cc-f23c95f8a679}">
           <p14:sldIdLst>
             <p14:sldId id="256"/>
           </p14:sldIdLst>
         </p14:section>
-        <p14:section name="Where we stand" id="{aba76259-1a75-8fa7-cf68-9506f57f1825}">
+        <p14:section name="Where we stand" id="{807591e4-ca4d-c80c-cc28-ce535a68e555}">
           <p14:sldIdLst>
             <p14:sldId id="257"/>
             <p14:sldId id="258"/>
           </p14:sldIdLst>
         </p14:section>
-        <p14:section name="The AToure answer" id="{8fbff4dd-0f60-fca7-674e-98a0450b65f7}">
+        <p14:section name="The AToure answer" id="{2ccc0e7f-3be1-42a2-112b-fb520960a4d3}">
           <p14:sldIdLst>
             <p14:sldId id="259"/>
             <p14:sldId id="260"/>
           </p14:sldIdLst>
         </p14:section>
-        <p14:section name="Visibility" id="{a14b0a46-d7db-7e45-7523-93a132ffbc8d}">
+        <p14:section name="Visibility" id="{4f0cc013-ed16-31c1-f320-f00396fed880}">
           <p14:sldIdLst>
             <p14:sldId id="261"/>
             <p14:sldId id="262"/>
           </p14:sldIdLst>
         </p14:section>
-        <p14:section name="The visibility report" id="{e6abcbe9-abe5-ce5d-fde4-f3cc194975c3}">
+        <p14:section name="The visibility report" id="{8eb308de-b9cd-c380-2333-b7c85db1df64}">
           <p14:sldIdLst>
             <p14:sldId id="263"/>
             <p14:sldId id="264"/>
           </p14:sldIdLst>
         </p14:section>
-        <p14:section name="Proof" id="{fc2ba310-1718-3c19-c4d3-1b42352da6c1}">
+        <p14:section name="Proof" id="{bea4a2c9-a6c1-f697-9fc4-ba3a437d0f2e}">
           <p14:sldIdLst>
             <p14:sldId id="265"/>
           </p14:sldIdLst>
         </p14:section>
-        <p14:section name="The ask" id="{a0f92758-4b69-4ac4-53cf-e76757a44841}">
+        <p14:section name="The ask" id="{28a184f7-8718-fd31-4fd0-645d471964e1}">
           <p14:sldIdLst>
             <p14:sldId id="266"/>
           </p14:sldIdLst>
@@ -648,7 +648,7 @@
           <a:p>
             <a:r>
               <a:rPr lang="en-US" dirty="0"/>
-              <a:t>This is not a new capability. In Abidjan, AToure built the IShowSpeed operation from zero, and ran Race Weekend Abidjan, its own event, with partner brands and Ivorian creators. In Morocco it delivered the AFCON mascot reveal with CAF and the FRMF. The Ashton Hall tour covered five countries end to end. Confirm the Ashton Hall figure before presenting: the decks use 1.57 billion, the website uses the media kit figure.</a:t>
+              <a:t>This is not a new capability. In Abidjan, AToure built the IShowSpeed operation from zero. In Morocco it delivered the AFCON mascot reveal with CAF and the Royal Moroccan Football Federation. The Ashton Hall tour covered five countries, managed end to end.</a:t>
             </a:r>
             <a:endParaRPr lang="en-US" dirty="0"/>
           </a:p>
@@ -824,7 +824,7 @@
           <a:p>
             <a:r>
               <a:rPr lang="en-US" dirty="0"/>
-              <a:t>Everything on the left comes from the festival’s own posters and press material. Ask the team to correct anything we have wrong. The right side is what any festival needs once it starts selling its audience to sponsors. Present it as the next stage, not as a list of faults.</a:t>
+              <a:t>Everything on the left comes from public reporting and the festival’s own announcements, so ask the team to correct anything we have wrong. 15,000 and 40 percent are the figures reported for the first edition in December 2022. 20,000 is what the organisers expect for the 5th edition, not a result. The 1 billion FCFA figure is the festival’s weight as a sponsorship instrument. The right side is what any festival needs once it sells its audience to sponsors: present it as the next stage, not as a list of faults. Sources: Africa Radio, Music In Africa, Abidjan.net, Liferadio, France 24, Pulse and allAfrica.</a:t>
             </a:r>
             <a:endParaRPr lang="en-US" dirty="0"/>
           </a:p>
@@ -1264,7 +1264,7 @@
           <a:p>
             <a:r>
               <a:rPr lang="en-US" dirty="0"/>
-              <a:t>Sponsors are paying for visibility, and creators are one of the best ways to deliver it. Sponsor mentions go into every brief, creators are guided to each activation and stage banner on both nights, and every partner gets its own page in the report. That page is what helps the festival renew its sponsors for 2027. Any media value is an estimate and is labelled as one.</a:t>
+              <a:t>Sponsors are paying for visibility, and creators are one of the best ways to deliver it. Sponsor mentions go into every brief, creators are guided to each activation and stage banner on both nights, and every partner gets its own page in the report. The revenue model is the same chain as before, seen from the sponsor’s side: more creators bring more visibility, visibility meets the brands’ goals, and met goals bring sponsor money back for 2027. Any media value is an estimate and is labelled as one.</a:t>
             </a:r>
             <a:endParaRPr lang="en-US" dirty="0"/>
           </a:p>
@@ -3544,7 +3544,7 @@
         <p:spPr>
           <a:xfrm>
             <a:off x="548640" y="1783080"/>
-            <a:ext cx="3615240" cy="2514600"/>
+            <a:ext cx="3943898" cy="2743200"/>
           </a:xfrm>
           <a:prstGeom prst="rect">
             <a:avLst/>
@@ -3559,7 +3559,7 @@
         </p:nvSpPr>
         <p:spPr>
           <a:xfrm>
-            <a:off x="658368" y="3895344"/>
+            <a:off x="658368" y="4123944"/>
             <a:ext cx="796442" cy="292608"/>
           </a:xfrm>
           <a:prstGeom prst="roundRect">
@@ -3583,7 +3583,7 @@
         </p:nvSpPr>
         <p:spPr>
           <a:xfrm>
-            <a:off x="658368" y="3895344"/>
+            <a:off x="658368" y="4123944"/>
             <a:ext cx="796442" cy="292608"/>
           </a:xfrm>
           <a:prstGeom prst="rect">
@@ -3619,8 +3619,8 @@
         </p:nvSpPr>
         <p:spPr>
           <a:xfrm>
-            <a:off x="548640" y="4434840"/>
-            <a:ext cx="3615240" cy="457200"/>
+            <a:off x="548640" y="4663440"/>
+            <a:ext cx="3943898" cy="457200"/>
           </a:xfrm>
           <a:prstGeom prst="rect">
             <a:avLst/>
@@ -3655,8 +3655,8 @@
         </p:nvSpPr>
         <p:spPr>
           <a:xfrm>
-            <a:off x="548640" y="4937760"/>
-            <a:ext cx="3615240" cy="777240"/>
+            <a:off x="548640" y="5138928"/>
+            <a:ext cx="3943898" cy="685800"/>
           </a:xfrm>
           <a:prstGeom prst="rect">
             <a:avLst/>
@@ -3699,8 +3699,8 @@
         </p:blipFill>
         <p:spPr>
           <a:xfrm>
-            <a:off x="4438200" y="1783080"/>
-            <a:ext cx="1679194" cy="2514600"/>
+            <a:off x="4766858" y="1783080"/>
+            <a:ext cx="1831848" cy="2743200"/>
           </a:xfrm>
           <a:prstGeom prst="rect">
             <a:avLst/>
@@ -3715,7 +3715,7 @@
         </p:nvSpPr>
         <p:spPr>
           <a:xfrm>
-            <a:off x="4547928" y="3895344"/>
+            <a:off x="4876586" y="4123944"/>
             <a:ext cx="796442" cy="292608"/>
           </a:xfrm>
           <a:prstGeom prst="roundRect">
@@ -3739,7 +3739,7 @@
         </p:nvSpPr>
         <p:spPr>
           <a:xfrm>
-            <a:off x="4547928" y="3895344"/>
+            <a:off x="4876586" y="4123944"/>
             <a:ext cx="796442" cy="292608"/>
           </a:xfrm>
           <a:prstGeom prst="rect">
@@ -3775,8 +3775,8 @@
         </p:nvSpPr>
         <p:spPr>
           <a:xfrm>
-            <a:off x="4438200" y="4434840"/>
-            <a:ext cx="1679194" cy="457200"/>
+            <a:off x="4766858" y="4663440"/>
+            <a:ext cx="1831848" cy="457200"/>
           </a:xfrm>
           <a:prstGeom prst="rect">
             <a:avLst/>
@@ -3811,8 +3811,8 @@
         </p:nvSpPr>
         <p:spPr>
           <a:xfrm>
-            <a:off x="4438200" y="4937760"/>
-            <a:ext cx="1679194" cy="777240"/>
+            <a:off x="4766858" y="5138928"/>
+            <a:ext cx="1831848" cy="685800"/>
           </a:xfrm>
           <a:prstGeom prst="rect">
             <a:avLst/>
@@ -3855,8 +3855,8 @@
         </p:blipFill>
         <p:spPr>
           <a:xfrm>
-            <a:off x="6391714" y="1783080"/>
-            <a:ext cx="2011680" cy="2514600"/>
+            <a:off x="6873026" y="1783080"/>
+            <a:ext cx="2194560" cy="2743200"/>
           </a:xfrm>
           <a:prstGeom prst="rect">
             <a:avLst/>
@@ -3871,7 +3871,7 @@
         </p:nvSpPr>
         <p:spPr>
           <a:xfrm>
-            <a:off x="6501442" y="3895344"/>
+            <a:off x="6982754" y="4123944"/>
             <a:ext cx="662940" cy="292608"/>
           </a:xfrm>
           <a:prstGeom prst="roundRect">
@@ -3895,7 +3895,7 @@
         </p:nvSpPr>
         <p:spPr>
           <a:xfrm>
-            <a:off x="6501442" y="3895344"/>
+            <a:off x="6982754" y="4123944"/>
             <a:ext cx="662940" cy="292608"/>
           </a:xfrm>
           <a:prstGeom prst="rect">
@@ -3931,8 +3931,8 @@
         </p:nvSpPr>
         <p:spPr>
           <a:xfrm>
-            <a:off x="6391714" y="4434840"/>
-            <a:ext cx="2011680" cy="457200"/>
+            <a:off x="6873026" y="4663440"/>
+            <a:ext cx="2194560" cy="457200"/>
           </a:xfrm>
           <a:prstGeom prst="rect">
             <a:avLst/>
@@ -3967,8 +3967,8 @@
         </p:nvSpPr>
         <p:spPr>
           <a:xfrm>
-            <a:off x="6391714" y="4937760"/>
-            <a:ext cx="2011680" cy="777240"/>
+            <a:off x="6873026" y="5138928"/>
+            <a:ext cx="2194560" cy="685800"/>
           </a:xfrm>
           <a:prstGeom prst="rect">
             <a:avLst/>
@@ -4003,12 +4003,12 @@
         </p:nvSpPr>
         <p:spPr>
           <a:xfrm>
-            <a:off x="8677714" y="1783080"/>
-            <a:ext cx="2965342" cy="2514600"/>
+            <a:off x="9387626" y="1783080"/>
+            <a:ext cx="2255429" cy="2743200"/>
           </a:xfrm>
           <a:prstGeom prst="roundRect">
             <a:avLst>
-              <a:gd name="adj" fmla="val 3636"/>
+              <a:gd name="adj" fmla="val 4054"/>
             </a:avLst>
           </a:prstGeom>
           <a:solidFill>
@@ -4032,8 +4032,8 @@
         </p:nvSpPr>
         <p:spPr>
           <a:xfrm>
-            <a:off x="8906314" y="2057400"/>
-            <a:ext cx="2508142" cy="548640"/>
+            <a:off x="9588794" y="2011680"/>
+            <a:ext cx="1889669" cy="256032"/>
           </a:xfrm>
           <a:prstGeom prst="rect">
             <a:avLst/>
@@ -4054,7 +4054,7 @@
                   <a:schemeClr val="accent1"/>
                 </a:solidFill>
               </a:rPr>
-              <a:t>RACE WEEKEND ABIDJAN 2026</a:t>
+              <a:t>WHAT ATOURE DID</a:t>
             </a:r>
             <a:endParaRPr lang="en-GB" sz="1100" dirty="0"/>
           </a:p>
@@ -4068,8 +4068,8 @@
         </p:nvSpPr>
         <p:spPr>
           <a:xfrm>
-            <a:off x="8906314" y="2679192"/>
-            <a:ext cx="2508142" cy="1463040"/>
+            <a:off x="9588794" y="2423160"/>
+            <a:ext cx="1889669" cy="1965960"/>
           </a:xfrm>
           <a:prstGeom prst="rect">
             <a:avLst/>
@@ -4081,127 +4081,110 @@
           <a:bodyPr wrap="square" lIns="0" tIns="0" rIns="0" bIns="0" rtlCol="0" anchor="t"/>
           <a:lstStyle/>
           <a:p>
+            <a:pPr marL="177800" indent="-177800">
+              <a:spcAft>
+                <a:spcPts val="800"/>
+              </a:spcAft>
+              <a:buSzPct val="100000"/>
+              <a:buChar char="•"/>
+            </a:pPr>
+            <a:r>
+              <a:rPr lang="en-GB" altLang="en-US" sz="1200" dirty="0">
+                <a:solidFill>
+                  <a:schemeClr val="accent5"/>
+                </a:solidFill>
+              </a:rPr>
+              <a:t>Operations built from zero in Abidjan</a:t>
+            </a:r>
+            <a:endParaRPr lang="en-GB" sz="1200" dirty="0"/>
+          </a:p>
+          <a:p>
+            <a:pPr marL="177800" indent="-177800">
+              <a:spcAft>
+                <a:spcPts val="800"/>
+              </a:spcAft>
+              <a:buSzPct val="100000"/>
+              <a:buChar char="•"/>
+            </a:pPr>
+            <a:r>
+              <a:rPr lang="en-GB" altLang="en-US" sz="1200" dirty="0">
+                <a:solidFill>
+                  <a:schemeClr val="accent5"/>
+                </a:solidFill>
+              </a:rPr>
+              <a:t>State visas, permits and security</a:t>
+            </a:r>
+            <a:endParaRPr lang="en-GB" sz="1200" dirty="0"/>
+          </a:p>
+          <a:p>
+            <a:pPr marL="177800" indent="-177800">
+              <a:spcAft>
+                <a:spcPts val="800"/>
+              </a:spcAft>
+              <a:buSzPct val="100000"/>
+              <a:buChar char="•"/>
+            </a:pPr>
+            <a:r>
+              <a:rPr lang="en-GB" altLang="en-US" sz="1200" dirty="0">
+                <a:solidFill>
+                  <a:schemeClr val="accent5"/>
+                </a:solidFill>
+              </a:rPr>
+              <a:t>Sponsors and partners brought in</a:t>
+            </a:r>
+            <a:endParaRPr lang="en-GB" sz="1200" dirty="0"/>
+          </a:p>
+          <a:p>
+            <a:pPr marL="177800" indent="-177800">
+              <a:spcAft>
+                <a:spcPts val="800"/>
+              </a:spcAft>
+              <a:buSzPct val="100000"/>
+              <a:buChar char="•"/>
+            </a:pPr>
+            <a:r>
+              <a:rPr lang="en-GB" altLang="en-US" sz="1200" dirty="0">
+                <a:solidFill>
+                  <a:schemeClr val="accent5"/>
+                </a:solidFill>
+              </a:rPr>
+              <a:t>Creators managed end to end</a:t>
+            </a:r>
+            <a:endParaRPr lang="en-GB" sz="1200" dirty="0"/>
+          </a:p>
+        </p:txBody>
+      </p:sp>
+      <p:sp>
+        <p:nvSpPr>
+          <p:cNvPr id="28" name="Text 19"/>
+          <p:cNvSpPr txBox="1"/>
+          <p:nvPr/>
+        </p:nvSpPr>
+        <p:spPr>
+          <a:xfrm>
+            <a:off x="548640" y="5943600"/>
+            <a:ext cx="11094415" cy="237744"/>
+          </a:xfrm>
+          <a:prstGeom prst="rect">
+            <a:avLst/>
+          </a:prstGeom>
+          <a:noFill/>
+          <a:ln/>
+        </p:spPr>
+        <p:txBody>
+          <a:bodyPr wrap="square" lIns="0" tIns="0" rIns="0" bIns="0" rtlCol="0" anchor="t"/>
+          <a:lstStyle/>
+          <a:p>
             <a:pPr indent="0" marL="0">
               <a:buNone/>
             </a:pPr>
             <a:r>
-              <a:rPr lang="en-GB" altLang="en-US" sz="1800" dirty="0">
-                <a:solidFill>
-                  <a:schemeClr val="bg1"/>
-                </a:solidFill>
-                <a:latin typeface="+mj-lt" pitchFamily="34" charset="0"/>
-                <a:ea typeface="+mj-lt" pitchFamily="34" charset="-122"/>
-                <a:cs typeface="+mj-lt" pitchFamily="34" charset="-120"/>
-              </a:rPr>
-              <a:t>AToure’s own event: the first premium Formula 1 activation staged in Côte d’Ivoire.</a:t>
-            </a:r>
-            <a:endParaRPr lang="en-GB" sz="1800" dirty="0"/>
-          </a:p>
-        </p:txBody>
-      </p:sp>
-      <p:sp>
-        <p:nvSpPr>
-          <p:cNvPr id="28" name="Text 19"/>
-          <p:cNvSpPr txBox="1"/>
-          <p:nvPr/>
-        </p:nvSpPr>
-        <p:spPr>
-          <a:xfrm>
-            <a:off x="8677714" y="4434840"/>
-            <a:ext cx="2965342" cy="457200"/>
-          </a:xfrm>
-          <a:prstGeom prst="rect">
-            <a:avLst/>
-          </a:prstGeom>
-          <a:noFill/>
-          <a:ln/>
-        </p:spPr>
-        <p:txBody>
-          <a:bodyPr wrap="square" lIns="0" tIns="0" rIns="0" bIns="0" rtlCol="0" anchor="t"/>
-          <a:lstStyle/>
-          <a:p>
-            <a:pPr indent="0" marL="0">
-              <a:buNone/>
-            </a:pPr>
-            <a:r>
-              <a:rPr lang="en-GB" altLang="en-US" sz="2800" dirty="0">
-                <a:solidFill>
-                  <a:schemeClr val="accent4"/>
-                </a:solidFill>
-              </a:rPr>
-              <a:t>600</a:t>
-            </a:r>
-            <a:endParaRPr lang="en-GB" sz="2800" dirty="0"/>
-          </a:p>
-        </p:txBody>
-      </p:sp>
-      <p:sp>
-        <p:nvSpPr>
-          <p:cNvPr id="29" name="Text 20"/>
-          <p:cNvSpPr txBox="1"/>
-          <p:nvPr/>
-        </p:nvSpPr>
-        <p:spPr>
-          <a:xfrm>
-            <a:off x="8677714" y="4937760"/>
-            <a:ext cx="2965342" cy="777240"/>
-          </a:xfrm>
-          <a:prstGeom prst="rect">
-            <a:avLst/>
-          </a:prstGeom>
-          <a:noFill/>
-          <a:ln/>
-        </p:spPr>
-        <p:txBody>
-          <a:bodyPr wrap="square" lIns="0" tIns="0" rIns="0" bIns="0" rtlCol="0" anchor="t"/>
-          <a:lstStyle/>
-          <a:p>
-            <a:pPr indent="0" marL="0">
-              <a:buNone/>
-            </a:pPr>
-            <a:r>
-              <a:rPr lang="en-GB" altLang="en-US" sz="1100" dirty="0">
+              <a:rPr lang="en-GB" altLang="en-US" sz="1000" dirty="0">
                 <a:solidFill>
                   <a:schemeClr val="accent5"/>
                 </a:solidFill>
               </a:rPr>
-              <a:t>Guests over two days, with 9 partner brands and 7 Ivorian creators booked.</a:t>
-            </a:r>
-            <a:endParaRPr lang="en-GB" sz="1100" dirty="0"/>
-          </a:p>
-        </p:txBody>
-      </p:sp>
-      <p:sp>
-        <p:nvSpPr>
-          <p:cNvPr id="30" name="Text 21"/>
-          <p:cNvSpPr txBox="1"/>
-          <p:nvPr/>
-        </p:nvSpPr>
-        <p:spPr>
-          <a:xfrm>
-            <a:off x="548640" y="5897880"/>
-            <a:ext cx="11094415" cy="237744"/>
-          </a:xfrm>
-          <a:prstGeom prst="rect">
-            <a:avLst/>
-          </a:prstGeom>
-          <a:noFill/>
-          <a:ln/>
-        </p:spPr>
-        <p:txBody>
-          <a:bodyPr wrap="square" lIns="0" tIns="0" rIns="0" bIns="0" rtlCol="0" anchor="t"/>
-          <a:lstStyle/>
-          <a:p>
-            <a:pPr indent="0" marL="0">
-              <a:buNone/>
-            </a:pPr>
-            <a:r>
-              <a:rPr lang="en-GB" altLang="en-US" sz="1000" dirty="0">
-                <a:solidFill>
-                  <a:schemeClr val="accent5"/>
-                </a:solidFill>
-              </a:rPr>
-              <a:t>Sources: Instagram and YouTube analytics, tour figures supplied by the client, AToure event records.</a:t>
+              <a:t>Sources: Instagram and YouTube analytics, tour figures supplied by the client.</a:t>
             </a:r>
             <a:endParaRPr lang="en-GB" sz="1000" dirty="0"/>
           </a:p>
@@ -5421,12 +5404,10 @@
         <p:spPr>
           <a:xfrm>
             <a:off x="548640" y="1783080"/>
-            <a:ext cx="2971800" cy="1965960"/>
-          </a:xfrm>
-          <a:prstGeom prst="roundRect">
-            <a:avLst>
-              <a:gd name="adj" fmla="val 4651"/>
-            </a:avLst>
+            <a:ext cx="3086100" cy="1097280"/>
+          </a:xfrm>
+          <a:prstGeom prst="rect">
+            <a:avLst/>
           </a:prstGeom>
           <a:solidFill>
             <a:schemeClr val="bg1"/>
@@ -5439,13 +5420,6 @@
             </a:solidFill>
             <a:prstDash val="solid"/>
           </a:ln>
-          <a:effectLst>
-            <a:outerShdw sx="100000" sy="100000" kx="0" ky="0" algn="bl" rotWithShape="0" blurRad="127000" dist="38100" dir="5400000">
-              <a:srgbClr val="133524">
-                <a:alpha val="10000"/>
-              </a:srgbClr>
-            </a:outerShdw>
-          </a:effectLst>
         </p:spPr>
       </p:sp>
       <p:sp>
@@ -5456,52 +5430,28 @@
         </p:nvSpPr>
         <p:spPr>
           <a:xfrm>
-            <a:off x="822960" y="2057400"/>
-            <a:ext cx="502920" cy="502920"/>
-          </a:xfrm>
-          <a:prstGeom prst="ellipse">
+            <a:off x="548640" y="1783080"/>
+            <a:ext cx="3086100" cy="45720"/>
+          </a:xfrm>
+          <a:prstGeom prst="rect">
             <a:avLst/>
           </a:prstGeom>
           <a:solidFill>
-            <a:schemeClr val="accent2"/>
+            <a:schemeClr val="accent1"/>
           </a:solidFill>
           <a:ln/>
         </p:spPr>
       </p:sp>
-      <p:pic>
-        <p:nvPicPr>
-          <p:cNvPr id="10" name="Image 2" descr="preencoded.png">    </p:cNvPr>
-          <p:cNvPicPr>
-            <a:picLocks noChangeAspect="1"/>
-          </p:cNvPicPr>
-          <p:nvPr/>
-        </p:nvPicPr>
-        <p:blipFill>
-          <a:blip r:embed="rId3"/>
-          <a:stretch>
-            <a:fillRect/>
-          </a:stretch>
-        </p:blipFill>
-        <p:spPr>
-          <a:xfrm>
-            <a:off x="943661" y="2178101"/>
-            <a:ext cx="261518" cy="261518"/>
-          </a:xfrm>
-          <a:prstGeom prst="rect">
-            <a:avLst/>
-          </a:prstGeom>
-        </p:spPr>
-      </p:pic>
-      <p:sp>
-        <p:nvSpPr>
-          <p:cNvPr id="11" name="Text 5"/>
-          <p:cNvSpPr txBox="1"/>
-          <p:nvPr/>
-        </p:nvSpPr>
-        <p:spPr>
-          <a:xfrm>
-            <a:off x="822960" y="2679192"/>
-            <a:ext cx="2423160" cy="347472"/>
+      <p:sp>
+        <p:nvSpPr>
+          <p:cNvPr id="10" name="Text 5"/>
+          <p:cNvSpPr txBox="1"/>
+          <p:nvPr/>
+        </p:nvSpPr>
+        <p:spPr>
+          <a:xfrm>
+            <a:off x="777240" y="1929384"/>
+            <a:ext cx="2628900" cy="457200"/>
           </a:xfrm>
           <a:prstGeom prst="rect">
             <a:avLst/>
@@ -5517,30 +5467,27 @@
               <a:buNone/>
             </a:pPr>
             <a:r>
-              <a:rPr lang="en-GB" altLang="en-US" sz="2000" dirty="0">
-                <a:solidFill>
-                  <a:schemeClr val="tx1"/>
-                </a:solidFill>
-                <a:latin typeface="+mj-lt" pitchFamily="34" charset="0"/>
-                <a:ea typeface="+mj-lt" pitchFamily="34" charset="-122"/>
-                <a:cs typeface="+mj-lt" pitchFamily="34" charset="-120"/>
-              </a:rPr>
-              <a:t>Four editions</a:t>
-            </a:r>
-            <a:endParaRPr lang="en-GB" sz="2000" dirty="0"/>
-          </a:p>
-        </p:txBody>
-      </p:sp>
-      <p:sp>
-        <p:nvSpPr>
-          <p:cNvPr id="12" name="Text 6"/>
-          <p:cNvSpPr txBox="1"/>
-          <p:nvPr/>
-        </p:nvSpPr>
-        <p:spPr>
-          <a:xfrm>
-            <a:off x="822960" y="3063240"/>
-            <a:ext cx="2423160" cy="640080"/>
+              <a:rPr lang="en-GB" altLang="en-US" sz="2800" b="1" dirty="0">
+                <a:solidFill>
+                  <a:schemeClr val="accent3"/>
+                </a:solidFill>
+              </a:rPr>
+              <a:t>15,000+</a:t>
+            </a:r>
+            <a:endParaRPr lang="en-GB" sz="2800" dirty="0"/>
+          </a:p>
+        </p:txBody>
+      </p:sp>
+      <p:sp>
+        <p:nvSpPr>
+          <p:cNvPr id="11" name="Text 6"/>
+          <p:cNvSpPr txBox="1"/>
+          <p:nvPr/>
+        </p:nvSpPr>
+        <p:spPr>
+          <a:xfrm>
+            <a:off x="777240" y="2423160"/>
+            <a:ext cx="2674620" cy="384048"/>
           </a:xfrm>
           <a:prstGeom prst="rect">
             <a:avLst/>
@@ -5556,32 +5503,30 @@
               <a:buNone/>
             </a:pPr>
             <a:r>
-              <a:rPr lang="en-GB" altLang="en-US" sz="1300" dirty="0">
+              <a:rPr lang="en-GB" altLang="en-US" sz="1200" dirty="0">
                 <a:solidFill>
                   <a:schemeClr val="tx2"/>
                 </a:solidFill>
               </a:rPr>
-              <a:t>The 4th edition ran at Marcory Zone 4 on 27 and 28 December 2025.</a:t>
-            </a:r>
-            <a:endParaRPr lang="en-GB" sz="1300" dirty="0"/>
-          </a:p>
-        </p:txBody>
-      </p:sp>
-      <p:sp>
-        <p:nvSpPr>
-          <p:cNvPr id="13" name="Shape 7"/>
+              <a:t>Festival goers at the first edition, December 2022</a:t>
+            </a:r>
+            <a:endParaRPr lang="en-GB" sz="1200" dirty="0"/>
+          </a:p>
+        </p:txBody>
+      </p:sp>
+      <p:sp>
+        <p:nvSpPr>
+          <p:cNvPr id="12" name="Shape 7"/>
           <p:cNvSpPr/>
           <p:nvPr/>
         </p:nvSpPr>
         <p:spPr>
           <a:xfrm>
-            <a:off x="3749040" y="1783080"/>
-            <a:ext cx="2971800" cy="1965960"/>
-          </a:xfrm>
-          <a:prstGeom prst="roundRect">
-            <a:avLst>
-              <a:gd name="adj" fmla="val 4651"/>
-            </a:avLst>
+            <a:off x="3863340" y="1783080"/>
+            <a:ext cx="3086100" cy="1097280"/>
+          </a:xfrm>
+          <a:prstGeom prst="rect">
+            <a:avLst/>
           </a:prstGeom>
           <a:solidFill>
             <a:schemeClr val="bg1"/>
@@ -5594,69 +5539,38 @@
             </a:solidFill>
             <a:prstDash val="solid"/>
           </a:ln>
-          <a:effectLst>
-            <a:outerShdw sx="100000" sy="100000" kx="0" ky="0" algn="bl" rotWithShape="0" blurRad="127000" dist="38100" dir="5400000">
-              <a:srgbClr val="133524">
-                <a:alpha val="10000"/>
-              </a:srgbClr>
-            </a:outerShdw>
-          </a:effectLst>
-        </p:spPr>
-      </p:sp>
-      <p:sp>
-        <p:nvSpPr>
-          <p:cNvPr id="14" name="Shape 8"/>
+        </p:spPr>
+      </p:sp>
+      <p:sp>
+        <p:nvSpPr>
+          <p:cNvPr id="13" name="Shape 8"/>
           <p:cNvSpPr/>
           <p:nvPr/>
         </p:nvSpPr>
         <p:spPr>
           <a:xfrm>
-            <a:off x="4023360" y="2057400"/>
-            <a:ext cx="502920" cy="502920"/>
-          </a:xfrm>
-          <a:prstGeom prst="ellipse">
+            <a:off x="3863340" y="1783080"/>
+            <a:ext cx="3086100" cy="45720"/>
+          </a:xfrm>
+          <a:prstGeom prst="rect">
             <a:avLst/>
           </a:prstGeom>
           <a:solidFill>
-            <a:schemeClr val="accent2"/>
+            <a:schemeClr val="accent1"/>
           </a:solidFill>
           <a:ln/>
         </p:spPr>
       </p:sp>
-      <p:pic>
-        <p:nvPicPr>
-          <p:cNvPr id="15" name="Image 3" descr="preencoded.png">    </p:cNvPr>
-          <p:cNvPicPr>
-            <a:picLocks noChangeAspect="1"/>
-          </p:cNvPicPr>
-          <p:nvPr/>
-        </p:nvPicPr>
-        <p:blipFill>
-          <a:blip r:embed="rId4"/>
-          <a:stretch>
-            <a:fillRect/>
-          </a:stretch>
-        </p:blipFill>
-        <p:spPr>
-          <a:xfrm>
-            <a:off x="4144061" y="2178101"/>
-            <a:ext cx="261518" cy="261518"/>
-          </a:xfrm>
-          <a:prstGeom prst="rect">
-            <a:avLst/>
-          </a:prstGeom>
-        </p:spPr>
-      </p:pic>
-      <p:sp>
-        <p:nvSpPr>
-          <p:cNvPr id="16" name="Text 9"/>
-          <p:cNvSpPr txBox="1"/>
-          <p:nvPr/>
-        </p:nvSpPr>
-        <p:spPr>
-          <a:xfrm>
-            <a:off x="4023360" y="2679192"/>
-            <a:ext cx="2423160" cy="347472"/>
+      <p:sp>
+        <p:nvSpPr>
+          <p:cNvPr id="14" name="Text 9"/>
+          <p:cNvSpPr txBox="1"/>
+          <p:nvPr/>
+        </p:nvSpPr>
+        <p:spPr>
+          <a:xfrm>
+            <a:off x="4091940" y="1929384"/>
+            <a:ext cx="2628900" cy="457200"/>
           </a:xfrm>
           <a:prstGeom prst="rect">
             <a:avLst/>
@@ -5672,30 +5586,27 @@
               <a:buNone/>
             </a:pPr>
             <a:r>
-              <a:rPr lang="en-GB" altLang="en-US" sz="2000" dirty="0">
-                <a:solidFill>
-                  <a:schemeClr val="tx1"/>
-                </a:solidFill>
-                <a:latin typeface="+mj-lt" pitchFamily="34" charset="0"/>
-                <a:ea typeface="+mj-lt" pitchFamily="34" charset="-122"/>
-                <a:cs typeface="+mj-lt" pitchFamily="34" charset="-120"/>
-              </a:rPr>
-              <a:t>Davido for year five</a:t>
-            </a:r>
-            <a:endParaRPr lang="en-GB" sz="2000" dirty="0"/>
-          </a:p>
-        </p:txBody>
-      </p:sp>
-      <p:sp>
-        <p:nvSpPr>
-          <p:cNvPr id="17" name="Text 10"/>
-          <p:cNvSpPr txBox="1"/>
-          <p:nvPr/>
-        </p:nvSpPr>
-        <p:spPr>
-          <a:xfrm>
-            <a:off x="4023360" y="3063240"/>
-            <a:ext cx="2423160" cy="640080"/>
+              <a:rPr lang="en-GB" altLang="en-US" sz="2800" b="1" dirty="0">
+                <a:solidFill>
+                  <a:schemeClr val="accent3"/>
+                </a:solidFill>
+              </a:rPr>
+              <a:t>40%</a:t>
+            </a:r>
+            <a:endParaRPr lang="en-GB" sz="2800" dirty="0"/>
+          </a:p>
+        </p:txBody>
+      </p:sp>
+      <p:sp>
+        <p:nvSpPr>
+          <p:cNvPr id="15" name="Text 10"/>
+          <p:cNvSpPr txBox="1"/>
+          <p:nvPr/>
+        </p:nvSpPr>
+        <p:spPr>
+          <a:xfrm>
+            <a:off x="4091940" y="2423160"/>
+            <a:ext cx="2674620" cy="384048"/>
           </a:xfrm>
           <a:prstGeom prst="rect">
             <a:avLst/>
@@ -5711,32 +5622,30 @@
               <a:buNone/>
             </a:pPr>
             <a:r>
-              <a:rPr lang="en-GB" altLang="en-US" sz="1300" dirty="0">
+              <a:rPr lang="en-GB" altLang="en-US" sz="1200" dirty="0">
                 <a:solidFill>
                   <a:schemeClr val="tx2"/>
                 </a:solidFill>
               </a:rPr>
-              <a:t>Davido headlines the 5th edition, the festival’s anniversary year.</a:t>
-            </a:r>
-            <a:endParaRPr lang="en-GB" sz="1300" dirty="0"/>
-          </a:p>
-        </p:txBody>
-      </p:sp>
-      <p:sp>
-        <p:nvSpPr>
-          <p:cNvPr id="18" name="Shape 11"/>
+              <a:t>Of them came from other countries, as reported</a:t>
+            </a:r>
+            <a:endParaRPr lang="en-GB" sz="1200" dirty="0"/>
+          </a:p>
+        </p:txBody>
+      </p:sp>
+      <p:sp>
+        <p:nvSpPr>
+          <p:cNvPr id="16" name="Shape 11"/>
           <p:cNvSpPr/>
           <p:nvPr/>
         </p:nvSpPr>
         <p:spPr>
           <a:xfrm>
-            <a:off x="548640" y="3977640"/>
-            <a:ext cx="2971800" cy="1965960"/>
-          </a:xfrm>
-          <a:prstGeom prst="roundRect">
-            <a:avLst>
-              <a:gd name="adj" fmla="val 4651"/>
-            </a:avLst>
+            <a:off x="548640" y="3044952"/>
+            <a:ext cx="3086100" cy="1097280"/>
+          </a:xfrm>
+          <a:prstGeom prst="rect">
+            <a:avLst/>
           </a:prstGeom>
           <a:solidFill>
             <a:schemeClr val="bg1"/>
@@ -5749,27 +5658,132 @@
             </a:solidFill>
             <a:prstDash val="solid"/>
           </a:ln>
-          <a:effectLst>
-            <a:outerShdw sx="100000" sy="100000" kx="0" ky="0" algn="bl" rotWithShape="0" blurRad="127000" dist="38100" dir="5400000">
-              <a:srgbClr val="133524">
-                <a:alpha val="10000"/>
-              </a:srgbClr>
-            </a:outerShdw>
-          </a:effectLst>
-        </p:spPr>
-      </p:sp>
-      <p:sp>
-        <p:nvSpPr>
-          <p:cNvPr id="19" name="Shape 12"/>
+        </p:spPr>
+      </p:sp>
+      <p:sp>
+        <p:nvSpPr>
+          <p:cNvPr id="17" name="Shape 12"/>
           <p:cNvSpPr/>
           <p:nvPr/>
         </p:nvSpPr>
         <p:spPr>
           <a:xfrm>
-            <a:off x="822960" y="4251960"/>
-            <a:ext cx="502920" cy="502920"/>
-          </a:xfrm>
-          <a:prstGeom prst="ellipse">
+            <a:off x="548640" y="3044952"/>
+            <a:ext cx="3086100" cy="45720"/>
+          </a:xfrm>
+          <a:prstGeom prst="rect">
+            <a:avLst/>
+          </a:prstGeom>
+          <a:solidFill>
+            <a:schemeClr val="accent1"/>
+          </a:solidFill>
+          <a:ln/>
+        </p:spPr>
+      </p:sp>
+      <p:sp>
+        <p:nvSpPr>
+          <p:cNvPr id="18" name="Text 13"/>
+          <p:cNvSpPr txBox="1"/>
+          <p:nvPr/>
+        </p:nvSpPr>
+        <p:spPr>
+          <a:xfrm>
+            <a:off x="777240" y="3191256"/>
+            <a:ext cx="2628900" cy="457200"/>
+          </a:xfrm>
+          <a:prstGeom prst="rect">
+            <a:avLst/>
+          </a:prstGeom>
+          <a:noFill/>
+          <a:ln/>
+        </p:spPr>
+        <p:txBody>
+          <a:bodyPr wrap="square" lIns="0" tIns="0" rIns="0" bIns="0" rtlCol="0" anchor="t"/>
+          <a:lstStyle/>
+          <a:p>
+            <a:pPr indent="0" marL="0">
+              <a:buNone/>
+            </a:pPr>
+            <a:r>
+              <a:rPr lang="en-GB" altLang="en-US" sz="2800" b="1" dirty="0">
+                <a:solidFill>
+                  <a:schemeClr val="accent3"/>
+                </a:solidFill>
+              </a:rPr>
+              <a:t>20,000+</a:t>
+            </a:r>
+            <a:endParaRPr lang="en-GB" sz="2800" dirty="0"/>
+          </a:p>
+        </p:txBody>
+      </p:sp>
+      <p:sp>
+        <p:nvSpPr>
+          <p:cNvPr id="19" name="Text 14"/>
+          <p:cNvSpPr txBox="1"/>
+          <p:nvPr/>
+        </p:nvSpPr>
+        <p:spPr>
+          <a:xfrm>
+            <a:off x="777240" y="3685032"/>
+            <a:ext cx="2674620" cy="384048"/>
+          </a:xfrm>
+          <a:prstGeom prst="rect">
+            <a:avLst/>
+          </a:prstGeom>
+          <a:noFill/>
+          <a:ln/>
+        </p:spPr>
+        <p:txBody>
+          <a:bodyPr wrap="square" lIns="0" tIns="0" rIns="0" bIns="0" rtlCol="0" anchor="t"/>
+          <a:lstStyle/>
+          <a:p>
+            <a:pPr indent="0" marL="0">
+              <a:buNone/>
+            </a:pPr>
+            <a:r>
+              <a:rPr lang="en-GB" altLang="en-US" sz="1200" dirty="0">
+                <a:solidFill>
+                  <a:schemeClr val="tx2"/>
+                </a:solidFill>
+              </a:rPr>
+              <a:t>Expected at the 5th edition, according to the organisers</a:t>
+            </a:r>
+            <a:endParaRPr lang="en-GB" sz="1200" dirty="0"/>
+          </a:p>
+        </p:txBody>
+      </p:sp>
+      <p:sp>
+        <p:nvSpPr>
+          <p:cNvPr id="20" name="Shape 15"/>
+          <p:cNvSpPr/>
+          <p:nvPr/>
+        </p:nvSpPr>
+        <p:spPr>
+          <a:xfrm>
+            <a:off x="3863340" y="3044952"/>
+            <a:ext cx="3086100" cy="1097280"/>
+          </a:xfrm>
+          <a:prstGeom prst="rect">
+            <a:avLst/>
+          </a:prstGeom>
+          <a:solidFill>
+            <a:schemeClr val="tx1"/>
+          </a:solidFill>
+          <a:ln/>
+        </p:spPr>
+      </p:sp>
+      <p:sp>
+        <p:nvSpPr>
+          <p:cNvPr id="21" name="Shape 16"/>
+          <p:cNvSpPr/>
+          <p:nvPr/>
+        </p:nvSpPr>
+        <p:spPr>
+          <a:xfrm>
+            <a:off x="3863340" y="3044952"/>
+            <a:ext cx="3086100" cy="45720"/>
+          </a:xfrm>
+          <a:prstGeom prst="rect">
             <a:avLst/>
           </a:prstGeom>
           <a:solidFill>
@@ -5778,9 +5792,814 @@
           <a:ln/>
         </p:spPr>
       </p:sp>
+      <p:sp>
+        <p:nvSpPr>
+          <p:cNvPr id="22" name="Text 17"/>
+          <p:cNvSpPr txBox="1"/>
+          <p:nvPr/>
+        </p:nvSpPr>
+        <p:spPr>
+          <a:xfrm>
+            <a:off x="4091940" y="3191256"/>
+            <a:ext cx="2628900" cy="457200"/>
+          </a:xfrm>
+          <a:prstGeom prst="rect">
+            <a:avLst/>
+          </a:prstGeom>
+          <a:noFill/>
+          <a:ln/>
+        </p:spPr>
+        <p:txBody>
+          <a:bodyPr wrap="square" lIns="0" tIns="0" rIns="0" bIns="0" rtlCol="0" anchor="t"/>
+          <a:lstStyle/>
+          <a:p>
+            <a:pPr indent="0" marL="0">
+              <a:buNone/>
+            </a:pPr>
+            <a:r>
+              <a:rPr lang="en-GB" altLang="en-US" sz="2800" b="1" dirty="0">
+                <a:solidFill>
+                  <a:schemeClr val="accent4"/>
+                </a:solidFill>
+              </a:rPr>
+              <a:t>1B+ FCFA</a:t>
+            </a:r>
+            <a:endParaRPr lang="en-GB" sz="2800" dirty="0"/>
+          </a:p>
+        </p:txBody>
+      </p:sp>
+      <p:sp>
+        <p:nvSpPr>
+          <p:cNvPr id="23" name="Text 18"/>
+          <p:cNvSpPr txBox="1"/>
+          <p:nvPr/>
+        </p:nvSpPr>
+        <p:spPr>
+          <a:xfrm>
+            <a:off x="4091940" y="3685032"/>
+            <a:ext cx="2674620" cy="384048"/>
+          </a:xfrm>
+          <a:prstGeom prst="rect">
+            <a:avLst/>
+          </a:prstGeom>
+          <a:noFill/>
+          <a:ln/>
+        </p:spPr>
+        <p:txBody>
+          <a:bodyPr wrap="square" lIns="0" tIns="0" rIns="0" bIns="0" rtlCol="0" anchor="t"/>
+          <a:lstStyle/>
+          <a:p>
+            <a:pPr indent="0" marL="0">
+              <a:buNone/>
+            </a:pPr>
+            <a:r>
+              <a:rPr lang="en-GB" altLang="en-US" sz="1200" dirty="0">
+                <a:solidFill>
+                  <a:schemeClr val="accent5"/>
+                </a:solidFill>
+              </a:rPr>
+              <a:t>Over 1 billion FCFA: the festival as a sponsorship instrument</a:t>
+            </a:r>
+            <a:endParaRPr lang="en-GB" sz="1200" dirty="0"/>
+          </a:p>
+        </p:txBody>
+      </p:sp>
+      <p:sp>
+        <p:nvSpPr>
+          <p:cNvPr id="24" name="Text 19"/>
+          <p:cNvSpPr txBox="1"/>
+          <p:nvPr/>
+        </p:nvSpPr>
+        <p:spPr>
+          <a:xfrm>
+            <a:off x="548640" y="4370832"/>
+            <a:ext cx="3657600" cy="256032"/>
+          </a:xfrm>
+          <a:prstGeom prst="rect">
+            <a:avLst/>
+          </a:prstGeom>
+          <a:noFill/>
+          <a:ln/>
+        </p:spPr>
+        <p:txBody>
+          <a:bodyPr wrap="square" lIns="0" tIns="0" rIns="0" bIns="0" rtlCol="0" anchor="t"/>
+          <a:lstStyle/>
+          <a:p>
+            <a:pPr indent="0" marL="0">
+              <a:buNone/>
+            </a:pPr>
+            <a:r>
+              <a:rPr lang="en-GB" altLang="en-US" sz="1100" b="1" spc="300" kern="0" dirty="0">
+                <a:solidFill>
+                  <a:schemeClr val="accent3"/>
+                </a:solidFill>
+              </a:rPr>
+              <a:t>THE STORY SO FAR</a:t>
+            </a:r>
+            <a:endParaRPr lang="en-GB" sz="1100" dirty="0"/>
+          </a:p>
+        </p:txBody>
+      </p:sp>
+      <p:sp>
+        <p:nvSpPr>
+          <p:cNvPr id="25" name="Shape 20"/>
+          <p:cNvSpPr/>
+          <p:nvPr/>
+        </p:nvSpPr>
+        <p:spPr>
+          <a:xfrm>
+            <a:off x="548640" y="4846320"/>
+            <a:ext cx="6400800" cy="0"/>
+          </a:xfrm>
+          <a:prstGeom prst="line">
+            <a:avLst/>
+          </a:prstGeom>
+          <a:noFill/>
+          <a:ln w="19050">
+            <a:solidFill>
+              <a:schemeClr val="accent1"/>
+            </a:solidFill>
+            <a:prstDash val="solid"/>
+          </a:ln>
+        </p:spPr>
+      </p:sp>
+      <p:sp>
+        <p:nvSpPr>
+          <p:cNvPr id="26" name="Shape 21"/>
+          <p:cNvSpPr/>
+          <p:nvPr/>
+        </p:nvSpPr>
+        <p:spPr>
+          <a:xfrm>
+            <a:off x="548640" y="4773168"/>
+            <a:ext cx="146304" cy="146304"/>
+          </a:xfrm>
+          <a:prstGeom prst="ellipse">
+            <a:avLst/>
+          </a:prstGeom>
+          <a:solidFill>
+            <a:schemeClr val="accent1"/>
+          </a:solidFill>
+          <a:ln/>
+        </p:spPr>
+      </p:sp>
+      <p:sp>
+        <p:nvSpPr>
+          <p:cNvPr id="27" name="Text 22"/>
+          <p:cNvSpPr txBox="1"/>
+          <p:nvPr/>
+        </p:nvSpPr>
+        <p:spPr>
+          <a:xfrm>
+            <a:off x="548640" y="4983480"/>
+            <a:ext cx="1188720" cy="237744"/>
+          </a:xfrm>
+          <a:prstGeom prst="rect">
+            <a:avLst/>
+          </a:prstGeom>
+          <a:noFill/>
+          <a:ln/>
+        </p:spPr>
+        <p:txBody>
+          <a:bodyPr wrap="square" lIns="0" tIns="0" rIns="0" bIns="0" rtlCol="0" anchor="t"/>
+          <a:lstStyle/>
+          <a:p>
+            <a:pPr indent="0" marL="0">
+              <a:buNone/>
+            </a:pPr>
+            <a:r>
+              <a:rPr lang="en-GB" altLang="en-US" sz="1300" b="1" dirty="0">
+                <a:solidFill>
+                  <a:schemeClr val="tx1"/>
+                </a:solidFill>
+              </a:rPr>
+              <a:t>2022</a:t>
+            </a:r>
+            <a:endParaRPr lang="en-GB" sz="1300" dirty="0"/>
+          </a:p>
+        </p:txBody>
+      </p:sp>
+      <p:sp>
+        <p:nvSpPr>
+          <p:cNvPr id="28" name="Text 23"/>
+          <p:cNvSpPr txBox="1"/>
+          <p:nvPr/>
+        </p:nvSpPr>
+        <p:spPr>
+          <a:xfrm>
+            <a:off x="548640" y="5248656"/>
+            <a:ext cx="1188720" cy="640080"/>
+          </a:xfrm>
+          <a:prstGeom prst="rect">
+            <a:avLst/>
+          </a:prstGeom>
+          <a:noFill/>
+          <a:ln/>
+        </p:spPr>
+        <p:txBody>
+          <a:bodyPr wrap="square" lIns="0" tIns="0" rIns="0" bIns="0" rtlCol="0" anchor="t"/>
+          <a:lstStyle/>
+          <a:p>
+            <a:pPr indent="0" marL="0">
+              <a:buNone/>
+            </a:pPr>
+            <a:r>
+              <a:rPr lang="en-GB" altLang="en-US" sz="1050" dirty="0">
+                <a:solidFill>
+                  <a:schemeClr val="tx2"/>
+                </a:solidFill>
+              </a:rPr>
+              <a:t>First edition, 28 to 30 December in Abidjan</a:t>
+            </a:r>
+            <a:endParaRPr lang="en-GB" sz="1050" dirty="0"/>
+          </a:p>
+        </p:txBody>
+      </p:sp>
+      <p:sp>
+        <p:nvSpPr>
+          <p:cNvPr id="29" name="Shape 24"/>
+          <p:cNvSpPr/>
+          <p:nvPr/>
+        </p:nvSpPr>
+        <p:spPr>
+          <a:xfrm>
+            <a:off x="1828800" y="4773168"/>
+            <a:ext cx="146304" cy="146304"/>
+          </a:xfrm>
+          <a:prstGeom prst="ellipse">
+            <a:avLst/>
+          </a:prstGeom>
+          <a:solidFill>
+            <a:schemeClr val="accent1"/>
+          </a:solidFill>
+          <a:ln/>
+        </p:spPr>
+      </p:sp>
+      <p:sp>
+        <p:nvSpPr>
+          <p:cNvPr id="30" name="Text 25"/>
+          <p:cNvSpPr txBox="1"/>
+          <p:nvPr/>
+        </p:nvSpPr>
+        <p:spPr>
+          <a:xfrm>
+            <a:off x="1828800" y="4983480"/>
+            <a:ext cx="1188720" cy="237744"/>
+          </a:xfrm>
+          <a:prstGeom prst="rect">
+            <a:avLst/>
+          </a:prstGeom>
+          <a:noFill/>
+          <a:ln/>
+        </p:spPr>
+        <p:txBody>
+          <a:bodyPr wrap="square" lIns="0" tIns="0" rIns="0" bIns="0" rtlCol="0" anchor="t"/>
+          <a:lstStyle/>
+          <a:p>
+            <a:pPr indent="0" marL="0">
+              <a:buNone/>
+            </a:pPr>
+            <a:r>
+              <a:rPr lang="en-GB" altLang="en-US" sz="1300" b="1" dirty="0">
+                <a:solidFill>
+                  <a:schemeClr val="tx1"/>
+                </a:solidFill>
+              </a:rPr>
+              <a:t>2023</a:t>
+            </a:r>
+            <a:endParaRPr lang="en-GB" sz="1300" dirty="0"/>
+          </a:p>
+        </p:txBody>
+      </p:sp>
+      <p:sp>
+        <p:nvSpPr>
+          <p:cNvPr id="31" name="Text 26"/>
+          <p:cNvSpPr txBox="1"/>
+          <p:nvPr/>
+        </p:nvSpPr>
+        <p:spPr>
+          <a:xfrm>
+            <a:off x="1828800" y="5248656"/>
+            <a:ext cx="1188720" cy="640080"/>
+          </a:xfrm>
+          <a:prstGeom prst="rect">
+            <a:avLst/>
+          </a:prstGeom>
+          <a:noFill/>
+          <a:ln/>
+        </p:spPr>
+        <p:txBody>
+          <a:bodyPr wrap="square" lIns="0" tIns="0" rIns="0" bIns="0" rtlCol="0" anchor="t"/>
+          <a:lstStyle/>
+          <a:p>
+            <a:pPr indent="0" marL="0">
+              <a:buNone/>
+            </a:pPr>
+            <a:r>
+              <a:rPr lang="en-GB" altLang="en-US" sz="1050" dirty="0">
+                <a:solidFill>
+                  <a:schemeClr val="tx2"/>
+                </a:solidFill>
+              </a:rPr>
+              <a:t>2nd edition: Aya Nakamura, Ayra Starr</a:t>
+            </a:r>
+            <a:endParaRPr lang="en-GB" sz="1050" dirty="0"/>
+          </a:p>
+        </p:txBody>
+      </p:sp>
+      <p:sp>
+        <p:nvSpPr>
+          <p:cNvPr id="32" name="Shape 27"/>
+          <p:cNvSpPr/>
+          <p:nvPr/>
+        </p:nvSpPr>
+        <p:spPr>
+          <a:xfrm>
+            <a:off x="3108960" y="4773168"/>
+            <a:ext cx="146304" cy="146304"/>
+          </a:xfrm>
+          <a:prstGeom prst="ellipse">
+            <a:avLst/>
+          </a:prstGeom>
+          <a:solidFill>
+            <a:schemeClr val="accent1"/>
+          </a:solidFill>
+          <a:ln/>
+        </p:spPr>
+      </p:sp>
+      <p:sp>
+        <p:nvSpPr>
+          <p:cNvPr id="33" name="Text 28"/>
+          <p:cNvSpPr txBox="1"/>
+          <p:nvPr/>
+        </p:nvSpPr>
+        <p:spPr>
+          <a:xfrm>
+            <a:off x="3108960" y="4983480"/>
+            <a:ext cx="1188720" cy="237744"/>
+          </a:xfrm>
+          <a:prstGeom prst="rect">
+            <a:avLst/>
+          </a:prstGeom>
+          <a:noFill/>
+          <a:ln/>
+        </p:spPr>
+        <p:txBody>
+          <a:bodyPr wrap="square" lIns="0" tIns="0" rIns="0" bIns="0" rtlCol="0" anchor="t"/>
+          <a:lstStyle/>
+          <a:p>
+            <a:pPr indent="0" marL="0">
+              <a:buNone/>
+            </a:pPr>
+            <a:r>
+              <a:rPr lang="en-GB" altLang="en-US" sz="1300" b="1" dirty="0">
+                <a:solidFill>
+                  <a:schemeClr val="tx1"/>
+                </a:solidFill>
+              </a:rPr>
+              <a:t>2024</a:t>
+            </a:r>
+            <a:endParaRPr lang="en-GB" sz="1300" dirty="0"/>
+          </a:p>
+        </p:txBody>
+      </p:sp>
+      <p:sp>
+        <p:nvSpPr>
+          <p:cNvPr id="34" name="Text 29"/>
+          <p:cNvSpPr txBox="1"/>
+          <p:nvPr/>
+        </p:nvSpPr>
+        <p:spPr>
+          <a:xfrm>
+            <a:off x="3108960" y="5248656"/>
+            <a:ext cx="1188720" cy="640080"/>
+          </a:xfrm>
+          <a:prstGeom prst="rect">
+            <a:avLst/>
+          </a:prstGeom>
+          <a:noFill/>
+          <a:ln/>
+        </p:spPr>
+        <p:txBody>
+          <a:bodyPr wrap="square" lIns="0" tIns="0" rIns="0" bIns="0" rtlCol="0" anchor="t"/>
+          <a:lstStyle/>
+          <a:p>
+            <a:pPr indent="0" marL="0">
+              <a:buNone/>
+            </a:pPr>
+            <a:r>
+              <a:rPr lang="en-GB" altLang="en-US" sz="1050" dirty="0">
+                <a:solidFill>
+                  <a:schemeClr val="tx2"/>
+                </a:solidFill>
+              </a:rPr>
+              <a:t>3rd edition: Dadju and Tayc</a:t>
+            </a:r>
+            <a:endParaRPr lang="en-GB" sz="1050" dirty="0"/>
+          </a:p>
+        </p:txBody>
+      </p:sp>
+      <p:sp>
+        <p:nvSpPr>
+          <p:cNvPr id="35" name="Shape 30"/>
+          <p:cNvSpPr/>
+          <p:nvPr/>
+        </p:nvSpPr>
+        <p:spPr>
+          <a:xfrm>
+            <a:off x="4389120" y="4773168"/>
+            <a:ext cx="146304" cy="146304"/>
+          </a:xfrm>
+          <a:prstGeom prst="ellipse">
+            <a:avLst/>
+          </a:prstGeom>
+          <a:solidFill>
+            <a:schemeClr val="accent1"/>
+          </a:solidFill>
+          <a:ln/>
+        </p:spPr>
+      </p:sp>
+      <p:sp>
+        <p:nvSpPr>
+          <p:cNvPr id="36" name="Text 31"/>
+          <p:cNvSpPr txBox="1"/>
+          <p:nvPr/>
+        </p:nvSpPr>
+        <p:spPr>
+          <a:xfrm>
+            <a:off x="4389120" y="4983480"/>
+            <a:ext cx="1188720" cy="237744"/>
+          </a:xfrm>
+          <a:prstGeom prst="rect">
+            <a:avLst/>
+          </a:prstGeom>
+          <a:noFill/>
+          <a:ln/>
+        </p:spPr>
+        <p:txBody>
+          <a:bodyPr wrap="square" lIns="0" tIns="0" rIns="0" bIns="0" rtlCol="0" anchor="t"/>
+          <a:lstStyle/>
+          <a:p>
+            <a:pPr indent="0" marL="0">
+              <a:buNone/>
+            </a:pPr>
+            <a:r>
+              <a:rPr lang="en-GB" altLang="en-US" sz="1300" b="1" dirty="0">
+                <a:solidFill>
+                  <a:schemeClr val="tx1"/>
+                </a:solidFill>
+              </a:rPr>
+              <a:t>2025</a:t>
+            </a:r>
+            <a:endParaRPr lang="en-GB" sz="1300" dirty="0"/>
+          </a:p>
+        </p:txBody>
+      </p:sp>
+      <p:sp>
+        <p:nvSpPr>
+          <p:cNvPr id="37" name="Text 32"/>
+          <p:cNvSpPr txBox="1"/>
+          <p:nvPr/>
+        </p:nvSpPr>
+        <p:spPr>
+          <a:xfrm>
+            <a:off x="4389120" y="5248656"/>
+            <a:ext cx="1188720" cy="640080"/>
+          </a:xfrm>
+          <a:prstGeom prst="rect">
+            <a:avLst/>
+          </a:prstGeom>
+          <a:noFill/>
+          <a:ln/>
+        </p:spPr>
+        <p:txBody>
+          <a:bodyPr wrap="square" lIns="0" tIns="0" rIns="0" bIns="0" rtlCol="0" anchor="t"/>
+          <a:lstStyle/>
+          <a:p>
+            <a:pPr indent="0" marL="0">
+              <a:buNone/>
+            </a:pPr>
+            <a:r>
+              <a:rPr lang="en-GB" altLang="en-US" sz="1050" dirty="0">
+                <a:solidFill>
+                  <a:schemeClr val="tx2"/>
+                </a:solidFill>
+              </a:rPr>
+              <a:t>4th edition: Gims, Asake. On France 24</a:t>
+            </a:r>
+            <a:endParaRPr lang="en-GB" sz="1050" dirty="0"/>
+          </a:p>
+        </p:txBody>
+      </p:sp>
+      <p:sp>
+        <p:nvSpPr>
+          <p:cNvPr id="38" name="Shape 33"/>
+          <p:cNvSpPr/>
+          <p:nvPr/>
+        </p:nvSpPr>
+        <p:spPr>
+          <a:xfrm>
+            <a:off x="5669280" y="4773168"/>
+            <a:ext cx="146304" cy="146304"/>
+          </a:xfrm>
+          <a:prstGeom prst="ellipse">
+            <a:avLst/>
+          </a:prstGeom>
+          <a:solidFill>
+            <a:schemeClr val="accent2"/>
+          </a:solidFill>
+          <a:ln/>
+        </p:spPr>
+      </p:sp>
+      <p:sp>
+        <p:nvSpPr>
+          <p:cNvPr id="39" name="Text 34"/>
+          <p:cNvSpPr txBox="1"/>
+          <p:nvPr/>
+        </p:nvSpPr>
+        <p:spPr>
+          <a:xfrm>
+            <a:off x="5669280" y="4983480"/>
+            <a:ext cx="1188720" cy="237744"/>
+          </a:xfrm>
+          <a:prstGeom prst="rect">
+            <a:avLst/>
+          </a:prstGeom>
+          <a:noFill/>
+          <a:ln/>
+        </p:spPr>
+        <p:txBody>
+          <a:bodyPr wrap="square" lIns="0" tIns="0" rIns="0" bIns="0" rtlCol="0" anchor="t"/>
+          <a:lstStyle/>
+          <a:p>
+            <a:pPr indent="0" marL="0">
+              <a:buNone/>
+            </a:pPr>
+            <a:r>
+              <a:rPr lang="en-GB" altLang="en-US" sz="1300" b="1" dirty="0">
+                <a:solidFill>
+                  <a:schemeClr val="accent3"/>
+                </a:solidFill>
+              </a:rPr>
+              <a:t>2026</a:t>
+            </a:r>
+            <a:endParaRPr lang="en-GB" sz="1300" dirty="0"/>
+          </a:p>
+        </p:txBody>
+      </p:sp>
+      <p:sp>
+        <p:nvSpPr>
+          <p:cNvPr id="40" name="Text 35"/>
+          <p:cNvSpPr txBox="1"/>
+          <p:nvPr/>
+        </p:nvSpPr>
+        <p:spPr>
+          <a:xfrm>
+            <a:off x="5669280" y="5248656"/>
+            <a:ext cx="1188720" cy="640080"/>
+          </a:xfrm>
+          <a:prstGeom prst="rect">
+            <a:avLst/>
+          </a:prstGeom>
+          <a:noFill/>
+          <a:ln/>
+        </p:spPr>
+        <p:txBody>
+          <a:bodyPr wrap="square" lIns="0" tIns="0" rIns="0" bIns="0" rtlCol="0" anchor="t"/>
+          <a:lstStyle/>
+          <a:p>
+            <a:pPr indent="0" marL="0">
+              <a:buNone/>
+            </a:pPr>
+            <a:r>
+              <a:rPr lang="en-GB" altLang="en-US" sz="1050" dirty="0">
+                <a:solidFill>
+                  <a:schemeClr val="tx2"/>
+                </a:solidFill>
+              </a:rPr>
+              <a:t>5th edition: Davido headlines</a:t>
+            </a:r>
+            <a:endParaRPr lang="en-GB" sz="1050" dirty="0"/>
+          </a:p>
+        </p:txBody>
+      </p:sp>
+      <p:sp>
+        <p:nvSpPr>
+          <p:cNvPr id="41" name="Text 36"/>
+          <p:cNvSpPr txBox="1"/>
+          <p:nvPr/>
+        </p:nvSpPr>
+        <p:spPr>
+          <a:xfrm>
+            <a:off x="548640" y="5989320"/>
+            <a:ext cx="6400800" cy="274320"/>
+          </a:xfrm>
+          <a:prstGeom prst="rect">
+            <a:avLst/>
+          </a:prstGeom>
+          <a:noFill/>
+          <a:ln/>
+        </p:spPr>
+        <p:txBody>
+          <a:bodyPr wrap="square" lIns="0" tIns="0" rIns="0" bIns="0" rtlCol="0" anchor="t"/>
+          <a:lstStyle/>
+          <a:p>
+            <a:pPr indent="0" marL="0">
+              <a:buNone/>
+            </a:pPr>
+            <a:r>
+              <a:rPr lang="en-GB" altLang="en-US" sz="950" i="1" dirty="0">
+                <a:solidFill>
+                  <a:schemeClr val="tx2"/>
+                </a:solidFill>
+              </a:rPr>
+              <a:t>Sources: Africa Radio, Music In Africa, Abidjan.net, Liferadio, France 24, Pulse, allAfrica. 20,000+ is the organisers’ expected figure.</a:t>
+            </a:r>
+            <a:endParaRPr lang="en-GB" sz="950" dirty="0"/>
+          </a:p>
+        </p:txBody>
+      </p:sp>
+      <p:sp>
+        <p:nvSpPr>
+          <p:cNvPr id="42" name="Shape 37"/>
+          <p:cNvSpPr/>
+          <p:nvPr/>
+        </p:nvSpPr>
+        <p:spPr>
+          <a:xfrm>
+            <a:off x="7178040" y="1783080"/>
+            <a:ext cx="4465015" cy="4251960"/>
+          </a:xfrm>
+          <a:prstGeom prst="roundRect">
+            <a:avLst>
+              <a:gd name="adj" fmla="val 2151"/>
+            </a:avLst>
+          </a:prstGeom>
+          <a:solidFill>
+            <a:schemeClr val="tx1"/>
+          </a:solidFill>
+          <a:ln/>
+        </p:spPr>
+      </p:sp>
+      <p:sp>
+        <p:nvSpPr>
+          <p:cNvPr id="43" name="Text 38"/>
+          <p:cNvSpPr txBox="1"/>
+          <p:nvPr/>
+        </p:nvSpPr>
+        <p:spPr>
+          <a:xfrm>
+            <a:off x="7452360" y="2029968"/>
+            <a:ext cx="3931920" cy="256032"/>
+          </a:xfrm>
+          <a:prstGeom prst="rect">
+            <a:avLst/>
+          </a:prstGeom>
+          <a:noFill/>
+          <a:ln/>
+        </p:spPr>
+        <p:txBody>
+          <a:bodyPr wrap="square" lIns="0" tIns="0" rIns="0" bIns="0" rtlCol="0" anchor="t"/>
+          <a:lstStyle/>
+          <a:p>
+            <a:pPr indent="0" marL="0">
+              <a:buNone/>
+            </a:pPr>
+            <a:r>
+              <a:rPr lang="en-GB" altLang="en-US" sz="1100" b="1" spc="300" kern="0" dirty="0">
+                <a:solidFill>
+                  <a:schemeClr val="accent1"/>
+                </a:solidFill>
+              </a:rPr>
+              <a:t>WHAT THE 5TH EDITION NEEDS</a:t>
+            </a:r>
+            <a:endParaRPr lang="en-GB" sz="1100" dirty="0"/>
+          </a:p>
+        </p:txBody>
+      </p:sp>
       <p:pic>
         <p:nvPicPr>
-          <p:cNvPr id="20" name="Image 4" descr="preencoded.png">    </p:cNvPr>
+          <p:cNvPr id="44" name="Image 2" descr="preencoded.png">    </p:cNvPr>
+          <p:cNvPicPr>
+            <a:picLocks noChangeAspect="1"/>
+          </p:cNvPicPr>
+          <p:nvPr/>
+        </p:nvPicPr>
+        <p:blipFill>
+          <a:blip r:embed="rId3"/>
+          <a:stretch>
+            <a:fillRect/>
+          </a:stretch>
+        </p:blipFill>
+        <p:spPr>
+          <a:xfrm>
+            <a:off x="7452360" y="2532888"/>
+            <a:ext cx="256032" cy="256032"/>
+          </a:xfrm>
+          <a:prstGeom prst="rect">
+            <a:avLst/>
+          </a:prstGeom>
+        </p:spPr>
+      </p:pic>
+      <p:sp>
+        <p:nvSpPr>
+          <p:cNvPr id="45" name="Text 39"/>
+          <p:cNvSpPr txBox="1"/>
+          <p:nvPr/>
+        </p:nvSpPr>
+        <p:spPr>
+          <a:xfrm>
+            <a:off x="7863840" y="2514600"/>
+            <a:ext cx="3520440" cy="457200"/>
+          </a:xfrm>
+          <a:prstGeom prst="rect">
+            <a:avLst/>
+          </a:prstGeom>
+          <a:noFill/>
+          <a:ln/>
+        </p:spPr>
+        <p:txBody>
+          <a:bodyPr wrap="square" lIns="0" tIns="0" rIns="0" bIns="0" rtlCol="0" anchor="t"/>
+          <a:lstStyle/>
+          <a:p>
+            <a:pPr indent="0" marL="0">
+              <a:buNone/>
+            </a:pPr>
+            <a:r>
+              <a:rPr lang="en-GB" altLang="en-US" sz="1400" dirty="0">
+                <a:solidFill>
+                  <a:schemeClr val="bg1"/>
+                </a:solidFill>
+              </a:rPr>
+              <a:t>Creators chosen for the audiences the festival wants most</a:t>
+            </a:r>
+            <a:endParaRPr lang="en-GB" sz="1400" dirty="0"/>
+          </a:p>
+        </p:txBody>
+      </p:sp>
+      <p:pic>
+        <p:nvPicPr>
+          <p:cNvPr id="46" name="Image 3" descr="preencoded.png">    </p:cNvPr>
+          <p:cNvPicPr>
+            <a:picLocks noChangeAspect="1"/>
+          </p:cNvPicPr>
+          <p:nvPr/>
+        </p:nvPicPr>
+        <p:blipFill>
+          <a:blip r:embed="rId4"/>
+          <a:stretch>
+            <a:fillRect/>
+          </a:stretch>
+        </p:blipFill>
+        <p:spPr>
+          <a:xfrm>
+            <a:off x="7452360" y="3246120"/>
+            <a:ext cx="256032" cy="256032"/>
+          </a:xfrm>
+          <a:prstGeom prst="rect">
+            <a:avLst/>
+          </a:prstGeom>
+        </p:spPr>
+      </p:pic>
+      <p:sp>
+        <p:nvSpPr>
+          <p:cNvPr id="47" name="Text 40"/>
+          <p:cNvSpPr txBox="1"/>
+          <p:nvPr/>
+        </p:nvSpPr>
+        <p:spPr>
+          <a:xfrm>
+            <a:off x="7863840" y="3227832"/>
+            <a:ext cx="3520440" cy="457200"/>
+          </a:xfrm>
+          <a:prstGeom prst="rect">
+            <a:avLst/>
+          </a:prstGeom>
+          <a:noFill/>
+          <a:ln/>
+        </p:spPr>
+        <p:txBody>
+          <a:bodyPr wrap="square" lIns="0" tIns="0" rIns="0" bIns="0" rtlCol="0" anchor="t"/>
+          <a:lstStyle/>
+          <a:p>
+            <a:pPr indent="0" marL="0">
+              <a:buNone/>
+            </a:pPr>
+            <a:r>
+              <a:rPr lang="en-GB" altLang="en-US" sz="1400" dirty="0">
+                <a:solidFill>
+                  <a:schemeClr val="bg1"/>
+                </a:solidFill>
+              </a:rPr>
+              <a:t>Set deliverables and key messages for every creator</a:t>
+            </a:r>
+            <a:endParaRPr lang="en-GB" sz="1400" dirty="0"/>
+          </a:p>
+        </p:txBody>
+      </p:sp>
+      <p:pic>
+        <p:nvPicPr>
+          <p:cNvPr id="48" name="Image 4" descr="preencoded.png">    </p:cNvPr>
           <p:cNvPicPr>
             <a:picLocks noChangeAspect="1"/>
           </p:cNvPicPr>
@@ -5794,8 +6613,8 @@
         </p:blipFill>
         <p:spPr>
           <a:xfrm>
-            <a:off x="943661" y="4372661"/>
-            <a:ext cx="261518" cy="261518"/>
+            <a:off x="7452360" y="3959352"/>
+            <a:ext cx="256032" cy="256032"/>
           </a:xfrm>
           <a:prstGeom prst="rect">
             <a:avLst/>
@@ -5804,14 +6623,14 @@
       </p:pic>
       <p:sp>
         <p:nvSpPr>
-          <p:cNvPr id="21" name="Text 13"/>
-          <p:cNvSpPr txBox="1"/>
-          <p:nvPr/>
-        </p:nvSpPr>
-        <p:spPr>
-          <a:xfrm>
-            <a:off x="822960" y="4873752"/>
-            <a:ext cx="2423160" cy="347472"/>
+          <p:cNvPr id="49" name="Text 41"/>
+          <p:cNvSpPr txBox="1"/>
+          <p:nvPr/>
+        </p:nvSpPr>
+        <p:spPr>
+          <a:xfrm>
+            <a:off x="7863840" y="3941064"/>
+            <a:ext cx="3520440" cy="457200"/>
           </a:xfrm>
           <a:prstGeom prst="rect">
             <a:avLst/>
@@ -5827,115 +6646,20 @@
               <a:buNone/>
             </a:pPr>
             <a:r>
-              <a:rPr lang="en-GB" altLang="en-US" sz="2000" dirty="0">
-                <a:solidFill>
-                  <a:schemeClr val="tx1"/>
-                </a:solidFill>
-                <a:latin typeface="+mj-lt" pitchFamily="34" charset="0"/>
-                <a:ea typeface="+mj-lt" pitchFamily="34" charset="-122"/>
-                <a:cs typeface="+mj-lt" pitchFamily="34" charset="-120"/>
-              </a:rPr>
-              <a:t>Sponsors on board</a:t>
-            </a:r>
-            <a:endParaRPr lang="en-GB" sz="2000" dirty="0"/>
-          </a:p>
-        </p:txBody>
-      </p:sp>
-      <p:sp>
-        <p:nvSpPr>
-          <p:cNvPr id="22" name="Text 14"/>
-          <p:cNvSpPr txBox="1"/>
-          <p:nvPr/>
-        </p:nvSpPr>
-        <p:spPr>
-          <a:xfrm>
-            <a:off x="822960" y="5257800"/>
-            <a:ext cx="2423160" cy="640080"/>
-          </a:xfrm>
-          <a:prstGeom prst="rect">
-            <a:avLst/>
-          </a:prstGeom>
-          <a:noFill/>
-          <a:ln/>
-        </p:spPr>
-        <p:txBody>
-          <a:bodyPr wrap="square" lIns="0" tIns="0" rIns="0" bIns="0" rtlCol="0" anchor="t"/>
-          <a:lstStyle/>
-          <a:p>
-            <a:pPr indent="0" marL="0">
-              <a:buNone/>
-            </a:pPr>
-            <a:r>
-              <a:rPr lang="en-GB" altLang="en-US" sz="1300" dirty="0">
-                <a:solidFill>
-                  <a:schemeClr val="tx2"/>
-                </a:solidFill>
-              </a:rPr>
-              <a:t>Partner brands already back the festival, as the press launch showed.</a:t>
-            </a:r>
-            <a:endParaRPr lang="en-GB" sz="1300" dirty="0"/>
-          </a:p>
-        </p:txBody>
-      </p:sp>
-      <p:sp>
-        <p:nvSpPr>
-          <p:cNvPr id="23" name="Shape 15"/>
-          <p:cNvSpPr/>
-          <p:nvPr/>
-        </p:nvSpPr>
-        <p:spPr>
-          <a:xfrm>
-            <a:off x="3749040" y="3977640"/>
-            <a:ext cx="2971800" cy="1965960"/>
-          </a:xfrm>
-          <a:prstGeom prst="roundRect">
-            <a:avLst>
-              <a:gd name="adj" fmla="val 4651"/>
-            </a:avLst>
-          </a:prstGeom>
-          <a:solidFill>
-            <a:schemeClr val="bg1"/>
-          </a:solidFill>
-          <a:ln w="9525">
-            <a:solidFill>
-              <a:schemeClr val="tx2">
-                <a:alpha val="28000"/>
-              </a:schemeClr>
-            </a:solidFill>
-            <a:prstDash val="solid"/>
-          </a:ln>
-          <a:effectLst>
-            <a:outerShdw sx="100000" sy="100000" kx="0" ky="0" algn="bl" rotWithShape="0" blurRad="127000" dist="38100" dir="5400000">
-              <a:srgbClr val="133524">
-                <a:alpha val="10000"/>
-              </a:srgbClr>
-            </a:outerShdw>
-          </a:effectLst>
-        </p:spPr>
-      </p:sp>
-      <p:sp>
-        <p:nvSpPr>
-          <p:cNvPr id="24" name="Shape 16"/>
-          <p:cNvSpPr/>
-          <p:nvPr/>
-        </p:nvSpPr>
-        <p:spPr>
-          <a:xfrm>
-            <a:off x="4023360" y="4251960"/>
-            <a:ext cx="502920" cy="502920"/>
-          </a:xfrm>
-          <a:prstGeom prst="ellipse">
-            <a:avLst/>
-          </a:prstGeom>
-          <a:solidFill>
-            <a:schemeClr val="accent2"/>
-          </a:solidFill>
-          <a:ln/>
-        </p:spPr>
+              <a:rPr lang="en-GB" altLang="en-US" sz="1400" dirty="0">
+                <a:solidFill>
+                  <a:schemeClr val="bg1"/>
+                </a:solidFill>
+              </a:rPr>
+              <a:t>A clear view of what each creator posts, and when</a:t>
+            </a:r>
+            <a:endParaRPr lang="en-GB" sz="1400" dirty="0"/>
+          </a:p>
+        </p:txBody>
       </p:sp>
       <p:pic>
         <p:nvPicPr>
-          <p:cNvPr id="25" name="Image 5" descr="preencoded.png">    </p:cNvPr>
+          <p:cNvPr id="50" name="Image 5" descr="preencoded.png">    </p:cNvPr>
           <p:cNvPicPr>
             <a:picLocks noChangeAspect="1"/>
           </p:cNvPicPr>
@@ -5949,8 +6673,8 @@
         </p:blipFill>
         <p:spPr>
           <a:xfrm>
-            <a:off x="4144061" y="4372661"/>
-            <a:ext cx="261518" cy="261518"/>
+            <a:off x="7452360" y="4672584"/>
+            <a:ext cx="256032" cy="256032"/>
           </a:xfrm>
           <a:prstGeom prst="rect">
             <a:avLst/>
@@ -5959,14 +6683,14 @@
       </p:pic>
       <p:sp>
         <p:nvSpPr>
-          <p:cNvPr id="26" name="Text 17"/>
-          <p:cNvSpPr txBox="1"/>
-          <p:nvPr/>
-        </p:nvSpPr>
-        <p:spPr>
-          <a:xfrm>
-            <a:off x="4023360" y="4873752"/>
-            <a:ext cx="2423160" cy="347472"/>
+          <p:cNvPr id="51" name="Text 42"/>
+          <p:cNvSpPr txBox="1"/>
+          <p:nvPr/>
+        </p:nvSpPr>
+        <p:spPr>
+          <a:xfrm>
+            <a:off x="7863840" y="4654296"/>
+            <a:ext cx="3520440" cy="457200"/>
           </a:xfrm>
           <a:prstGeom prst="rect">
             <a:avLst/>
@@ -5982,117 +6706,20 @@
               <a:buNone/>
             </a:pPr>
             <a:r>
-              <a:rPr lang="en-GB" altLang="en-US" sz="2000" dirty="0">
-                <a:solidFill>
-                  <a:schemeClr val="tx1"/>
-                </a:solidFill>
-                <a:latin typeface="+mj-lt" pitchFamily="34" charset="0"/>
-                <a:ea typeface="+mj-lt" pitchFamily="34" charset="-122"/>
-                <a:cs typeface="+mj-lt" pitchFamily="34" charset="-120"/>
-              </a:rPr>
-              <a:t>Tickets sold online</a:t>
-            </a:r>
-            <a:endParaRPr lang="en-GB" sz="2000" dirty="0"/>
-          </a:p>
-        </p:txBody>
-      </p:sp>
-      <p:sp>
-        <p:nvSpPr>
-          <p:cNvPr id="27" name="Text 18"/>
-          <p:cNvSpPr txBox="1"/>
-          <p:nvPr/>
-        </p:nvSpPr>
-        <p:spPr>
-          <a:xfrm>
-            <a:off x="4023360" y="5257800"/>
-            <a:ext cx="2423160" cy="640080"/>
-          </a:xfrm>
-          <a:prstGeom prst="rect">
-            <a:avLst/>
-          </a:prstGeom>
-          <a:noFill/>
-          <a:ln/>
-        </p:spPr>
-        <p:txBody>
-          <a:bodyPr wrap="square" lIns="0" tIns="0" rIns="0" bIns="0" rtlCol="0" anchor="t"/>
-          <a:lstStyle/>
-          <a:p>
-            <a:pPr indent="0" marL="0">
-              <a:buNone/>
-            </a:pPr>
-            <a:r>
-              <a:rPr lang="en-GB" altLang="en-US" sz="1300" dirty="0">
-                <a:solidFill>
-                  <a:schemeClr val="tx2"/>
-                </a:solidFill>
-              </a:rPr>
-              <a:t>Sales run online through maf.tikerama.com, ready for tracked links.</a:t>
-            </a:r>
-            <a:endParaRPr lang="en-GB" sz="1300" dirty="0"/>
-          </a:p>
-        </p:txBody>
-      </p:sp>
-      <p:sp>
-        <p:nvSpPr>
-          <p:cNvPr id="28" name="Shape 19"/>
-          <p:cNvSpPr/>
-          <p:nvPr/>
-        </p:nvSpPr>
-        <p:spPr>
-          <a:xfrm>
-            <a:off x="7086600" y="1783080"/>
-            <a:ext cx="4553712" cy="4160520"/>
-          </a:xfrm>
-          <a:prstGeom prst="roundRect">
-            <a:avLst>
-              <a:gd name="adj" fmla="val 2198"/>
-            </a:avLst>
-          </a:prstGeom>
-          <a:solidFill>
-            <a:schemeClr val="tx1"/>
-          </a:solidFill>
-          <a:ln/>
-        </p:spPr>
-      </p:sp>
-      <p:sp>
-        <p:nvSpPr>
-          <p:cNvPr id="29" name="Text 20"/>
-          <p:cNvSpPr txBox="1"/>
-          <p:nvPr/>
-        </p:nvSpPr>
-        <p:spPr>
-          <a:xfrm>
-            <a:off x="7360920" y="2029968"/>
-            <a:ext cx="4023360" cy="256032"/>
-          </a:xfrm>
-          <a:prstGeom prst="rect">
-            <a:avLst/>
-          </a:prstGeom>
-          <a:noFill/>
-          <a:ln/>
-        </p:spPr>
-        <p:txBody>
-          <a:bodyPr wrap="square" lIns="0" tIns="0" rIns="0" bIns="0" rtlCol="0" anchor="t"/>
-          <a:lstStyle/>
-          <a:p>
-            <a:pPr indent="0" marL="0">
-              <a:buNone/>
-            </a:pPr>
-            <a:r>
-              <a:rPr lang="en-GB" altLang="en-US" sz="1100" b="1" spc="300" kern="0" dirty="0">
-                <a:solidFill>
-                  <a:schemeClr val="accent1"/>
-                </a:solidFill>
-              </a:rPr>
-              <a:t>WHAT THE 5TH EDITION NEEDS</a:t>
-            </a:r>
-            <a:endParaRPr lang="en-GB" sz="1100" dirty="0"/>
+              <a:rPr lang="en-GB" altLang="en-US" sz="1400" dirty="0">
+                <a:solidFill>
+                  <a:schemeClr val="bg1"/>
+                </a:solidFill>
+              </a:rPr>
+              <a:t>Sponsor visibility the festival can prove, partner by partner</a:t>
+            </a:r>
+            <a:endParaRPr lang="en-GB" sz="1400" dirty="0"/>
           </a:p>
         </p:txBody>
       </p:sp>
       <p:pic>
         <p:nvPicPr>
-          <p:cNvPr id="30" name="Image 6" descr="preencoded.png">    </p:cNvPr>
+          <p:cNvPr id="52" name="Image 6" descr="preencoded.png">    </p:cNvPr>
           <p:cNvPicPr>
             <a:picLocks noChangeAspect="1"/>
           </p:cNvPicPr>
@@ -6106,7 +6733,7 @@
         </p:blipFill>
         <p:spPr>
           <a:xfrm>
-            <a:off x="7360920" y="2505456"/>
+            <a:off x="7452360" y="5385816"/>
             <a:ext cx="256032" cy="256032"/>
           </a:xfrm>
           <a:prstGeom prst="rect">
@@ -6116,254 +6743,14 @@
       </p:pic>
       <p:sp>
         <p:nvSpPr>
-          <p:cNvPr id="31" name="Text 21"/>
-          <p:cNvSpPr txBox="1"/>
-          <p:nvPr/>
-        </p:nvSpPr>
-        <p:spPr>
-          <a:xfrm>
-            <a:off x="7772400" y="2487168"/>
-            <a:ext cx="3611880" cy="457200"/>
-          </a:xfrm>
-          <a:prstGeom prst="rect">
-            <a:avLst/>
-          </a:prstGeom>
-          <a:noFill/>
-          <a:ln/>
-        </p:spPr>
-        <p:txBody>
-          <a:bodyPr wrap="square" lIns="0" tIns="0" rIns="0" bIns="0" rtlCol="0" anchor="t"/>
-          <a:lstStyle/>
-          <a:p>
-            <a:pPr indent="0" marL="0">
-              <a:buNone/>
-            </a:pPr>
-            <a:r>
-              <a:rPr lang="en-GB" altLang="en-US" sz="1400" dirty="0">
-                <a:solidFill>
-                  <a:schemeClr val="bg1"/>
-                </a:solidFill>
-              </a:rPr>
-              <a:t>Creators chosen for the audiences the festival wants most</a:t>
-            </a:r>
-            <a:endParaRPr lang="en-GB" sz="1400" dirty="0"/>
-          </a:p>
-        </p:txBody>
-      </p:sp>
-      <p:pic>
-        <p:nvPicPr>
-          <p:cNvPr id="32" name="Image 7" descr="preencoded.png">    </p:cNvPr>
-          <p:cNvPicPr>
-            <a:picLocks noChangeAspect="1"/>
-          </p:cNvPicPr>
-          <p:nvPr/>
-        </p:nvPicPr>
-        <p:blipFill>
-          <a:blip r:embed="rId8"/>
-          <a:stretch>
-            <a:fillRect/>
-          </a:stretch>
-        </p:blipFill>
-        <p:spPr>
-          <a:xfrm>
-            <a:off x="7360920" y="3191256"/>
-            <a:ext cx="256032" cy="256032"/>
-          </a:xfrm>
-          <a:prstGeom prst="rect">
-            <a:avLst/>
-          </a:prstGeom>
-        </p:spPr>
-      </p:pic>
-      <p:sp>
-        <p:nvSpPr>
-          <p:cNvPr id="33" name="Text 22"/>
-          <p:cNvSpPr txBox="1"/>
-          <p:nvPr/>
-        </p:nvSpPr>
-        <p:spPr>
-          <a:xfrm>
-            <a:off x="7772400" y="3172968"/>
-            <a:ext cx="3611880" cy="457200"/>
-          </a:xfrm>
-          <a:prstGeom prst="rect">
-            <a:avLst/>
-          </a:prstGeom>
-          <a:noFill/>
-          <a:ln/>
-        </p:spPr>
-        <p:txBody>
-          <a:bodyPr wrap="square" lIns="0" tIns="0" rIns="0" bIns="0" rtlCol="0" anchor="t"/>
-          <a:lstStyle/>
-          <a:p>
-            <a:pPr indent="0" marL="0">
-              <a:buNone/>
-            </a:pPr>
-            <a:r>
-              <a:rPr lang="en-GB" altLang="en-US" sz="1400" dirty="0">
-                <a:solidFill>
-                  <a:schemeClr val="bg1"/>
-                </a:solidFill>
-              </a:rPr>
-              <a:t>Set deliverables and key messages for every creator</a:t>
-            </a:r>
-            <a:endParaRPr lang="en-GB" sz="1400" dirty="0"/>
-          </a:p>
-        </p:txBody>
-      </p:sp>
-      <p:pic>
-        <p:nvPicPr>
-          <p:cNvPr id="34" name="Image 8" descr="preencoded.png">    </p:cNvPr>
-          <p:cNvPicPr>
-            <a:picLocks noChangeAspect="1"/>
-          </p:cNvPicPr>
-          <p:nvPr/>
-        </p:nvPicPr>
-        <p:blipFill>
-          <a:blip r:embed="rId9"/>
-          <a:stretch>
-            <a:fillRect/>
-          </a:stretch>
-        </p:blipFill>
-        <p:spPr>
-          <a:xfrm>
-            <a:off x="7360920" y="3877056"/>
-            <a:ext cx="256032" cy="256032"/>
-          </a:xfrm>
-          <a:prstGeom prst="rect">
-            <a:avLst/>
-          </a:prstGeom>
-        </p:spPr>
-      </p:pic>
-      <p:sp>
-        <p:nvSpPr>
-          <p:cNvPr id="35" name="Text 23"/>
-          <p:cNvSpPr txBox="1"/>
-          <p:nvPr/>
-        </p:nvSpPr>
-        <p:spPr>
-          <a:xfrm>
-            <a:off x="7772400" y="3858768"/>
-            <a:ext cx="3611880" cy="457200"/>
-          </a:xfrm>
-          <a:prstGeom prst="rect">
-            <a:avLst/>
-          </a:prstGeom>
-          <a:noFill/>
-          <a:ln/>
-        </p:spPr>
-        <p:txBody>
-          <a:bodyPr wrap="square" lIns="0" tIns="0" rIns="0" bIns="0" rtlCol="0" anchor="t"/>
-          <a:lstStyle/>
-          <a:p>
-            <a:pPr indent="0" marL="0">
-              <a:buNone/>
-            </a:pPr>
-            <a:r>
-              <a:rPr lang="en-GB" altLang="en-US" sz="1400" dirty="0">
-                <a:solidFill>
-                  <a:schemeClr val="bg1"/>
-                </a:solidFill>
-              </a:rPr>
-              <a:t>A clear view of what each creator posts, and when</a:t>
-            </a:r>
-            <a:endParaRPr lang="en-GB" sz="1400" dirty="0"/>
-          </a:p>
-        </p:txBody>
-      </p:sp>
-      <p:pic>
-        <p:nvPicPr>
-          <p:cNvPr id="36" name="Image 9" descr="preencoded.png">    </p:cNvPr>
-          <p:cNvPicPr>
-            <a:picLocks noChangeAspect="1"/>
-          </p:cNvPicPr>
-          <p:nvPr/>
-        </p:nvPicPr>
-        <p:blipFill>
-          <a:blip r:embed="rId10"/>
-          <a:stretch>
-            <a:fillRect/>
-          </a:stretch>
-        </p:blipFill>
-        <p:spPr>
-          <a:xfrm>
-            <a:off x="7360920" y="4562856"/>
-            <a:ext cx="256032" cy="256032"/>
-          </a:xfrm>
-          <a:prstGeom prst="rect">
-            <a:avLst/>
-          </a:prstGeom>
-        </p:spPr>
-      </p:pic>
-      <p:sp>
-        <p:nvSpPr>
-          <p:cNvPr id="37" name="Text 24"/>
-          <p:cNvSpPr txBox="1"/>
-          <p:nvPr/>
-        </p:nvSpPr>
-        <p:spPr>
-          <a:xfrm>
-            <a:off x="7772400" y="4544568"/>
-            <a:ext cx="3611880" cy="457200"/>
-          </a:xfrm>
-          <a:prstGeom prst="rect">
-            <a:avLst/>
-          </a:prstGeom>
-          <a:noFill/>
-          <a:ln/>
-        </p:spPr>
-        <p:txBody>
-          <a:bodyPr wrap="square" lIns="0" tIns="0" rIns="0" bIns="0" rtlCol="0" anchor="t"/>
-          <a:lstStyle/>
-          <a:p>
-            <a:pPr indent="0" marL="0">
-              <a:buNone/>
-            </a:pPr>
-            <a:r>
-              <a:rPr lang="en-GB" altLang="en-US" sz="1400" dirty="0">
-                <a:solidFill>
-                  <a:schemeClr val="bg1"/>
-                </a:solidFill>
-              </a:rPr>
-              <a:t>Sponsor visibility the festival can prove, partner by partner</a:t>
-            </a:r>
-            <a:endParaRPr lang="en-GB" sz="1400" dirty="0"/>
-          </a:p>
-        </p:txBody>
-      </p:sp>
-      <p:pic>
-        <p:nvPicPr>
-          <p:cNvPr id="38" name="Image 10" descr="preencoded.png">    </p:cNvPr>
-          <p:cNvPicPr>
-            <a:picLocks noChangeAspect="1"/>
-          </p:cNvPicPr>
-          <p:nvPr/>
-        </p:nvPicPr>
-        <p:blipFill>
-          <a:blip r:embed="rId11"/>
-          <a:stretch>
-            <a:fillRect/>
-          </a:stretch>
-        </p:blipFill>
-        <p:spPr>
-          <a:xfrm>
-            <a:off x="7360920" y="5248656"/>
-            <a:ext cx="256032" cy="256032"/>
-          </a:xfrm>
-          <a:prstGeom prst="rect">
-            <a:avLst/>
-          </a:prstGeom>
-        </p:spPr>
-      </p:pic>
-      <p:sp>
-        <p:nvSpPr>
-          <p:cNvPr id="39" name="Text 25"/>
-          <p:cNvSpPr txBox="1"/>
-          <p:nvPr/>
-        </p:nvSpPr>
-        <p:spPr>
-          <a:xfrm>
-            <a:off x="7772400" y="5230368"/>
-            <a:ext cx="3611880" cy="457200"/>
+          <p:cNvPr id="53" name="Text 43"/>
+          <p:cNvSpPr txBox="1"/>
+          <p:nvPr/>
+        </p:nvSpPr>
+        <p:spPr>
+          <a:xfrm>
+            <a:off x="7863840" y="5367528"/>
+            <a:ext cx="3520440" cy="457200"/>
           </a:xfrm>
           <a:prstGeom prst="rect">
             <a:avLst/>
@@ -11666,7 +12053,7 @@
         <p:spPr>
           <a:xfrm>
             <a:off x="548640" y="1783080"/>
-            <a:ext cx="4297680" cy="2697480"/>
+            <a:ext cx="3657600" cy="2295728"/>
           </a:xfrm>
           <a:prstGeom prst="rect">
             <a:avLst/>
@@ -11681,7 +12068,7 @@
         </p:nvSpPr>
         <p:spPr>
           <a:xfrm>
-            <a:off x="685800" y="4050792"/>
+            <a:off x="658368" y="3676472"/>
             <a:ext cx="2598725" cy="292608"/>
           </a:xfrm>
           <a:prstGeom prst="roundRect">
@@ -11705,7 +12092,7 @@
         </p:nvSpPr>
         <p:spPr>
           <a:xfrm>
-            <a:off x="685800" y="4050792"/>
+            <a:off x="658368" y="3676472"/>
             <a:ext cx="2598725" cy="292608"/>
           </a:xfrm>
           <a:prstGeom prst="rect">
@@ -11735,53 +12122,14 @@
       </p:sp>
       <p:sp>
         <p:nvSpPr>
-          <p:cNvPr id="11" name="Text 5"/>
-          <p:cNvSpPr txBox="1"/>
-          <p:nvPr/>
-        </p:nvSpPr>
-        <p:spPr>
-          <a:xfrm>
-            <a:off x="548640" y="4709160"/>
-            <a:ext cx="4297680" cy="822960"/>
-          </a:xfrm>
-          <a:prstGeom prst="rect">
-            <a:avLst/>
-          </a:prstGeom>
-          <a:noFill/>
-          <a:ln/>
-        </p:spPr>
-        <p:txBody>
-          <a:bodyPr wrap="square" lIns="0" tIns="0" rIns="0" bIns="0" rtlCol="0" anchor="t"/>
-          <a:lstStyle/>
-          <a:p>
-            <a:pPr indent="0" marL="0">
-              <a:buNone/>
-            </a:pPr>
-            <a:r>
-              <a:rPr lang="en-GB" altLang="en-US" sz="2000" dirty="0">
-                <a:solidFill>
-                  <a:schemeClr val="accent3"/>
-                </a:solidFill>
-                <a:latin typeface="+mj-lt" pitchFamily="34" charset="0"/>
-                <a:ea typeface="+mj-lt" pitchFamily="34" charset="-122"/>
-                <a:cs typeface="+mj-lt" pitchFamily="34" charset="-120"/>
-              </a:rPr>
-              <a:t>Sponsors buy proven visibility. The report is how the festival proves it.</a:t>
-            </a:r>
-            <a:endParaRPr lang="en-GB" sz="2000" dirty="0"/>
-          </a:p>
-        </p:txBody>
-      </p:sp>
-      <p:sp>
-        <p:nvSpPr>
-          <p:cNvPr id="12" name="Shape 6"/>
+          <p:cNvPr id="11" name="Shape 5"/>
           <p:cNvSpPr/>
           <p:nvPr/>
         </p:nvSpPr>
         <p:spPr>
           <a:xfrm>
-            <a:off x="5349240" y="1783080"/>
-            <a:ext cx="502920" cy="502920"/>
+            <a:off x="4526280" y="1783080"/>
+            <a:ext cx="457200" cy="457200"/>
           </a:xfrm>
           <a:prstGeom prst="ellipse">
             <a:avLst/>
@@ -11794,7 +12142,7 @@
       </p:sp>
       <p:pic>
         <p:nvPicPr>
-          <p:cNvPr id="13" name="Image 3" descr="preencoded.png">    </p:cNvPr>
+          <p:cNvPr id="12" name="Image 3" descr="preencoded.png">    </p:cNvPr>
           <p:cNvPicPr>
             <a:picLocks noChangeAspect="1"/>
           </p:cNvPicPr>
@@ -11808,8 +12156,8 @@
         </p:blipFill>
         <p:spPr>
           <a:xfrm>
-            <a:off x="5469941" y="1903781"/>
-            <a:ext cx="261518" cy="261518"/>
+            <a:off x="4636008" y="1892808"/>
+            <a:ext cx="237744" cy="237744"/>
           </a:xfrm>
           <a:prstGeom prst="rect">
             <a:avLst/>
@@ -11818,14 +12166,14 @@
       </p:pic>
       <p:sp>
         <p:nvSpPr>
-          <p:cNvPr id="14" name="Text 7"/>
-          <p:cNvSpPr txBox="1"/>
-          <p:nvPr/>
-        </p:nvSpPr>
-        <p:spPr>
-          <a:xfrm>
-            <a:off x="6080760" y="1764792"/>
-            <a:ext cx="5532120" cy="347472"/>
+          <p:cNvPr id="13" name="Text 6"/>
+          <p:cNvSpPr txBox="1"/>
+          <p:nvPr/>
+        </p:nvSpPr>
+        <p:spPr>
+          <a:xfrm>
+            <a:off x="5120640" y="1755648"/>
+            <a:ext cx="2834640" cy="329184"/>
           </a:xfrm>
           <a:prstGeom prst="rect">
             <a:avLst/>
@@ -11841,7 +12189,7 @@
               <a:buNone/>
             </a:pPr>
             <a:r>
-              <a:rPr lang="en-GB" altLang="en-US" sz="2000" dirty="0">
+              <a:rPr lang="en-GB" altLang="en-US" sz="1800" dirty="0">
                 <a:solidFill>
                   <a:schemeClr val="tx1"/>
                 </a:solidFill>
@@ -11851,20 +12199,20 @@
               </a:rPr>
               <a:t>Written into every brief</a:t>
             </a:r>
-            <a:endParaRPr lang="en-GB" sz="2000" dirty="0"/>
-          </a:p>
-        </p:txBody>
-      </p:sp>
-      <p:sp>
-        <p:nvSpPr>
-          <p:cNvPr id="15" name="Text 8"/>
-          <p:cNvSpPr txBox="1"/>
-          <p:nvPr/>
-        </p:nvSpPr>
-        <p:spPr>
-          <a:xfrm>
-            <a:off x="6080760" y="2130552"/>
-            <a:ext cx="5532120" cy="457200"/>
+            <a:endParaRPr lang="en-GB" sz="1800" dirty="0"/>
+          </a:p>
+        </p:txBody>
+      </p:sp>
+      <p:sp>
+        <p:nvSpPr>
+          <p:cNvPr id="14" name="Text 7"/>
+          <p:cNvSpPr txBox="1"/>
+          <p:nvPr/>
+        </p:nvSpPr>
+        <p:spPr>
+          <a:xfrm>
+            <a:off x="5120640" y="2112264"/>
+            <a:ext cx="2834640" cy="685800"/>
           </a:xfrm>
           <a:prstGeom prst="rect">
             <a:avLst/>
@@ -11880,27 +12228,27 @@
               <a:buNone/>
             </a:pPr>
             <a:r>
-              <a:rPr lang="en-GB" altLang="en-US" sz="1400" dirty="0">
+              <a:rPr lang="en-GB" altLang="en-US" sz="1250" dirty="0">
                 <a:solidFill>
                   <a:schemeClr val="tx2"/>
                 </a:solidFill>
               </a:rPr>
               <a:t>Sponsor mentions agreed in advance, so partners appear naturally.</a:t>
             </a:r>
-            <a:endParaRPr lang="en-GB" sz="1400" dirty="0"/>
-          </a:p>
-        </p:txBody>
-      </p:sp>
-      <p:sp>
-        <p:nvSpPr>
-          <p:cNvPr id="16" name="Shape 9"/>
+            <a:endParaRPr lang="en-GB" sz="1250" dirty="0"/>
+          </a:p>
+        </p:txBody>
+      </p:sp>
+      <p:sp>
+        <p:nvSpPr>
+          <p:cNvPr id="15" name="Shape 8"/>
           <p:cNvSpPr/>
           <p:nvPr/>
         </p:nvSpPr>
         <p:spPr>
           <a:xfrm>
-            <a:off x="5349240" y="2807208"/>
-            <a:ext cx="502920" cy="502920"/>
+            <a:off x="8129016" y="1783080"/>
+            <a:ext cx="457200" cy="457200"/>
           </a:xfrm>
           <a:prstGeom prst="ellipse">
             <a:avLst/>
@@ -11913,7 +12261,7 @@
       </p:sp>
       <p:pic>
         <p:nvPicPr>
-          <p:cNvPr id="17" name="Image 4" descr="preencoded.png">    </p:cNvPr>
+          <p:cNvPr id="16" name="Image 4" descr="preencoded.png">    </p:cNvPr>
           <p:cNvPicPr>
             <a:picLocks noChangeAspect="1"/>
           </p:cNvPicPr>
@@ -11927,8 +12275,8 @@
         </p:blipFill>
         <p:spPr>
           <a:xfrm>
-            <a:off x="5469941" y="2927909"/>
-            <a:ext cx="261518" cy="261518"/>
+            <a:off x="8238744" y="1892808"/>
+            <a:ext cx="237744" cy="237744"/>
           </a:xfrm>
           <a:prstGeom prst="rect">
             <a:avLst/>
@@ -11937,14 +12285,14 @@
       </p:pic>
       <p:sp>
         <p:nvSpPr>
-          <p:cNvPr id="18" name="Text 10"/>
-          <p:cNvSpPr txBox="1"/>
-          <p:nvPr/>
-        </p:nvSpPr>
-        <p:spPr>
-          <a:xfrm>
-            <a:off x="6080760" y="2788920"/>
-            <a:ext cx="5532120" cy="347472"/>
+          <p:cNvPr id="17" name="Text 9"/>
+          <p:cNvSpPr txBox="1"/>
+          <p:nvPr/>
+        </p:nvSpPr>
+        <p:spPr>
+          <a:xfrm>
+            <a:off x="8723376" y="1755648"/>
+            <a:ext cx="2834640" cy="329184"/>
           </a:xfrm>
           <a:prstGeom prst="rect">
             <a:avLst/>
@@ -11960,7 +12308,7 @@
               <a:buNone/>
             </a:pPr>
             <a:r>
-              <a:rPr lang="en-GB" altLang="en-US" sz="2000" dirty="0">
+              <a:rPr lang="en-GB" altLang="en-US" sz="1800" dirty="0">
                 <a:solidFill>
                   <a:schemeClr val="tx1"/>
                 </a:solidFill>
@@ -11970,20 +12318,20 @@
               </a:rPr>
               <a:t>Branding in shot</a:t>
             </a:r>
-            <a:endParaRPr lang="en-GB" sz="2000" dirty="0"/>
-          </a:p>
-        </p:txBody>
-      </p:sp>
-      <p:sp>
-        <p:nvSpPr>
-          <p:cNvPr id="19" name="Text 11"/>
-          <p:cNvSpPr txBox="1"/>
-          <p:nvPr/>
-        </p:nvSpPr>
-        <p:spPr>
-          <a:xfrm>
-            <a:off x="6080760" y="3154680"/>
-            <a:ext cx="5532120" cy="457200"/>
+            <a:endParaRPr lang="en-GB" sz="1800" dirty="0"/>
+          </a:p>
+        </p:txBody>
+      </p:sp>
+      <p:sp>
+        <p:nvSpPr>
+          <p:cNvPr id="18" name="Text 10"/>
+          <p:cNvSpPr txBox="1"/>
+          <p:nvPr/>
+        </p:nvSpPr>
+        <p:spPr>
+          <a:xfrm>
+            <a:off x="8723376" y="2112264"/>
+            <a:ext cx="2834640" cy="685800"/>
           </a:xfrm>
           <a:prstGeom prst="rect">
             <a:avLst/>
@@ -11999,27 +12347,27 @@
               <a:buNone/>
             </a:pPr>
             <a:r>
-              <a:rPr lang="en-GB" altLang="en-US" sz="1400" dirty="0">
+              <a:rPr lang="en-GB" altLang="en-US" sz="1250" dirty="0">
                 <a:solidFill>
                   <a:schemeClr val="tx2"/>
                 </a:solidFill>
               </a:rPr>
               <a:t>Creators guided to every activation and stage banner on both nights.</a:t>
             </a:r>
-            <a:endParaRPr lang="en-GB" sz="1400" dirty="0"/>
-          </a:p>
-        </p:txBody>
-      </p:sp>
-      <p:sp>
-        <p:nvSpPr>
-          <p:cNvPr id="20" name="Shape 12"/>
+            <a:endParaRPr lang="en-GB" sz="1250" dirty="0"/>
+          </a:p>
+        </p:txBody>
+      </p:sp>
+      <p:sp>
+        <p:nvSpPr>
+          <p:cNvPr id="19" name="Shape 11"/>
           <p:cNvSpPr/>
           <p:nvPr/>
         </p:nvSpPr>
         <p:spPr>
           <a:xfrm>
-            <a:off x="5349240" y="3831336"/>
-            <a:ext cx="502920" cy="502920"/>
+            <a:off x="4526280" y="2971800"/>
+            <a:ext cx="457200" cy="457200"/>
           </a:xfrm>
           <a:prstGeom prst="ellipse">
             <a:avLst/>
@@ -12032,7 +12380,7 @@
       </p:sp>
       <p:pic>
         <p:nvPicPr>
-          <p:cNvPr id="21" name="Image 5" descr="preencoded.png">    </p:cNvPr>
+          <p:cNvPr id="20" name="Image 5" descr="preencoded.png">    </p:cNvPr>
           <p:cNvPicPr>
             <a:picLocks noChangeAspect="1"/>
           </p:cNvPicPr>
@@ -12046,8 +12394,8 @@
         </p:blipFill>
         <p:spPr>
           <a:xfrm>
-            <a:off x="5469941" y="3952037"/>
-            <a:ext cx="261518" cy="261518"/>
+            <a:off x="4636008" y="3081528"/>
+            <a:ext cx="237744" cy="237744"/>
           </a:xfrm>
           <a:prstGeom prst="rect">
             <a:avLst/>
@@ -12056,14 +12404,14 @@
       </p:pic>
       <p:sp>
         <p:nvSpPr>
-          <p:cNvPr id="22" name="Text 13"/>
-          <p:cNvSpPr txBox="1"/>
-          <p:nvPr/>
-        </p:nvSpPr>
-        <p:spPr>
-          <a:xfrm>
-            <a:off x="6080760" y="3813048"/>
-            <a:ext cx="5532120" cy="347472"/>
+          <p:cNvPr id="21" name="Text 12"/>
+          <p:cNvSpPr txBox="1"/>
+          <p:nvPr/>
+        </p:nvSpPr>
+        <p:spPr>
+          <a:xfrm>
+            <a:off x="5120640" y="2944368"/>
+            <a:ext cx="2834640" cy="329184"/>
           </a:xfrm>
           <a:prstGeom prst="rect">
             <a:avLst/>
@@ -12079,7 +12427,7 @@
               <a:buNone/>
             </a:pPr>
             <a:r>
-              <a:rPr lang="en-GB" altLang="en-US" sz="2000" dirty="0">
+              <a:rPr lang="en-GB" altLang="en-US" sz="1800" dirty="0">
                 <a:solidFill>
                   <a:schemeClr val="tx1"/>
                 </a:solidFill>
@@ -12087,22 +12435,22 @@
                 <a:ea typeface="+mj-lt" pitchFamily="34" charset="-122"/>
                 <a:cs typeface="+mj-lt" pitchFamily="34" charset="-120"/>
               </a:rPr>
-              <a:t>A page per sponsor in the report</a:t>
-            </a:r>
-            <a:endParaRPr lang="en-GB" sz="2000" dirty="0"/>
-          </a:p>
-        </p:txBody>
-      </p:sp>
-      <p:sp>
-        <p:nvSpPr>
-          <p:cNvPr id="23" name="Text 14"/>
-          <p:cNvSpPr txBox="1"/>
-          <p:nvPr/>
-        </p:nvSpPr>
-        <p:spPr>
-          <a:xfrm>
-            <a:off x="6080760" y="4178808"/>
-            <a:ext cx="5532120" cy="457200"/>
+              <a:t>A page per sponsor</a:t>
+            </a:r>
+            <a:endParaRPr lang="en-GB" sz="1800" dirty="0"/>
+          </a:p>
+        </p:txBody>
+      </p:sp>
+      <p:sp>
+        <p:nvSpPr>
+          <p:cNvPr id="22" name="Text 13"/>
+          <p:cNvSpPr txBox="1"/>
+          <p:nvPr/>
+        </p:nvSpPr>
+        <p:spPr>
+          <a:xfrm>
+            <a:off x="5120640" y="3300984"/>
+            <a:ext cx="2834640" cy="685800"/>
           </a:xfrm>
           <a:prstGeom prst="rect">
             <a:avLst/>
@@ -12118,27 +12466,27 @@
               <a:buNone/>
             </a:pPr>
             <a:r>
-              <a:rPr lang="en-GB" altLang="en-US" sz="1400" dirty="0">
+              <a:rPr lang="en-GB" altLang="en-US" sz="1250" dirty="0">
                 <a:solidFill>
                   <a:schemeClr val="tx2"/>
                 </a:solidFill>
               </a:rPr>
               <a:t>Posts, views, screen time and a media value, clearly labelled as estimated.</a:t>
             </a:r>
-            <a:endParaRPr lang="en-GB" sz="1400" dirty="0"/>
-          </a:p>
-        </p:txBody>
-      </p:sp>
-      <p:sp>
-        <p:nvSpPr>
-          <p:cNvPr id="24" name="Shape 15"/>
+            <a:endParaRPr lang="en-GB" sz="1250" dirty="0"/>
+          </a:p>
+        </p:txBody>
+      </p:sp>
+      <p:sp>
+        <p:nvSpPr>
+          <p:cNvPr id="23" name="Shape 14"/>
           <p:cNvSpPr/>
           <p:nvPr/>
         </p:nvSpPr>
         <p:spPr>
           <a:xfrm>
-            <a:off x="5349240" y="4855464"/>
-            <a:ext cx="502920" cy="502920"/>
+            <a:off x="8129016" y="2971800"/>
+            <a:ext cx="457200" cy="457200"/>
           </a:xfrm>
           <a:prstGeom prst="ellipse">
             <a:avLst/>
@@ -12151,7 +12499,7 @@
       </p:sp>
       <p:pic>
         <p:nvPicPr>
-          <p:cNvPr id="25" name="Image 6" descr="preencoded.png">    </p:cNvPr>
+          <p:cNvPr id="24" name="Image 6" descr="preencoded.png">    </p:cNvPr>
           <p:cNvPicPr>
             <a:picLocks noChangeAspect="1"/>
           </p:cNvPicPr>
@@ -12165,8 +12513,8 @@
         </p:blipFill>
         <p:spPr>
           <a:xfrm>
-            <a:off x="5469941" y="4976165"/>
-            <a:ext cx="261518" cy="261518"/>
+            <a:off x="8238744" y="3081528"/>
+            <a:ext cx="237744" cy="237744"/>
           </a:xfrm>
           <a:prstGeom prst="rect">
             <a:avLst/>
@@ -12175,14 +12523,14 @@
       </p:pic>
       <p:sp>
         <p:nvSpPr>
-          <p:cNvPr id="26" name="Text 16"/>
-          <p:cNvSpPr txBox="1"/>
-          <p:nvPr/>
-        </p:nvSpPr>
-        <p:spPr>
-          <a:xfrm>
-            <a:off x="6080760" y="4837176"/>
-            <a:ext cx="5532120" cy="347472"/>
+          <p:cNvPr id="25" name="Text 15"/>
+          <p:cNvSpPr txBox="1"/>
+          <p:nvPr/>
+        </p:nvSpPr>
+        <p:spPr>
+          <a:xfrm>
+            <a:off x="8723376" y="2944368"/>
+            <a:ext cx="2834640" cy="329184"/>
           </a:xfrm>
           <a:prstGeom prst="rect">
             <a:avLst/>
@@ -12198,7 +12546,7 @@
               <a:buNone/>
             </a:pPr>
             <a:r>
-              <a:rPr lang="en-GB" altLang="en-US" sz="2000" dirty="0">
+              <a:rPr lang="en-GB" altLang="en-US" sz="1800" dirty="0">
                 <a:solidFill>
                   <a:schemeClr val="tx1"/>
                 </a:solidFill>
@@ -12206,22 +12554,22 @@
                 <a:ea typeface="+mj-lt" pitchFamily="34" charset="-122"/>
                 <a:cs typeface="+mj-lt" pitchFamily="34" charset="-120"/>
               </a:rPr>
-              <a:t>Content the partners can reuse</a:t>
-            </a:r>
-            <a:endParaRPr lang="en-GB" sz="2000" dirty="0"/>
-          </a:p>
-        </p:txBody>
-      </p:sp>
-      <p:sp>
-        <p:nvSpPr>
-          <p:cNvPr id="27" name="Text 17"/>
-          <p:cNvSpPr txBox="1"/>
-          <p:nvPr/>
-        </p:nvSpPr>
-        <p:spPr>
-          <a:xfrm>
-            <a:off x="6080760" y="5202936"/>
-            <a:ext cx="5532120" cy="457200"/>
+              <a:t>Reusable content</a:t>
+            </a:r>
+            <a:endParaRPr lang="en-GB" sz="1800" dirty="0"/>
+          </a:p>
+        </p:txBody>
+      </p:sp>
+      <p:sp>
+        <p:nvSpPr>
+          <p:cNvPr id="26" name="Text 16"/>
+          <p:cNvSpPr txBox="1"/>
+          <p:nvPr/>
+        </p:nvSpPr>
+        <p:spPr>
+          <a:xfrm>
+            <a:off x="8723376" y="3300984"/>
+            <a:ext cx="2834640" cy="685800"/>
           </a:xfrm>
           <a:prstGeom prst="rect">
             <a:avLst/>
@@ -12237,14 +12585,481 @@
               <a:buNone/>
             </a:pPr>
             <a:r>
-              <a:rPr lang="en-GB" altLang="en-US" sz="1400" dirty="0">
+              <a:rPr lang="en-GB" altLang="en-US" sz="1250" dirty="0">
                 <a:solidFill>
                   <a:schemeClr val="tx2"/>
                 </a:solidFill>
               </a:rPr>
               <a:t>The festival and its sponsors can share the best pieces again.</a:t>
             </a:r>
-            <a:endParaRPr lang="en-GB" sz="1400" dirty="0"/>
+            <a:endParaRPr lang="en-GB" sz="1250" dirty="0"/>
+          </a:p>
+        </p:txBody>
+      </p:sp>
+      <p:sp>
+        <p:nvSpPr>
+          <p:cNvPr id="27" name="Shape 17"/>
+          <p:cNvSpPr/>
+          <p:nvPr/>
+        </p:nvSpPr>
+        <p:spPr>
+          <a:xfrm>
+            <a:off x="548640" y="4343400"/>
+            <a:ext cx="11094415" cy="1737360"/>
+          </a:xfrm>
+          <a:prstGeom prst="roundRect">
+            <a:avLst>
+              <a:gd name="adj" fmla="val 4211"/>
+            </a:avLst>
+          </a:prstGeom>
+          <a:solidFill>
+            <a:schemeClr val="tx1"/>
+          </a:solidFill>
+          <a:ln w="22225">
+            <a:solidFill>
+              <a:schemeClr val="accent1"/>
+            </a:solidFill>
+            <a:prstDash val="solid"/>
+          </a:ln>
+          <a:effectLst>
+            <a:outerShdw sx="100000" sy="100000" kx="0" ky="0" algn="bl" rotWithShape="0" blurRad="228600" dist="50800" dir="5400000">
+              <a:srgbClr val="C8A951">
+                <a:alpha val="30000"/>
+              </a:srgbClr>
+            </a:outerShdw>
+          </a:effectLst>
+        </p:spPr>
+      </p:sp>
+      <p:sp>
+        <p:nvSpPr>
+          <p:cNvPr id="28" name="Text 18"/>
+          <p:cNvSpPr txBox="1"/>
+          <p:nvPr/>
+        </p:nvSpPr>
+        <p:spPr>
+          <a:xfrm>
+            <a:off x="822960" y="4544568"/>
+            <a:ext cx="3108960" cy="365760"/>
+          </a:xfrm>
+          <a:prstGeom prst="rect">
+            <a:avLst/>
+          </a:prstGeom>
+          <a:noFill/>
+          <a:ln/>
+        </p:spPr>
+        <p:txBody>
+          <a:bodyPr wrap="square" lIns="0" tIns="0" rIns="0" bIns="0" rtlCol="0" anchor="ctr"/>
+          <a:lstStyle/>
+          <a:p>
+            <a:pPr indent="0" marL="0">
+              <a:buNone/>
+            </a:pPr>
+            <a:r>
+              <a:rPr lang="en-GB" altLang="en-US" sz="1700" b="1" spc="100" kern="0" dirty="0">
+                <a:solidFill>
+                  <a:schemeClr val="accent1"/>
+                </a:solidFill>
+              </a:rPr>
+              <a:t>THE REVENUE MODEL</a:t>
+            </a:r>
+            <a:endParaRPr lang="en-GB" sz="1700" dirty="0"/>
+          </a:p>
+        </p:txBody>
+      </p:sp>
+      <p:sp>
+        <p:nvSpPr>
+          <p:cNvPr id="29" name="Text 19"/>
+          <p:cNvSpPr txBox="1"/>
+          <p:nvPr/>
+        </p:nvSpPr>
+        <p:spPr>
+          <a:xfrm>
+            <a:off x="3291840" y="4544568"/>
+            <a:ext cx="8076895" cy="365760"/>
+          </a:xfrm>
+          <a:prstGeom prst="rect">
+            <a:avLst/>
+          </a:prstGeom>
+          <a:noFill/>
+          <a:ln/>
+        </p:spPr>
+        <p:txBody>
+          <a:bodyPr wrap="square" lIns="0" tIns="0" rIns="0" bIns="0" rtlCol="0" anchor="ctr"/>
+          <a:lstStyle/>
+          <a:p>
+            <a:pPr algn="r" indent="0" marL="0">
+              <a:buNone/>
+            </a:pPr>
+            <a:r>
+              <a:rPr lang="en-GB" altLang="en-US" sz="950" b="1" spc="200" kern="0" dirty="0">
+                <a:solidFill>
+                  <a:schemeClr val="bg1"/>
+                </a:solidFill>
+              </a:rPr>
+              <a:t>WHERE THE NEW MONEY COMES FROM</a:t>
+            </a:r>
+            <a:endParaRPr lang="en-GB" sz="950" dirty="0"/>
+          </a:p>
+        </p:txBody>
+      </p:sp>
+      <p:sp>
+        <p:nvSpPr>
+          <p:cNvPr id="30" name="Shape 20"/>
+          <p:cNvSpPr/>
+          <p:nvPr/>
+        </p:nvSpPr>
+        <p:spPr>
+          <a:xfrm>
+            <a:off x="822960" y="5120640"/>
+            <a:ext cx="2274812" cy="731520"/>
+          </a:xfrm>
+          <a:prstGeom prst="roundRect">
+            <a:avLst>
+              <a:gd name="adj" fmla="val 7500"/>
+            </a:avLst>
+          </a:prstGeom>
+          <a:solidFill>
+            <a:schemeClr val="accent6"/>
+          </a:solidFill>
+          <a:ln w="6350">
+            <a:solidFill>
+              <a:schemeClr val="accent5">
+                <a:alpha val="25000"/>
+              </a:schemeClr>
+            </a:solidFill>
+            <a:prstDash val="solid"/>
+          </a:ln>
+        </p:spPr>
+      </p:sp>
+      <p:sp>
+        <p:nvSpPr>
+          <p:cNvPr id="31" name="Text 21"/>
+          <p:cNvSpPr txBox="1"/>
+          <p:nvPr/>
+        </p:nvSpPr>
+        <p:spPr>
+          <a:xfrm>
+            <a:off x="877824" y="5120640"/>
+            <a:ext cx="2165084" cy="731520"/>
+          </a:xfrm>
+          <a:prstGeom prst="rect">
+            <a:avLst/>
+          </a:prstGeom>
+          <a:noFill/>
+          <a:ln/>
+        </p:spPr>
+        <p:txBody>
+          <a:bodyPr wrap="square" lIns="0" tIns="0" rIns="0" bIns="0" rtlCol="0" anchor="ctr"/>
+          <a:lstStyle/>
+          <a:p>
+            <a:pPr algn="ctr" indent="0" marL="0">
+              <a:buNone/>
+            </a:pPr>
+            <a:r>
+              <a:rPr lang="en-GB" altLang="en-US" sz="1150" b="1" dirty="0">
+                <a:solidFill>
+                  <a:schemeClr val="bg1"/>
+                </a:solidFill>
+              </a:rPr>
+              <a:t>MORE CREATORS</a:t>
+            </a:r>
+            <a:endParaRPr lang="en-GB" sz="1150" dirty="0"/>
+          </a:p>
+        </p:txBody>
+      </p:sp>
+      <p:sp>
+        <p:nvSpPr>
+          <p:cNvPr id="32" name="Text 22"/>
+          <p:cNvSpPr txBox="1"/>
+          <p:nvPr/>
+        </p:nvSpPr>
+        <p:spPr>
+          <a:xfrm>
+            <a:off x="3097772" y="5120640"/>
+            <a:ext cx="292608" cy="731520"/>
+          </a:xfrm>
+          <a:prstGeom prst="rect">
+            <a:avLst/>
+          </a:prstGeom>
+          <a:noFill/>
+          <a:ln/>
+        </p:spPr>
+        <p:txBody>
+          <a:bodyPr wrap="square" lIns="0" tIns="0" rIns="0" bIns="0" rtlCol="0" anchor="ctr"/>
+          <a:lstStyle/>
+          <a:p>
+            <a:pPr algn="ctr" indent="0" marL="0">
+              <a:buNone/>
+            </a:pPr>
+            <a:r>
+              <a:rPr lang="en-GB" altLang="en-US" sz="1800" dirty="0">
+                <a:solidFill>
+                  <a:schemeClr val="accent1"/>
+                </a:solidFill>
+              </a:rPr>
+              <a:t>→</a:t>
+            </a:r>
+            <a:endParaRPr lang="en-GB" sz="1800" dirty="0"/>
+          </a:p>
+        </p:txBody>
+      </p:sp>
+      <p:sp>
+        <p:nvSpPr>
+          <p:cNvPr id="33" name="Shape 23"/>
+          <p:cNvSpPr/>
+          <p:nvPr/>
+        </p:nvSpPr>
+        <p:spPr>
+          <a:xfrm>
+            <a:off x="3390380" y="5120640"/>
+            <a:ext cx="2274812" cy="731520"/>
+          </a:xfrm>
+          <a:prstGeom prst="roundRect">
+            <a:avLst>
+              <a:gd name="adj" fmla="val 7500"/>
+            </a:avLst>
+          </a:prstGeom>
+          <a:solidFill>
+            <a:schemeClr val="accent6"/>
+          </a:solidFill>
+          <a:ln w="6350">
+            <a:solidFill>
+              <a:schemeClr val="accent5">
+                <a:alpha val="25000"/>
+              </a:schemeClr>
+            </a:solidFill>
+            <a:prstDash val="solid"/>
+          </a:ln>
+        </p:spPr>
+      </p:sp>
+      <p:sp>
+        <p:nvSpPr>
+          <p:cNvPr id="34" name="Text 24"/>
+          <p:cNvSpPr txBox="1"/>
+          <p:nvPr/>
+        </p:nvSpPr>
+        <p:spPr>
+          <a:xfrm>
+            <a:off x="3445244" y="5120640"/>
+            <a:ext cx="2165084" cy="731520"/>
+          </a:xfrm>
+          <a:prstGeom prst="rect">
+            <a:avLst/>
+          </a:prstGeom>
+          <a:noFill/>
+          <a:ln/>
+        </p:spPr>
+        <p:txBody>
+          <a:bodyPr wrap="square" lIns="0" tIns="0" rIns="0" bIns="0" rtlCol="0" anchor="ctr"/>
+          <a:lstStyle/>
+          <a:p>
+            <a:pPr algn="ctr" indent="0" marL="0">
+              <a:buNone/>
+            </a:pPr>
+            <a:r>
+              <a:rPr lang="en-GB" altLang="en-US" sz="1150" b="1" dirty="0">
+                <a:solidFill>
+                  <a:schemeClr val="bg1"/>
+                </a:solidFill>
+              </a:rPr>
+              <a:t>MORE VISIBILITY</a:t>
+            </a:r>
+            <a:endParaRPr lang="en-GB" sz="1150" dirty="0"/>
+          </a:p>
+        </p:txBody>
+      </p:sp>
+      <p:sp>
+        <p:nvSpPr>
+          <p:cNvPr id="35" name="Text 25"/>
+          <p:cNvSpPr txBox="1"/>
+          <p:nvPr/>
+        </p:nvSpPr>
+        <p:spPr>
+          <a:xfrm>
+            <a:off x="5665192" y="5120640"/>
+            <a:ext cx="292608" cy="731520"/>
+          </a:xfrm>
+          <a:prstGeom prst="rect">
+            <a:avLst/>
+          </a:prstGeom>
+          <a:noFill/>
+          <a:ln/>
+        </p:spPr>
+        <p:txBody>
+          <a:bodyPr wrap="square" lIns="0" tIns="0" rIns="0" bIns="0" rtlCol="0" anchor="ctr"/>
+          <a:lstStyle/>
+          <a:p>
+            <a:pPr algn="ctr" indent="0" marL="0">
+              <a:buNone/>
+            </a:pPr>
+            <a:r>
+              <a:rPr lang="en-GB" altLang="en-US" sz="1800" dirty="0">
+                <a:solidFill>
+                  <a:schemeClr val="accent1"/>
+                </a:solidFill>
+              </a:rPr>
+              <a:t>→</a:t>
+            </a:r>
+            <a:endParaRPr lang="en-GB" sz="1800" dirty="0"/>
+          </a:p>
+        </p:txBody>
+      </p:sp>
+      <p:sp>
+        <p:nvSpPr>
+          <p:cNvPr id="36" name="Shape 26"/>
+          <p:cNvSpPr/>
+          <p:nvPr/>
+        </p:nvSpPr>
+        <p:spPr>
+          <a:xfrm>
+            <a:off x="5957800" y="5120640"/>
+            <a:ext cx="2274812" cy="731520"/>
+          </a:xfrm>
+          <a:prstGeom prst="roundRect">
+            <a:avLst>
+              <a:gd name="adj" fmla="val 7500"/>
+            </a:avLst>
+          </a:prstGeom>
+          <a:solidFill>
+            <a:schemeClr val="accent6"/>
+          </a:solidFill>
+          <a:ln w="6350">
+            <a:solidFill>
+              <a:schemeClr val="accent5">
+                <a:alpha val="25000"/>
+              </a:schemeClr>
+            </a:solidFill>
+            <a:prstDash val="solid"/>
+          </a:ln>
+        </p:spPr>
+      </p:sp>
+      <p:sp>
+        <p:nvSpPr>
+          <p:cNvPr id="37" name="Text 27"/>
+          <p:cNvSpPr txBox="1"/>
+          <p:nvPr/>
+        </p:nvSpPr>
+        <p:spPr>
+          <a:xfrm>
+            <a:off x="6012664" y="5120640"/>
+            <a:ext cx="2165084" cy="731520"/>
+          </a:xfrm>
+          <a:prstGeom prst="rect">
+            <a:avLst/>
+          </a:prstGeom>
+          <a:noFill/>
+          <a:ln/>
+        </p:spPr>
+        <p:txBody>
+          <a:bodyPr wrap="square" lIns="0" tIns="0" rIns="0" bIns="0" rtlCol="0" anchor="ctr"/>
+          <a:lstStyle/>
+          <a:p>
+            <a:pPr algn="ctr" indent="0" marL="0">
+              <a:buNone/>
+            </a:pPr>
+            <a:r>
+              <a:rPr lang="en-GB" altLang="en-US" sz="1150" b="1" dirty="0">
+                <a:solidFill>
+                  <a:schemeClr val="bg1"/>
+                </a:solidFill>
+              </a:rPr>
+              <a:t>BRAND KPIS MET</a:t>
+            </a:r>
+            <a:endParaRPr lang="en-GB" sz="1150" dirty="0"/>
+          </a:p>
+        </p:txBody>
+      </p:sp>
+      <p:sp>
+        <p:nvSpPr>
+          <p:cNvPr id="38" name="Text 28"/>
+          <p:cNvSpPr txBox="1"/>
+          <p:nvPr/>
+        </p:nvSpPr>
+        <p:spPr>
+          <a:xfrm>
+            <a:off x="8232612" y="5120640"/>
+            <a:ext cx="292608" cy="731520"/>
+          </a:xfrm>
+          <a:prstGeom prst="rect">
+            <a:avLst/>
+          </a:prstGeom>
+          <a:noFill/>
+          <a:ln/>
+        </p:spPr>
+        <p:txBody>
+          <a:bodyPr wrap="square" lIns="0" tIns="0" rIns="0" bIns="0" rtlCol="0" anchor="ctr"/>
+          <a:lstStyle/>
+          <a:p>
+            <a:pPr algn="ctr" indent="0" marL="0">
+              <a:buNone/>
+            </a:pPr>
+            <a:r>
+              <a:rPr lang="en-GB" altLang="en-US" sz="1800" dirty="0">
+                <a:solidFill>
+                  <a:schemeClr val="accent1"/>
+                </a:solidFill>
+              </a:rPr>
+              <a:t>→</a:t>
+            </a:r>
+            <a:endParaRPr lang="en-GB" sz="1800" dirty="0"/>
+          </a:p>
+        </p:txBody>
+      </p:sp>
+      <p:sp>
+        <p:nvSpPr>
+          <p:cNvPr id="39" name="Shape 29"/>
+          <p:cNvSpPr/>
+          <p:nvPr/>
+        </p:nvSpPr>
+        <p:spPr>
+          <a:xfrm>
+            <a:off x="8525220" y="5120640"/>
+            <a:ext cx="2843515" cy="731520"/>
+          </a:xfrm>
+          <a:prstGeom prst="roundRect">
+            <a:avLst>
+              <a:gd name="adj" fmla="val 7500"/>
+            </a:avLst>
+          </a:prstGeom>
+          <a:solidFill>
+            <a:schemeClr val="accent1"/>
+          </a:solidFill>
+          <a:ln/>
+        </p:spPr>
+      </p:sp>
+      <p:sp>
+        <p:nvSpPr>
+          <p:cNvPr id="40" name="Text 30"/>
+          <p:cNvSpPr txBox="1"/>
+          <p:nvPr/>
+        </p:nvSpPr>
+        <p:spPr>
+          <a:xfrm>
+            <a:off x="8580084" y="5120640"/>
+            <a:ext cx="2733787" cy="731520"/>
+          </a:xfrm>
+          <a:prstGeom prst="rect">
+            <a:avLst/>
+          </a:prstGeom>
+          <a:noFill/>
+          <a:ln/>
+        </p:spPr>
+        <p:txBody>
+          <a:bodyPr wrap="square" lIns="0" tIns="0" rIns="0" bIns="0" rtlCol="0" anchor="ctr"/>
+          <a:lstStyle/>
+          <a:p>
+            <a:pPr algn="ctr" indent="0" marL="0">
+              <a:buNone/>
+            </a:pPr>
+            <a:r>
+              <a:rPr lang="en-GB" altLang="en-US" sz="1150" b="1" dirty="0">
+                <a:solidFill>
+                  <a:schemeClr val="tx1"/>
+                </a:solidFill>
+              </a:rPr>
+              <a:t>SPONSOR AND INVESTOR MONEY</a:t>
+            </a:r>
+            <a:endParaRPr lang="en-GB" sz="1150" dirty="0"/>
           </a:p>
         </p:txBody>
       </p:sp>

</xml_diff>

<commit_message>
Track record slide: three photos across the full width, no side box
Co-Authored-By: Claude Opus 5.5 <noreply@anthropic.com>
Claude-Session: https://claude.ai/code/session_01YTg2S2E4e7prUd2maqTatG
</commit_message>
<xml_diff>
--- a/proposition-deck/AToure Mother Africa Festival Proposal.pptx
+++ b/proposition-deck/AToure Mother Africa Festival Proposal.pptx
@@ -117,41 +117,41 @@
   <p:extLst>
     <p:ext uri="{521415D9-36F7-43E2-AB2F-B90AF26B5E84}">
       <p14:sectionLst xmlns:p14="http://schemas.microsoft.com/office/powerpoint/2010/main">
-        <p14:section name="Opening" id="{04354458-7b03-ce9b-95cc-f23c95f8a679}">
+        <p14:section name="Opening" id="{250c2eca-894e-41e1-0899-23d88bbe86cd}">
           <p14:sldIdLst>
             <p14:sldId id="256"/>
           </p14:sldIdLst>
         </p14:section>
-        <p14:section name="Where we stand" id="{807591e4-ca4d-c80c-cc28-ce535a68e555}">
+        <p14:section name="Where we stand" id="{00c2d038-d408-13f2-700a-4d52439472ad}">
           <p14:sldIdLst>
             <p14:sldId id="257"/>
             <p14:sldId id="258"/>
           </p14:sldIdLst>
         </p14:section>
-        <p14:section name="The AToure answer" id="{2ccc0e7f-3be1-42a2-112b-fb520960a4d3}">
+        <p14:section name="The AToure answer" id="{fcecd234-7045-e72b-f288-e32676b133af}">
           <p14:sldIdLst>
             <p14:sldId id="259"/>
             <p14:sldId id="260"/>
           </p14:sldIdLst>
         </p14:section>
-        <p14:section name="Visibility" id="{4f0cc013-ed16-31c1-f320-f00396fed880}">
+        <p14:section name="Visibility" id="{112061c7-b307-7a32-59b5-2126a98ce7fa}">
           <p14:sldIdLst>
             <p14:sldId id="261"/>
             <p14:sldId id="262"/>
           </p14:sldIdLst>
         </p14:section>
-        <p14:section name="The visibility report" id="{8eb308de-b9cd-c380-2333-b7c85db1df64}">
+        <p14:section name="The visibility report" id="{1e7f2a57-748a-2016-9ef1-acf4ac32d03d}">
           <p14:sldIdLst>
             <p14:sldId id="263"/>
             <p14:sldId id="264"/>
           </p14:sldIdLst>
         </p14:section>
-        <p14:section name="Proof" id="{bea4a2c9-a6c1-f697-9fc4-ba3a437d0f2e}">
+        <p14:section name="Proof" id="{87168272-fd2b-175f-9b7b-c2ea1c087d18}">
           <p14:sldIdLst>
             <p14:sldId id="265"/>
           </p14:sldIdLst>
         </p14:section>
-        <p14:section name="The ask" id="{28a184f7-8718-fd31-4fd0-645d471964e1}">
+        <p14:section name="The ask" id="{9747eb90-a63e-1ac4-a639-3967d4d288be}">
           <p14:sldIdLst>
             <p14:sldId id="266"/>
           </p14:sldIdLst>
@@ -3544,7 +3544,7 @@
         <p:spPr>
           <a:xfrm>
             <a:off x="548640" y="1783080"/>
-            <a:ext cx="3943898" cy="2743200"/>
+            <a:ext cx="4929872" cy="3429000"/>
           </a:xfrm>
           <a:prstGeom prst="rect">
             <a:avLst/>
@@ -3559,7 +3559,7 @@
         </p:nvSpPr>
         <p:spPr>
           <a:xfrm>
-            <a:off x="658368" y="4123944"/>
+            <a:off x="658368" y="4809744"/>
             <a:ext cx="796442" cy="292608"/>
           </a:xfrm>
           <a:prstGeom prst="roundRect">
@@ -3583,7 +3583,7 @@
         </p:nvSpPr>
         <p:spPr>
           <a:xfrm>
-            <a:off x="658368" y="4123944"/>
+            <a:off x="658368" y="4809744"/>
             <a:ext cx="796442" cy="292608"/>
           </a:xfrm>
           <a:prstGeom prst="rect">
@@ -3619,8 +3619,8 @@
         </p:nvSpPr>
         <p:spPr>
           <a:xfrm>
-            <a:off x="548640" y="4663440"/>
-            <a:ext cx="3943898" cy="457200"/>
+            <a:off x="548640" y="5321808"/>
+            <a:ext cx="4929872" cy="411480"/>
           </a:xfrm>
           <a:prstGeom prst="rect">
             <a:avLst/>
@@ -3636,14 +3636,14 @@
               <a:buNone/>
             </a:pPr>
             <a:r>
-              <a:rPr lang="en-GB" altLang="en-US" sz="2800" dirty="0">
+              <a:rPr lang="en-GB" altLang="en-US" sz="2600" dirty="0">
                 <a:solidFill>
                   <a:schemeClr val="accent4"/>
                 </a:solidFill>
               </a:rPr>
               <a:t>55.8M</a:t>
             </a:r>
-            <a:endParaRPr lang="en-GB" sz="2800" dirty="0"/>
+            <a:endParaRPr lang="en-GB" sz="2600" dirty="0"/>
           </a:p>
         </p:txBody>
       </p:sp>
@@ -3655,8 +3655,8 @@
         </p:nvSpPr>
         <p:spPr>
           <a:xfrm>
-            <a:off x="548640" y="5138928"/>
-            <a:ext cx="3943898" cy="685800"/>
+            <a:off x="548640" y="5733288"/>
+            <a:ext cx="4929872" cy="347472"/>
           </a:xfrm>
           <a:prstGeom prst="rect">
             <a:avLst/>
@@ -3672,14 +3672,14 @@
               <a:buNone/>
             </a:pPr>
             <a:r>
-              <a:rPr lang="en-GB" altLang="en-US" sz="1100" dirty="0">
+              <a:rPr lang="en-GB" altLang="en-US" sz="1050" dirty="0">
                 <a:solidFill>
                   <a:schemeClr val="accent5"/>
                 </a:solidFill>
               </a:rPr>
               <a:t>Instagram views on one reel. IShowSpeed in Côte d’Ivoire.</a:t>
             </a:r>
-            <a:endParaRPr lang="en-GB" sz="1100" dirty="0"/>
+            <a:endParaRPr lang="en-GB" sz="1050" dirty="0"/>
           </a:p>
         </p:txBody>
       </p:sp>
@@ -3699,8 +3699,8 @@
         </p:blipFill>
         <p:spPr>
           <a:xfrm>
-            <a:off x="4766858" y="1783080"/>
-            <a:ext cx="1831848" cy="2743200"/>
+            <a:off x="6044279" y="1783080"/>
+            <a:ext cx="2289810" cy="3429000"/>
           </a:xfrm>
           <a:prstGeom prst="rect">
             <a:avLst/>
@@ -3715,8 +3715,8 @@
         </p:nvSpPr>
         <p:spPr>
           <a:xfrm>
-            <a:off x="4876586" y="4123944"/>
-            <a:ext cx="796442" cy="292608"/>
+            <a:off x="6154007" y="4809744"/>
+            <a:ext cx="1664208" cy="292608"/>
           </a:xfrm>
           <a:prstGeom prst="roundRect">
             <a:avLst>
@@ -3739,8 +3739,8 @@
         </p:nvSpPr>
         <p:spPr>
           <a:xfrm>
-            <a:off x="4876586" y="4123944"/>
-            <a:ext cx="796442" cy="292608"/>
+            <a:off x="6154007" y="4809744"/>
+            <a:ext cx="1664208" cy="292608"/>
           </a:xfrm>
           <a:prstGeom prst="rect">
             <a:avLst/>
@@ -3761,7 +3761,7 @@
                   <a:schemeClr val="bg1"/>
                 </a:solidFill>
               </a:rPr>
-              <a:t>Morocco</a:t>
+              <a:t>Morocco, AFCON Final</a:t>
             </a:r>
             <a:endParaRPr lang="en-GB" sz="1000" dirty="0"/>
           </a:p>
@@ -3775,8 +3775,8 @@
         </p:nvSpPr>
         <p:spPr>
           <a:xfrm>
-            <a:off x="4766858" y="4663440"/>
-            <a:ext cx="1831848" cy="457200"/>
+            <a:off x="6044279" y="5321808"/>
+            <a:ext cx="2289810" cy="411480"/>
           </a:xfrm>
           <a:prstGeom prst="rect">
             <a:avLst/>
@@ -3792,14 +3792,14 @@
               <a:buNone/>
             </a:pPr>
             <a:r>
-              <a:rPr lang="en-GB" altLang="en-US" sz="2800" dirty="0">
+              <a:rPr lang="en-GB" altLang="en-US" sz="2600" dirty="0">
                 <a:solidFill>
                   <a:schemeClr val="accent4"/>
                 </a:solidFill>
               </a:rPr>
               <a:t>16M</a:t>
             </a:r>
-            <a:endParaRPr lang="en-GB" sz="2800" dirty="0"/>
+            <a:endParaRPr lang="en-GB" sz="2600" dirty="0"/>
           </a:p>
         </p:txBody>
       </p:sp>
@@ -3811,8 +3811,8 @@
         </p:nvSpPr>
         <p:spPr>
           <a:xfrm>
-            <a:off x="4766858" y="5138928"/>
-            <a:ext cx="1831848" cy="685800"/>
+            <a:off x="6044279" y="5733288"/>
+            <a:ext cx="2289810" cy="347472"/>
           </a:xfrm>
           <a:prstGeom prst="rect">
             <a:avLst/>
@@ -3828,14 +3828,14 @@
               <a:buNone/>
             </a:pPr>
             <a:r>
-              <a:rPr lang="en-GB" altLang="en-US" sz="1100" dirty="0">
+              <a:rPr lang="en-GB" altLang="en-US" sz="1050" dirty="0">
                 <a:solidFill>
                   <a:schemeClr val="accent5"/>
                 </a:solidFill>
               </a:rPr>
-              <a:t>Live stream views of the AFCON mascot reveal, with CAF and the FRMF.</a:t>
-            </a:r>
-            <a:endParaRPr lang="en-GB" sz="1100" dirty="0"/>
+              <a:t>Live stream views of the AFCON mascot reveal.</a:t>
+            </a:r>
+            <a:endParaRPr lang="en-GB" sz="1050" dirty="0"/>
           </a:p>
         </p:txBody>
       </p:sp>
@@ -3855,8 +3855,8 @@
         </p:blipFill>
         <p:spPr>
           <a:xfrm>
-            <a:off x="6873026" y="1783080"/>
-            <a:ext cx="2194560" cy="2743200"/>
+            <a:off x="8899855" y="1783080"/>
+            <a:ext cx="2743200" cy="3429000"/>
           </a:xfrm>
           <a:prstGeom prst="rect">
             <a:avLst/>
@@ -3871,7 +3871,7 @@
         </p:nvSpPr>
         <p:spPr>
           <a:xfrm>
-            <a:off x="6982754" y="4123944"/>
+            <a:off x="9009583" y="4809744"/>
             <a:ext cx="662940" cy="292608"/>
           </a:xfrm>
           <a:prstGeom prst="roundRect">
@@ -3895,7 +3895,7 @@
         </p:nvSpPr>
         <p:spPr>
           <a:xfrm>
-            <a:off x="6982754" y="4123944"/>
+            <a:off x="9009583" y="4809744"/>
             <a:ext cx="662940" cy="292608"/>
           </a:xfrm>
           <a:prstGeom prst="rect">
@@ -3931,8 +3931,8 @@
         </p:nvSpPr>
         <p:spPr>
           <a:xfrm>
-            <a:off x="6873026" y="4663440"/>
-            <a:ext cx="2194560" cy="457200"/>
+            <a:off x="8899855" y="5321808"/>
+            <a:ext cx="2743200" cy="411480"/>
           </a:xfrm>
           <a:prstGeom prst="rect">
             <a:avLst/>
@@ -3948,14 +3948,14 @@
               <a:buNone/>
             </a:pPr>
             <a:r>
-              <a:rPr lang="en-GB" altLang="en-US" sz="2800" dirty="0">
+              <a:rPr lang="en-GB" altLang="en-US" sz="2600" dirty="0">
                 <a:solidFill>
                   <a:schemeClr val="accent4"/>
                 </a:solidFill>
               </a:rPr>
               <a:t>1.57B</a:t>
             </a:r>
-            <a:endParaRPr lang="en-GB" sz="2800" dirty="0"/>
+            <a:endParaRPr lang="en-GB" sz="2600" dirty="0"/>
           </a:p>
         </p:txBody>
       </p:sp>
@@ -3967,8 +3967,8 @@
         </p:nvSpPr>
         <p:spPr>
           <a:xfrm>
-            <a:off x="6873026" y="5138928"/>
-            <a:ext cx="2194560" cy="685800"/>
+            <a:off x="8899855" y="5733288"/>
+            <a:ext cx="2743200" cy="347472"/>
           </a:xfrm>
           <a:prstGeom prst="rect">
             <a:avLst/>
@@ -3984,56 +3984,27 @@
               <a:buNone/>
             </a:pPr>
             <a:r>
-              <a:rPr lang="en-GB" altLang="en-US" sz="1100" dirty="0">
+              <a:rPr lang="en-GB" altLang="en-US" sz="1050" dirty="0">
                 <a:solidFill>
                   <a:schemeClr val="accent5"/>
                 </a:solidFill>
               </a:rPr>
               <a:t>Tour views across five countries, managed end to end.</a:t>
             </a:r>
-            <a:endParaRPr lang="en-GB" sz="1100" dirty="0"/>
-          </a:p>
-        </p:txBody>
-      </p:sp>
-      <p:sp>
-        <p:nvSpPr>
-          <p:cNvPr id="25" name="Shape 16"/>
-          <p:cNvSpPr/>
-          <p:nvPr/>
-        </p:nvSpPr>
-        <p:spPr>
-          <a:xfrm>
-            <a:off x="9387626" y="1783080"/>
-            <a:ext cx="2255429" cy="2743200"/>
-          </a:xfrm>
-          <a:prstGeom prst="roundRect">
-            <a:avLst>
-              <a:gd name="adj" fmla="val 4054"/>
-            </a:avLst>
-          </a:prstGeom>
-          <a:solidFill>
-            <a:schemeClr val="accent6"/>
-          </a:solidFill>
-          <a:ln w="9525">
-            <a:solidFill>
-              <a:schemeClr val="accent1">
-                <a:alpha val="45000"/>
-              </a:schemeClr>
-            </a:solidFill>
-            <a:prstDash val="solid"/>
-          </a:ln>
-        </p:spPr>
-      </p:sp>
-      <p:sp>
-        <p:nvSpPr>
-          <p:cNvPr id="26" name="Text 17"/>
-          <p:cNvSpPr txBox="1"/>
-          <p:nvPr/>
-        </p:nvSpPr>
-        <p:spPr>
-          <a:xfrm>
-            <a:off x="9588794" y="2011680"/>
-            <a:ext cx="1889669" cy="256032"/>
+            <a:endParaRPr lang="en-GB" sz="1050" dirty="0"/>
+          </a:p>
+        </p:txBody>
+      </p:sp>
+      <p:sp>
+        <p:nvSpPr>
+          <p:cNvPr id="25" name="Text 16"/>
+          <p:cNvSpPr txBox="1"/>
+          <p:nvPr/>
+        </p:nvSpPr>
+        <p:spPr>
+          <a:xfrm>
+            <a:off x="548640" y="6144768"/>
+            <a:ext cx="11094415" cy="201168"/>
           </a:xfrm>
           <a:prstGeom prst="rect">
             <a:avLst/>
@@ -4049,144 +4020,14 @@
               <a:buNone/>
             </a:pPr>
             <a:r>
-              <a:rPr lang="en-GB" altLang="en-US" sz="1100" b="1" spc="300" kern="0" dirty="0">
-                <a:solidFill>
-                  <a:schemeClr val="accent1"/>
-                </a:solidFill>
-              </a:rPr>
-              <a:t>WHAT ATOURE DID</a:t>
-            </a:r>
-            <a:endParaRPr lang="en-GB" sz="1100" dirty="0"/>
-          </a:p>
-        </p:txBody>
-      </p:sp>
-      <p:sp>
-        <p:nvSpPr>
-          <p:cNvPr id="27" name="Text 18"/>
-          <p:cNvSpPr txBox="1"/>
-          <p:nvPr/>
-        </p:nvSpPr>
-        <p:spPr>
-          <a:xfrm>
-            <a:off x="9588794" y="2423160"/>
-            <a:ext cx="1889669" cy="1965960"/>
-          </a:xfrm>
-          <a:prstGeom prst="rect">
-            <a:avLst/>
-          </a:prstGeom>
-          <a:noFill/>
-          <a:ln/>
-        </p:spPr>
-        <p:txBody>
-          <a:bodyPr wrap="square" lIns="0" tIns="0" rIns="0" bIns="0" rtlCol="0" anchor="t"/>
-          <a:lstStyle/>
-          <a:p>
-            <a:pPr marL="177800" indent="-177800">
-              <a:spcAft>
-                <a:spcPts val="800"/>
-              </a:spcAft>
-              <a:buSzPct val="100000"/>
-              <a:buChar char="•"/>
-            </a:pPr>
-            <a:r>
-              <a:rPr lang="en-GB" altLang="en-US" sz="1200" dirty="0">
+              <a:rPr lang="en-GB" altLang="en-US" sz="900" dirty="0">
                 <a:solidFill>
                   <a:schemeClr val="accent5"/>
                 </a:solidFill>
               </a:rPr>
-              <a:t>Operations built from zero in Abidjan</a:t>
-            </a:r>
-            <a:endParaRPr lang="en-GB" sz="1200" dirty="0"/>
-          </a:p>
-          <a:p>
-            <a:pPr marL="177800" indent="-177800">
-              <a:spcAft>
-                <a:spcPts val="800"/>
-              </a:spcAft>
-              <a:buSzPct val="100000"/>
-              <a:buChar char="•"/>
-            </a:pPr>
-            <a:r>
-              <a:rPr lang="en-GB" altLang="en-US" sz="1200" dirty="0">
-                <a:solidFill>
-                  <a:schemeClr val="accent5"/>
-                </a:solidFill>
-              </a:rPr>
-              <a:t>State visas, permits and security</a:t>
-            </a:r>
-            <a:endParaRPr lang="en-GB" sz="1200" dirty="0"/>
-          </a:p>
-          <a:p>
-            <a:pPr marL="177800" indent="-177800">
-              <a:spcAft>
-                <a:spcPts val="800"/>
-              </a:spcAft>
-              <a:buSzPct val="100000"/>
-              <a:buChar char="•"/>
-            </a:pPr>
-            <a:r>
-              <a:rPr lang="en-GB" altLang="en-US" sz="1200" dirty="0">
-                <a:solidFill>
-                  <a:schemeClr val="accent5"/>
-                </a:solidFill>
-              </a:rPr>
-              <a:t>Sponsors and partners brought in</a:t>
-            </a:r>
-            <a:endParaRPr lang="en-GB" sz="1200" dirty="0"/>
-          </a:p>
-          <a:p>
-            <a:pPr marL="177800" indent="-177800">
-              <a:spcAft>
-                <a:spcPts val="800"/>
-              </a:spcAft>
-              <a:buSzPct val="100000"/>
-              <a:buChar char="•"/>
-            </a:pPr>
-            <a:r>
-              <a:rPr lang="en-GB" altLang="en-US" sz="1200" dirty="0">
-                <a:solidFill>
-                  <a:schemeClr val="accent5"/>
-                </a:solidFill>
-              </a:rPr>
-              <a:t>Creators managed end to end</a:t>
-            </a:r>
-            <a:endParaRPr lang="en-GB" sz="1200" dirty="0"/>
-          </a:p>
-        </p:txBody>
-      </p:sp>
-      <p:sp>
-        <p:nvSpPr>
-          <p:cNvPr id="28" name="Text 19"/>
-          <p:cNvSpPr txBox="1"/>
-          <p:nvPr/>
-        </p:nvSpPr>
-        <p:spPr>
-          <a:xfrm>
-            <a:off x="548640" y="5943600"/>
-            <a:ext cx="11094415" cy="237744"/>
-          </a:xfrm>
-          <a:prstGeom prst="rect">
-            <a:avLst/>
-          </a:prstGeom>
-          <a:noFill/>
-          <a:ln/>
-        </p:spPr>
-        <p:txBody>
-          <a:bodyPr wrap="square" lIns="0" tIns="0" rIns="0" bIns="0" rtlCol="0" anchor="t"/>
-          <a:lstStyle/>
-          <a:p>
-            <a:pPr indent="0" marL="0">
-              <a:buNone/>
-            </a:pPr>
-            <a:r>
-              <a:rPr lang="en-GB" altLang="en-US" sz="1000" dirty="0">
-                <a:solidFill>
-                  <a:schemeClr val="accent5"/>
-                </a:solidFill>
-              </a:rPr>
               <a:t>Sources: Instagram and YouTube analytics, tour figures supplied by the client.</a:t>
             </a:r>
-            <a:endParaRPr lang="en-GB" sz="1000" dirty="0"/>
+            <a:endParaRPr lang="en-GB" sz="900" dirty="0"/>
           </a:p>
         </p:txBody>
       </p:sp>

</xml_diff>

<commit_message>
Show illustrative figures in the sample report on slide 9
Co-Authored-By: Claude Opus 5.5 <noreply@anthropic.com>
Claude-Session: https://claude.ai/code/session_01YTg2S2E4e7prUd2maqTatG
</commit_message>
<xml_diff>
--- a/proposition-deck/AToure Mother Africa Festival Proposal.pptx
+++ b/proposition-deck/AToure Mother Africa Festival Proposal.pptx
@@ -117,41 +117,41 @@
   <p:extLst>
     <p:ext uri="{521415D9-36F7-43E2-AB2F-B90AF26B5E84}">
       <p14:sectionLst xmlns:p14="http://schemas.microsoft.com/office/powerpoint/2010/main">
-        <p14:section name="Opening" id="{250c2eca-894e-41e1-0899-23d88bbe86cd}">
+        <p14:section name="Opening" id="{0a4d33fa-f2c4-ae50-61a1-d070f0b47e5f}">
           <p14:sldIdLst>
             <p14:sldId id="256"/>
           </p14:sldIdLst>
         </p14:section>
-        <p14:section name="Where we stand" id="{00c2d038-d408-13f2-700a-4d52439472ad}">
+        <p14:section name="Where we stand" id="{cde2ba44-b78f-8a02-fd81-129a32e7b7dd}">
           <p14:sldIdLst>
             <p14:sldId id="257"/>
             <p14:sldId id="258"/>
           </p14:sldIdLst>
         </p14:section>
-        <p14:section name="The AToure answer" id="{fcecd234-7045-e72b-f288-e32676b133af}">
+        <p14:section name="The AToure answer" id="{ceeebc9c-8ac9-f1a0-ee74-72a9d957be83}">
           <p14:sldIdLst>
             <p14:sldId id="259"/>
             <p14:sldId id="260"/>
           </p14:sldIdLst>
         </p14:section>
-        <p14:section name="Visibility" id="{112061c7-b307-7a32-59b5-2126a98ce7fa}">
+        <p14:section name="Visibility" id="{3b69fa0d-1995-668f-d320-f35445c926c7}">
           <p14:sldIdLst>
             <p14:sldId id="261"/>
             <p14:sldId id="262"/>
           </p14:sldIdLst>
         </p14:section>
-        <p14:section name="The visibility report" id="{1e7f2a57-748a-2016-9ef1-acf4ac32d03d}">
+        <p14:section name="The visibility report" id="{81698a7a-df62-7082-27d4-73a9adb31b74}">
           <p14:sldIdLst>
             <p14:sldId id="263"/>
             <p14:sldId id="264"/>
           </p14:sldIdLst>
         </p14:section>
-        <p14:section name="Proof" id="{87168272-fd2b-175f-9b7b-c2ea1c087d18}">
+        <p14:section name="Proof" id="{d9ae477a-e6d6-2737-895c-c692adf1566d}">
           <p14:sldIdLst>
             <p14:sldId id="265"/>
           </p14:sldIdLst>
         </p14:section>
-        <p14:section name="The ask" id="{9747eb90-a63e-1ac4-a639-3967d4d288be}">
+        <p14:section name="The ask" id="{f58007ae-1434-e264-4278-563b1ec01c3c}">
           <p14:sldIdLst>
             <p14:sldId id="266"/>
           </p14:sldIdLst>
@@ -1440,7 +1440,7 @@
           <a:p>
             <a:r>
               <a:rPr lang="en-US" dirty="0"/>
-              <a:t>Three fixed dates. A one page weekly pulse during the build up, so effort moves to the creators who are working. A check 48 hours after the festival: who posted, where, against which brief. The full report on day 14, by 11 January 2027, as a PDF for the board and sponsors with a web version. The page on the right is a sample layout only; it shows no figures.</a:t>
+              <a:t>Three fixed dates. A one page weekly pulse during the build up, so effort moves to the creators who are working. A check 48 hours after the festival: who posted, where, against which brief. The full report on day 14, by 11 January 2027, as a PDF for the board and sponsors with a web version. The page on the right is a sample layout: its figures are illustrative, to show the format, and are not a forecast for the festival.</a:t>
             </a:r>
             <a:endParaRPr lang="en-US" dirty="0"/>
           </a:p>
@@ -15594,27 +15594,39 @@
       </p:sp>
       <p:sp>
         <p:nvSpPr>
-          <p:cNvPr id="30" name="Shape 21"/>
-          <p:cNvSpPr/>
-          <p:nvPr/>
-        </p:nvSpPr>
-        <p:spPr>
-          <a:xfrm>
-            <a:off x="7388352" y="2980944"/>
-            <a:ext cx="1005840" cy="201168"/>
-          </a:xfrm>
-          <a:prstGeom prst="roundRect">
-            <a:avLst>
-              <a:gd name="adj" fmla="val 18182"/>
-            </a:avLst>
-          </a:prstGeom>
-          <a:solidFill>
-            <a:schemeClr val="tx2">
-              <a:alpha val="28000"/>
-            </a:schemeClr>
-          </a:solidFill>
-          <a:ln/>
-        </p:spPr>
+          <p:cNvPr id="30" name="Text 21"/>
+          <p:cNvSpPr txBox="1"/>
+          <p:nvPr/>
+        </p:nvSpPr>
+        <p:spPr>
+          <a:xfrm>
+            <a:off x="7388352" y="2907792"/>
+            <a:ext cx="1737360" cy="347472"/>
+          </a:xfrm>
+          <a:prstGeom prst="rect">
+            <a:avLst/>
+          </a:prstGeom>
+          <a:noFill/>
+          <a:ln/>
+        </p:spPr>
+        <p:txBody>
+          <a:bodyPr wrap="square" lIns="0" tIns="0" rIns="0" bIns="0" rtlCol="0" anchor="t"/>
+          <a:lstStyle/>
+          <a:p>
+            <a:pPr indent="0" marL="0">
+              <a:buNone/>
+            </a:pPr>
+            <a:r>
+              <a:rPr lang="en-GB" altLang="en-US" sz="1800" b="1" dirty="0">
+                <a:solidFill>
+                  <a:schemeClr val="tx1"/>
+                </a:solidFill>
+              </a:rPr>
+              <a:t>3,200,000</a:t>
+            </a:r>
+            <a:endParaRPr lang="en-GB" sz="1800" dirty="0"/>
+          </a:p>
+        </p:txBody>
       </p:sp>
       <p:sp>
         <p:nvSpPr>
@@ -15624,8 +15636,8 @@
         </p:nvSpPr>
         <p:spPr>
           <a:xfrm>
-            <a:off x="7388352" y="3255264"/>
-            <a:ext cx="1737360" cy="201168"/>
+            <a:off x="7388352" y="3273552"/>
+            <a:ext cx="1783080" cy="201168"/>
           </a:xfrm>
           <a:prstGeom prst="rect">
             <a:avLst/>
@@ -15676,27 +15688,39 @@
       </p:sp>
       <p:sp>
         <p:nvSpPr>
-          <p:cNvPr id="33" name="Shape 24"/>
-          <p:cNvSpPr/>
-          <p:nvPr/>
-        </p:nvSpPr>
-        <p:spPr>
-          <a:xfrm>
-            <a:off x="9509760" y="2980944"/>
-            <a:ext cx="1005840" cy="201168"/>
-          </a:xfrm>
-          <a:prstGeom prst="roundRect">
-            <a:avLst>
-              <a:gd name="adj" fmla="val 18182"/>
-            </a:avLst>
-          </a:prstGeom>
-          <a:solidFill>
-            <a:schemeClr val="tx2">
-              <a:alpha val="28000"/>
-            </a:schemeClr>
-          </a:solidFill>
-          <a:ln/>
-        </p:spPr>
+          <p:cNvPr id="33" name="Text 24"/>
+          <p:cNvSpPr txBox="1"/>
+          <p:nvPr/>
+        </p:nvSpPr>
+        <p:spPr>
+          <a:xfrm>
+            <a:off x="9509760" y="2907792"/>
+            <a:ext cx="1737360" cy="347472"/>
+          </a:xfrm>
+          <a:prstGeom prst="rect">
+            <a:avLst/>
+          </a:prstGeom>
+          <a:noFill/>
+          <a:ln/>
+        </p:spPr>
+        <p:txBody>
+          <a:bodyPr wrap="square" lIns="0" tIns="0" rIns="0" bIns="0" rtlCol="0" anchor="t"/>
+          <a:lstStyle/>
+          <a:p>
+            <a:pPr indent="0" marL="0">
+              <a:buNone/>
+            </a:pPr>
+            <a:r>
+              <a:rPr lang="en-GB" altLang="en-US" sz="1800" b="1" dirty="0">
+                <a:solidFill>
+                  <a:schemeClr val="tx1"/>
+                </a:solidFill>
+              </a:rPr>
+              <a:t>1,450,000</a:t>
+            </a:r>
+            <a:endParaRPr lang="en-GB" sz="1800" dirty="0"/>
+          </a:p>
+        </p:txBody>
       </p:sp>
       <p:sp>
         <p:nvSpPr>
@@ -15706,8 +15730,8 @@
         </p:nvSpPr>
         <p:spPr>
           <a:xfrm>
-            <a:off x="9509760" y="3255264"/>
-            <a:ext cx="1737360" cy="201168"/>
+            <a:off x="9509760" y="3273552"/>
+            <a:ext cx="1783080" cy="201168"/>
           </a:xfrm>
           <a:prstGeom prst="rect">
             <a:avLst/>
@@ -15758,27 +15782,39 @@
       </p:sp>
       <p:sp>
         <p:nvSpPr>
-          <p:cNvPr id="36" name="Shape 27"/>
-          <p:cNvSpPr/>
-          <p:nvPr/>
-        </p:nvSpPr>
-        <p:spPr>
-          <a:xfrm>
-            <a:off x="7388352" y="3849624"/>
-            <a:ext cx="1005840" cy="201168"/>
-          </a:xfrm>
-          <a:prstGeom prst="roundRect">
-            <a:avLst>
-              <a:gd name="adj" fmla="val 18182"/>
-            </a:avLst>
-          </a:prstGeom>
-          <a:solidFill>
-            <a:schemeClr val="tx2">
-              <a:alpha val="28000"/>
-            </a:schemeClr>
-          </a:solidFill>
-          <a:ln/>
-        </p:spPr>
+          <p:cNvPr id="36" name="Text 27"/>
+          <p:cNvSpPr txBox="1"/>
+          <p:nvPr/>
+        </p:nvSpPr>
+        <p:spPr>
+          <a:xfrm>
+            <a:off x="7388352" y="3776472"/>
+            <a:ext cx="1737360" cy="347472"/>
+          </a:xfrm>
+          <a:prstGeom prst="rect">
+            <a:avLst/>
+          </a:prstGeom>
+          <a:noFill/>
+          <a:ln/>
+        </p:spPr>
+        <p:txBody>
+          <a:bodyPr wrap="square" lIns="0" tIns="0" rIns="0" bIns="0" rtlCol="0" anchor="t"/>
+          <a:lstStyle/>
+          <a:p>
+            <a:pPr indent="0" marL="0">
+              <a:buNone/>
+            </a:pPr>
+            <a:r>
+              <a:rPr lang="en-GB" altLang="en-US" sz="1800" b="1" dirty="0">
+                <a:solidFill>
+                  <a:schemeClr val="tx1"/>
+                </a:solidFill>
+              </a:rPr>
+              <a:t>64</a:t>
+            </a:r>
+            <a:endParaRPr lang="en-GB" sz="1800" dirty="0"/>
+          </a:p>
+        </p:txBody>
       </p:sp>
       <p:sp>
         <p:nvSpPr>
@@ -15788,8 +15824,8 @@
         </p:nvSpPr>
         <p:spPr>
           <a:xfrm>
-            <a:off x="7388352" y="4123944"/>
-            <a:ext cx="1737360" cy="201168"/>
+            <a:off x="7388352" y="4142232"/>
+            <a:ext cx="1783080" cy="201168"/>
           </a:xfrm>
           <a:prstGeom prst="rect">
             <a:avLst/>
@@ -15810,7 +15846,7 @@
                   <a:schemeClr val="tx2"/>
                 </a:solidFill>
               </a:rPr>
-              <a:t>Posts checked</a:t>
+              <a:t>Posts checked against the brief</a:t>
             </a:r>
             <a:endParaRPr lang="en-GB" sz="1000" dirty="0"/>
           </a:p>
@@ -15840,27 +15876,39 @@
       </p:sp>
       <p:sp>
         <p:nvSpPr>
-          <p:cNvPr id="39" name="Shape 30"/>
-          <p:cNvSpPr/>
-          <p:nvPr/>
-        </p:nvSpPr>
-        <p:spPr>
-          <a:xfrm>
-            <a:off x="9509760" y="3849624"/>
-            <a:ext cx="1005840" cy="201168"/>
-          </a:xfrm>
-          <a:prstGeom prst="roundRect">
-            <a:avLst>
-              <a:gd name="adj" fmla="val 18182"/>
-            </a:avLst>
-          </a:prstGeom>
-          <a:solidFill>
-            <a:schemeClr val="tx2">
-              <a:alpha val="28000"/>
-            </a:schemeClr>
-          </a:solidFill>
-          <a:ln/>
-        </p:spPr>
+          <p:cNvPr id="39" name="Text 30"/>
+          <p:cNvSpPr txBox="1"/>
+          <p:nvPr/>
+        </p:nvSpPr>
+        <p:spPr>
+          <a:xfrm>
+            <a:off x="9509760" y="3776472"/>
+            <a:ext cx="1737360" cy="347472"/>
+          </a:xfrm>
+          <a:prstGeom prst="rect">
+            <a:avLst/>
+          </a:prstGeom>
+          <a:noFill/>
+          <a:ln/>
+        </p:spPr>
+        <p:txBody>
+          <a:bodyPr wrap="square" lIns="0" tIns="0" rIns="0" bIns="0" rtlCol="0" anchor="t"/>
+          <a:lstStyle/>
+          <a:p>
+            <a:pPr indent="0" marL="0">
+              <a:buNone/>
+            </a:pPr>
+            <a:r>
+              <a:rPr lang="en-GB" altLang="en-US" sz="1800" b="1" dirty="0">
+                <a:solidFill>
+                  <a:schemeClr val="tx1"/>
+                </a:solidFill>
+              </a:rPr>
+              <a:t>18</a:t>
+            </a:r>
+            <a:endParaRPr lang="en-GB" sz="1800" dirty="0"/>
+          </a:p>
+        </p:txBody>
       </p:sp>
       <p:sp>
         <p:nvSpPr>
@@ -15870,8 +15918,8 @@
         </p:nvSpPr>
         <p:spPr>
           <a:xfrm>
-            <a:off x="9509760" y="4123944"/>
-            <a:ext cx="1737360" cy="201168"/>
+            <a:off x="9509760" y="4142232"/>
+            <a:ext cx="1783080" cy="201168"/>
           </a:xfrm>
           <a:prstGeom prst="rect">
             <a:avLst/>
@@ -15979,7 +16027,7 @@
         <p:spPr>
           <a:xfrm>
             <a:off x="8275320" y="4946904"/>
-            <a:ext cx="2651760" cy="146304"/>
+            <a:ext cx="2468880" cy="146304"/>
           </a:xfrm>
           <a:prstGeom prst="roundRect">
             <a:avLst>
@@ -16000,6 +16048,42 @@
         </p:nvSpPr>
         <p:spPr>
           <a:xfrm>
+            <a:off x="10835640" y="4910328"/>
+            <a:ext cx="548640" cy="219456"/>
+          </a:xfrm>
+          <a:prstGeom prst="rect">
+            <a:avLst/>
+          </a:prstGeom>
+          <a:noFill/>
+          <a:ln/>
+        </p:spPr>
+        <p:txBody>
+          <a:bodyPr wrap="square" lIns="0" tIns="0" rIns="0" bIns="0" rtlCol="0" anchor="ctr"/>
+          <a:lstStyle/>
+          <a:p>
+            <a:pPr indent="0" marL="0">
+              <a:buNone/>
+            </a:pPr>
+            <a:r>
+              <a:rPr lang="en-GB" altLang="en-US" sz="1000" b="1" dirty="0">
+                <a:solidFill>
+                  <a:schemeClr val="tx1"/>
+                </a:solidFill>
+              </a:rPr>
+              <a:t>52%</a:t>
+            </a:r>
+            <a:endParaRPr lang="en-GB" sz="1000" dirty="0"/>
+          </a:p>
+        </p:txBody>
+      </p:sp>
+      <p:sp>
+        <p:nvSpPr>
+          <p:cNvPr id="45" name="Text 36"/>
+          <p:cNvSpPr txBox="1"/>
+          <p:nvPr/>
+        </p:nvSpPr>
+        <p:spPr>
+          <a:xfrm>
             <a:off x="7223760" y="5239512"/>
             <a:ext cx="1005840" cy="219456"/>
           </a:xfrm>
@@ -16030,14 +16114,14 @@
       </p:sp>
       <p:sp>
         <p:nvSpPr>
-          <p:cNvPr id="45" name="Shape 36"/>
+          <p:cNvPr id="46" name="Shape 37"/>
           <p:cNvSpPr/>
           <p:nvPr/>
         </p:nvSpPr>
         <p:spPr>
           <a:xfrm>
             <a:off x="8275320" y="5276088"/>
-            <a:ext cx="2011680" cy="146304"/>
+            <a:ext cx="1804182" cy="146304"/>
           </a:xfrm>
           <a:prstGeom prst="roundRect">
             <a:avLst>
@@ -16052,7 +16136,43 @@
       </p:sp>
       <p:sp>
         <p:nvSpPr>
-          <p:cNvPr id="46" name="Text 37"/>
+          <p:cNvPr id="47" name="Text 38"/>
+          <p:cNvSpPr txBox="1"/>
+          <p:nvPr/>
+        </p:nvSpPr>
+        <p:spPr>
+          <a:xfrm>
+            <a:off x="10170942" y="5239512"/>
+            <a:ext cx="548640" cy="219456"/>
+          </a:xfrm>
+          <a:prstGeom prst="rect">
+            <a:avLst/>
+          </a:prstGeom>
+          <a:noFill/>
+          <a:ln/>
+        </p:spPr>
+        <p:txBody>
+          <a:bodyPr wrap="square" lIns="0" tIns="0" rIns="0" bIns="0" rtlCol="0" anchor="ctr"/>
+          <a:lstStyle/>
+          <a:p>
+            <a:pPr indent="0" marL="0">
+              <a:buNone/>
+            </a:pPr>
+            <a:r>
+              <a:rPr lang="en-GB" altLang="en-US" sz="1000" b="1" dirty="0">
+                <a:solidFill>
+                  <a:schemeClr val="tx1"/>
+                </a:solidFill>
+              </a:rPr>
+              <a:t>38%</a:t>
+            </a:r>
+            <a:endParaRPr lang="en-GB" sz="1000" dirty="0"/>
+          </a:p>
+        </p:txBody>
+      </p:sp>
+      <p:sp>
+        <p:nvSpPr>
+          <p:cNvPr id="48" name="Text 39"/>
           <p:cNvSpPr txBox="1"/>
           <p:nvPr/>
         </p:nvSpPr>
@@ -16088,14 +16208,14 @@
       </p:sp>
       <p:sp>
         <p:nvSpPr>
-          <p:cNvPr id="47" name="Shape 38"/>
+          <p:cNvPr id="49" name="Shape 40"/>
           <p:cNvSpPr/>
           <p:nvPr/>
         </p:nvSpPr>
         <p:spPr>
           <a:xfrm>
             <a:off x="8275320" y="5605272"/>
-            <a:ext cx="1005840" cy="146304"/>
+            <a:ext cx="474785" cy="146304"/>
           </a:xfrm>
           <a:prstGeom prst="roundRect">
             <a:avLst>
@@ -16110,14 +16230,50 @@
       </p:sp>
       <p:sp>
         <p:nvSpPr>
-          <p:cNvPr id="48" name="Text 39"/>
+          <p:cNvPr id="50" name="Text 41"/>
+          <p:cNvSpPr txBox="1"/>
+          <p:nvPr/>
+        </p:nvSpPr>
+        <p:spPr>
+          <a:xfrm>
+            <a:off x="8841545" y="5568696"/>
+            <a:ext cx="548640" cy="219456"/>
+          </a:xfrm>
+          <a:prstGeom prst="rect">
+            <a:avLst/>
+          </a:prstGeom>
+          <a:noFill/>
+          <a:ln/>
+        </p:spPr>
+        <p:txBody>
+          <a:bodyPr wrap="square" lIns="0" tIns="0" rIns="0" bIns="0" rtlCol="0" anchor="ctr"/>
+          <a:lstStyle/>
+          <a:p>
+            <a:pPr indent="0" marL="0">
+              <a:buNone/>
+            </a:pPr>
+            <a:r>
+              <a:rPr lang="en-GB" altLang="en-US" sz="1000" b="1" dirty="0">
+                <a:solidFill>
+                  <a:schemeClr val="tx1"/>
+                </a:solidFill>
+              </a:rPr>
+              <a:t>10%</a:t>
+            </a:r>
+            <a:endParaRPr lang="en-GB" sz="1000" dirty="0"/>
+          </a:p>
+        </p:txBody>
+      </p:sp>
+      <p:sp>
+        <p:nvSpPr>
+          <p:cNvPr id="51" name="Text 42"/>
           <p:cNvSpPr txBox="1"/>
           <p:nvPr/>
         </p:nvSpPr>
         <p:spPr>
           <a:xfrm>
             <a:off x="7223760" y="5879592"/>
-            <a:ext cx="3657600" cy="201168"/>
+            <a:ext cx="4114800" cy="201168"/>
           </a:xfrm>
           <a:prstGeom prst="rect">
             <a:avLst/>
@@ -16133,12 +16289,12 @@
               <a:buNone/>
             </a:pPr>
             <a:r>
-              <a:rPr lang="en-GB" altLang="en-US" sz="1000" i="1" dirty="0">
-                <a:solidFill>
-                  <a:schemeClr val="tx2"/>
-                </a:solidFill>
-              </a:rPr>
-              <a:t>Sample layout. No figures shown.</a:t>
+              <a:rPr lang="en-GB" altLang="en-US" sz="1000" b="1" i="1" dirty="0">
+                <a:solidFill>
+                  <a:schemeClr val="accent3"/>
+                </a:solidFill>
+              </a:rPr>
+              <a:t>Sample layout. Figures are illustrative.</a:t>
             </a:r>
             <a:endParaRPr lang="en-GB" sz="1000" dirty="0"/>
           </a:p>

</xml_diff>

<commit_message>
Put the AI images in the deck, in English and French
The cover becomes a full bleed illustration of a festival goer filming
the stage. The briefing illustration joins creator management, a picture
heads each of the three waves, and the creator pass leads the proposal
slide. Real photos stay on the proof slides. Each illustration's alt text
starts with Illustration, and the cover notes say which slides use them.

Co-Authored-By: Claude Opus 5.5 <noreply@anthropic.com>
Claude-Session: https://claude.ai/code/session_01YTg2S2E4e7prUd2maqTatG
</commit_message>
<xml_diff>
--- a/proposition-deck/AToure Mother Africa Festival Proposal.pptx
+++ b/proposition-deck/AToure Mother Africa Festival Proposal.pptx
@@ -118,50 +118,50 @@
   <p:extLst>
     <p:ext uri="{521415D9-36F7-43E2-AB2F-B90AF26B5E84}">
       <p14:sectionLst xmlns:p14="http://schemas.microsoft.com/office/powerpoint/2010/main">
-        <p14:section name="Opening" id="{80000311-732c-2d10-74c1-8efbadcfd056}">
+        <p14:section name="Opening" id="{380a37e7-f4f1-a850-bd9c-f4e641fbccc8}">
           <p14:sldIdLst>
             <p14:sldId id="256"/>
           </p14:sldIdLst>
         </p14:section>
-        <p14:section name="Where we stand" id="{1663daec-388d-495c-fe94-427393a3f80f}">
+        <p14:section name="Where we stand" id="{0bb156a8-2274-c3c6-0544-a10804c3d700}">
           <p14:sldIdLst>
             <p14:sldId id="257"/>
             <p14:sldId id="258"/>
           </p14:sldIdLst>
         </p14:section>
-        <p14:section name="The AToure answer" id="{c4371925-ff2f-1cea-2456-8ca85570c1b7}">
+        <p14:section name="The AToure answer" id="{16f5454e-abac-c531-4c45-582d39c208de}">
           <p14:sldIdLst>
             <p14:sldId id="259"/>
             <p14:sldId id="260"/>
           </p14:sldIdLst>
         </p14:section>
-        <p14:section name="Visibility" id="{c4edc138-bade-a0e0-46d3-34e86f8c404c}">
+        <p14:section name="Visibility" id="{c4255278-f614-1b78-5300-959afaf00ab5}">
           <p14:sldIdLst>
             <p14:sldId id="261"/>
             <p14:sldId id="262"/>
           </p14:sldIdLst>
         </p14:section>
-        <p14:section name="The visibility report" id="{5dda36f6-aa59-b648-bb8b-fadc0856c663}">
+        <p14:section name="The visibility report" id="{f6165aa1-aa15-6176-96fe-583225500903}">
           <p14:sldIdLst>
             <p14:sldId id="263"/>
           </p14:sldIdLst>
         </p14:section>
-        <p14:section name="The proposal" id="{f715338a-5bd7-82c4-3c5f-fc8150f012a6}">
+        <p14:section name="The proposal" id="{dd1f0347-5f57-3449-8350-29d684f4ca99}">
           <p14:sldIdLst>
             <p14:sldId id="264"/>
           </p14:sldIdLst>
         </p14:section>
-        <p14:section name="Proof" id="{6149dafd-314a-ad9b-edce-93772ad636da}">
+        <p14:section name="Proof" id="{d67804b5-9706-a2a1-cc2e-119bf0c6f9b1}">
           <p14:sldIdLst>
             <p14:sldId id="265"/>
           </p14:sldIdLst>
         </p14:section>
-        <p14:section name="The ask" id="{1f219f9a-85e9-adac-4f90-dd4e91e6f4aa}">
+        <p14:section name="The ask" id="{5c094c9b-ca54-cf73-1f1a-d67fcbca994a}">
           <p14:sldIdLst>
             <p14:sldId id="266"/>
           </p14:sldIdLst>
         </p14:section>
-        <p14:section name="Appendix" id="{9394e37a-130a-0729-3c1f-061fea9af12c}">
+        <p14:section name="Appendix" id="{17e873f7-0897-60f2-1852-3d6b24924842}">
           <p14:sldIdLst>
             <p14:sldId id="267"/>
           </p14:sldIdLst>
@@ -570,7 +570,7 @@
           <a:p>
             <a:r>
               <a:rPr lang="en-US" dirty="0"/>
-              <a:t>Thank the Mother Africa team for the time. This proposal is about one thing: making the visibility that creators bring to the festival provable, so the festival can show it to sponsors. Everything on the next slide comes from the festival’s own posters and press material, so ask the team to correct anything we have wrong.</a:t>
+              <a:t>Thank the Mother Africa team for the time. This proposal is about one thing: making the visibility that creators bring to the festival provable, so the festival can show it to sponsors. Everything on the next slide comes from the festival’s own posters and press material, so ask the team to correct anything we have wrong. The pictures on the cover and on slides 5, 6 and 9 are illustrations, not photographs of the festival.</a:t>
             </a:r>
             <a:endParaRPr lang="en-US" dirty="0"/>
           </a:p>
@@ -1274,7 +1274,7 @@
           <a:p>
             <a:r>
               <a:rPr lang="en-US" dirty="0"/>
-              <a:t>Visibility comes in three waves. The build up runs about five weeks and has one job: sell tickets. The two festival nights are about live reach, making people who are not there wish they were. The afterglow keeps Mother Africa in feeds into January and gives sponsors content to point to. If the festival plans a 2027 announcement, the afterglow is where it lands.</a:t>
+              <a:t>Visibility comes in three waves. The build up runs about five weeks and has one job: sell tickets. The two festival nights are about live reach, making people who are not there wish they were. The afterglow keeps Mother Africa in feeds into January and gives sponsors content to point to. If the festival plans a 2027 announcement, the afterglow is where it lands. Every wave sits in one content calendar, approved by the festival before anything goes live. The pictures are illustrations.</a:t>
             </a:r>
             <a:endParaRPr lang="en-US" dirty="0"/>
           </a:p>
@@ -1693,7 +1693,7 @@
         <p:spPr>
           <a:xfrm>
             <a:off x="548640" y="2377440"/>
-            <a:ext cx="6949440" cy="1600200"/>
+            <a:ext cx="4846320" cy="1600200"/>
           </a:xfrm>
           <a:prstGeom prst="rect">
             <a:avLst/>
@@ -1709,7 +1709,7 @@
                 <a:spcPct val="95000"/>
               </a:lnSpc>
               <a:buNone/>
-              <a:defRPr lang="en-US" sz="5000" dirty="0">
+              <a:defRPr lang="en-US" sz="4600" dirty="0">
                 <a:solidFill>
                   <a:schemeClr val="bg1"/>
                 </a:solidFill>
@@ -1723,7 +1723,7 @@
               </a:lnSpc>
               <a:buNone/>
             </a:pPr>
-            <a:endParaRPr lang="en-US" sz="5000" dirty="0"/>
+            <a:endParaRPr lang="en-US" sz="4600" dirty="0"/>
           </a:p>
         </p:txBody>
       </p:sp>
@@ -3034,7 +3034,7 @@
       </p:grpSpPr>
       <p:pic>
         <p:nvPicPr>
-          <p:cNvPr id="2" name="Background stripes" descr="/home/user/Mother-Africa/proposition-deck/build/assets/stripes.png">    </p:cNvPr>
+          <p:cNvPr id="2" name="Photo ai_phone" descr="Illustration: a festival goer films the stage on her phone, among a crowd of raised phones">    </p:cNvPr>
           <p:cNvPicPr>
             <a:picLocks noChangeAspect="1"/>
           </p:cNvPicPr>
@@ -3048,39 +3048,17 @@
         </p:blipFill>
         <p:spPr>
           <a:xfrm>
-            <a:off x="0" y="0"/>
-            <a:ext cx="12191695" cy="6858000"/>
+            <a:off x="0" y="-634898"/>
+            <a:ext cx="12191695" cy="8127797"/>
           </a:xfrm>
           <a:prstGeom prst="rect">
             <a:avLst/>
           </a:prstGeom>
         </p:spPr>
       </p:pic>
-      <p:sp>
-        <p:nvSpPr>
-          <p:cNvPr id="3" name="Shape 0"/>
-          <p:cNvSpPr/>
-          <p:nvPr/>
-        </p:nvSpPr>
-        <p:spPr>
-          <a:xfrm>
-            <a:off x="8362372" y="1472184"/>
-            <a:ext cx="3134380" cy="4206240"/>
-          </a:xfrm>
-          <a:prstGeom prst="rect">
-            <a:avLst/>
-          </a:prstGeom>
-          <a:ln w="15875">
-            <a:solidFill>
-              <a:schemeClr val="accent1"/>
-            </a:solidFill>
-            <a:prstDash val="solid"/>
-          </a:ln>
-        </p:spPr>
-      </p:sp>
       <p:pic>
         <p:nvPicPr>
-          <p:cNvPr id="4" name="Photo poster2026" descr="Mother Africa Festival 2026 poster: Davido, 27 and 28 December, Marcory Zone 4, Abidjan, 5th edition anniversary">    </p:cNvPr>
+          <p:cNvPr id="3" name="Fade overlay" descr="preencoded.png">    </p:cNvPr>
           <p:cNvPicPr>
             <a:picLocks noChangeAspect="1"/>
           </p:cNvPicPr>
@@ -3094,152 +3072,17 @@
         </p:blipFill>
         <p:spPr>
           <a:xfrm>
-            <a:off x="8508676" y="1325880"/>
-            <a:ext cx="3134380" cy="4206240"/>
+            <a:off x="0" y="0"/>
+            <a:ext cx="6949440" cy="6858000"/>
           </a:xfrm>
           <a:prstGeom prst="rect">
             <a:avLst/>
           </a:prstGeom>
         </p:spPr>
       </p:pic>
-      <p:sp>
-        <p:nvSpPr>
-          <p:cNvPr id="5" name="Text 0"/>
-          <p:cNvSpPr/>
-          <p:nvPr>
-            <p:ph idx="100" type="title" hasCustomPrompt="1"/>
-          </p:nvPr>
-        </p:nvSpPr>
-        <p:spPr>
-          <a:xfrm>
-            <a:off x="548640" y="2377440"/>
-            <a:ext cx="6949440" cy="1600200"/>
-          </a:xfrm>
-          <a:prstGeom prst="rect">
-            <a:avLst/>
-          </a:prstGeom>
-          <a:noFill/>
-          <a:ln/>
-        </p:spPr>
-        <p:txBody>
-          <a:bodyPr wrap="square" lIns="0" tIns="0" rIns="0" bIns="0" rtlCol="0" anchor="t"/>
-          <a:lstStyle/>
-          <a:p>
-            <a:pPr algn="l" indent="0" marL="0">
-              <a:lnSpc>
-                <a:spcPct val="95000"/>
-              </a:lnSpc>
-              <a:buNone/>
-            </a:pPr>
-            <a:r>
-              <a:rPr lang="en-GB" altLang="en-US" sz="5000" dirty="0">
-                <a:solidFill>
-                  <a:schemeClr val="bg1"/>
-                </a:solidFill>
-              </a:rPr>
-              <a:t>Maximising Mother Africa visibility</a:t>
-            </a:r>
-            <a:endParaRPr lang="en-GB" sz="5000" dirty="0"/>
-          </a:p>
-        </p:txBody>
-      </p:sp>
-      <p:sp>
-        <p:nvSpPr>
-          <p:cNvPr id="6" name="Text 0"/>
-          <p:cNvSpPr/>
-          <p:nvPr>
-            <p:ph idx="101" type="body" hasCustomPrompt="1"/>
-          </p:nvPr>
-        </p:nvSpPr>
-        <p:spPr>
-          <a:xfrm>
-            <a:off x="548640" y="4206240"/>
-            <a:ext cx="5760720" cy="1371600"/>
-          </a:xfrm>
-          <a:prstGeom prst="rect">
-            <a:avLst/>
-          </a:prstGeom>
-          <a:noFill/>
-          <a:ln/>
-        </p:spPr>
-        <p:txBody>
-          <a:bodyPr wrap="square" lIns="0" tIns="0" rIns="0" bIns="0" rtlCol="0" anchor="t"/>
-          <a:lstStyle/>
-          <a:p>
-            <a:pPr algn="l" indent="0" marL="0">
-              <a:lnSpc>
-                <a:spcPct val="115000"/>
-              </a:lnSpc>
-              <a:buNone/>
-            </a:pPr>
-            <a:r>
-              <a:rPr lang="en-GB" altLang="en-US" sz="1600" dirty="0">
-                <a:solidFill>
-                  <a:schemeClr val="accent5"/>
-                </a:solidFill>
-              </a:rPr>
-              <a:t>A proposal for the 5th edition of Mother Africa Festival: talent access, creator management on the ground and one visibility report.</a:t>
-            </a:r>
-            <a:endParaRPr lang="en-GB" sz="1600" dirty="0"/>
-          </a:p>
-          <a:p>
-            <a:pPr algn="l" indent="0" marL="0">
-              <a:lnSpc>
-                <a:spcPct val="115000"/>
-              </a:lnSpc>
-              <a:buNone/>
-            </a:pPr>
-            <a:r>
-              <a:rPr lang="en-GB" altLang="en-US" sz="1600" dirty="0">
-                <a:solidFill>
-                  <a:schemeClr val="accent5"/>
-                </a:solidFill>
-              </a:rPr>
-              <a:t>27 and 28 December 2026, Marcory Zone 4, Abidjan.</a:t>
-            </a:r>
-            <a:endParaRPr lang="en-GB" sz="1600" dirty="0"/>
-          </a:p>
-        </p:txBody>
-      </p:sp>
-      <p:sp>
-        <p:nvSpPr>
-          <p:cNvPr id="8" name="Text 3"/>
-          <p:cNvSpPr txBox="1"/>
-          <p:nvPr/>
-        </p:nvSpPr>
-        <p:spPr>
-          <a:xfrm>
-            <a:off x="548640" y="411480"/>
-            <a:ext cx="3657600" cy="237744"/>
-          </a:xfrm>
-          <a:prstGeom prst="rect">
-            <a:avLst/>
-          </a:prstGeom>
-          <a:noFill/>
-          <a:ln/>
-        </p:spPr>
-        <p:txBody>
-          <a:bodyPr wrap="square" lIns="0" tIns="0" rIns="0" bIns="0" rtlCol="0" anchor="t"/>
-          <a:lstStyle/>
-          <a:p>
-            <a:pPr indent="0" marL="0">
-              <a:buNone/>
-            </a:pPr>
-            <a:r>
-              <a:rPr lang="en-GB" altLang="en-US" sz="1000" dirty="0">
-                <a:solidFill>
-                  <a:schemeClr val="accent5"/>
-                </a:solidFill>
-              </a:rPr>
-              <a:t>atoureconsulting.com</a:t>
-            </a:r>
-            <a:endParaRPr lang="en-GB" sz="1000" dirty="0"/>
-          </a:p>
-        </p:txBody>
-      </p:sp>
       <p:pic>
         <p:nvPicPr>
-          <p:cNvPr id="9" name="Image 2" descr="AToure Management &amp; Consulting">    </p:cNvPr>
+          <p:cNvPr id="4" name="Fade overlay" descr="preencoded.png">    </p:cNvPr>
           <p:cNvPicPr>
             <a:picLocks noChangeAspect="1"/>
           </p:cNvPicPr>
@@ -3253,8 +3096,8 @@
         </p:blipFill>
         <p:spPr>
           <a:xfrm>
-            <a:off x="548640" y="1371600"/>
-            <a:ext cx="2377440" cy="380390"/>
+            <a:off x="0" y="4846320"/>
+            <a:ext cx="12191695" cy="2011680"/>
           </a:xfrm>
           <a:prstGeom prst="rect">
             <a:avLst/>
@@ -3263,43 +3106,84 @@
       </p:pic>
       <p:sp>
         <p:nvSpPr>
-          <p:cNvPr id="10" name="Text 4"/>
-          <p:cNvSpPr txBox="1"/>
-          <p:nvPr/>
-        </p:nvSpPr>
-        <p:spPr>
-          <a:xfrm>
-            <a:off x="3017520" y="1261872"/>
-            <a:ext cx="365760" cy="365760"/>
-          </a:xfrm>
-          <a:prstGeom prst="rect">
-            <a:avLst/>
-          </a:prstGeom>
-          <a:noFill/>
-          <a:ln/>
-        </p:spPr>
-        <p:txBody>
-          <a:bodyPr wrap="square" lIns="0" tIns="0" rIns="0" bIns="0" rtlCol="0" anchor="ctr"/>
-          <a:lstStyle/>
-          <a:p>
-            <a:pPr algn="ctr" indent="0" marL="0">
-              <a:buNone/>
-            </a:pPr>
-            <a:r>
-              <a:rPr lang="en-GB" altLang="en-US" sz="2000" dirty="0">
-                <a:solidFill>
-                  <a:schemeClr val="accent1"/>
-                </a:solidFill>
-              </a:rPr>
-              <a:t>×</a:t>
-            </a:r>
-            <a:endParaRPr lang="en-GB" sz="2000" dirty="0"/>
+          <p:cNvPr id="5" name="Text 0"/>
+          <p:cNvSpPr/>
+          <p:nvPr>
+            <p:ph idx="100" type="title" hasCustomPrompt="1"/>
+          </p:nvPr>
+        </p:nvSpPr>
+        <p:spPr>
+          <a:xfrm>
+            <a:off x="548640" y="2377440"/>
+            <a:ext cx="4846320" cy="1600200"/>
+          </a:xfrm>
+          <a:prstGeom prst="rect">
+            <a:avLst/>
+          </a:prstGeom>
+          <a:noFill/>
+          <a:ln/>
+        </p:spPr>
+        <p:txBody>
+          <a:bodyPr wrap="square" lIns="0" tIns="0" rIns="0" bIns="0" rtlCol="0" anchor="t"/>
+          <a:lstStyle/>
+          <a:p>
+            <a:pPr algn="l" indent="0" marL="0">
+              <a:lnSpc>
+                <a:spcPct val="95000"/>
+              </a:lnSpc>
+              <a:buNone/>
+            </a:pPr>
+            <a:r>
+              <a:rPr lang="en-GB" altLang="en-US" sz="4600" dirty="0">
+                <a:solidFill>
+                  <a:schemeClr val="bg1"/>
+                </a:solidFill>
+              </a:rPr>
+              <a:t>Maximising Mother Africa visibility</a:t>
+            </a:r>
+            <a:endParaRPr lang="en-GB" sz="4600" dirty="0"/>
+          </a:p>
+        </p:txBody>
+      </p:sp>
+      <p:sp>
+        <p:nvSpPr>
+          <p:cNvPr id="7" name="Text 1"/>
+          <p:cNvSpPr txBox="1"/>
+          <p:nvPr/>
+        </p:nvSpPr>
+        <p:spPr>
+          <a:xfrm>
+            <a:off x="548640" y="411480"/>
+            <a:ext cx="3657600" cy="237744"/>
+          </a:xfrm>
+          <a:prstGeom prst="rect">
+            <a:avLst/>
+          </a:prstGeom>
+          <a:noFill/>
+          <a:ln/>
+        </p:spPr>
+        <p:txBody>
+          <a:bodyPr wrap="square" lIns="0" tIns="0" rIns="0" bIns="0" rtlCol="0" anchor="t"/>
+          <a:lstStyle/>
+          <a:p>
+            <a:pPr indent="0" marL="0">
+              <a:buNone/>
+            </a:pPr>
+            <a:r>
+              <a:rPr lang="en-GB" altLang="en-US" sz="1000" dirty="0">
+                <a:solidFill>
+                  <a:schemeClr val="accent5"/>
+                </a:solidFill>
+              </a:rPr>
+              <a:t>atoureconsulting.com</a:t>
+            </a:r>
+            <a:endParaRPr lang="en-GB" sz="1000" dirty="0"/>
           </a:p>
         </p:txBody>
       </p:sp>
       <p:pic>
         <p:nvPicPr>
-          <p:cNvPr id="11" name="Image 3" descr="Mother Africa Festival">    </p:cNvPr>
+          <p:cNvPr id="8" name="Image 3" descr="AToure Management &amp; Consulting">    </p:cNvPr>
           <p:cNvPicPr>
             <a:picLocks noChangeAspect="1"/>
           </p:cNvPicPr>
@@ -3313,6 +3197,66 @@
         </p:blipFill>
         <p:spPr>
           <a:xfrm>
+            <a:off x="548640" y="1371600"/>
+            <a:ext cx="2377440" cy="380390"/>
+          </a:xfrm>
+          <a:prstGeom prst="rect">
+            <a:avLst/>
+          </a:prstGeom>
+        </p:spPr>
+      </p:pic>
+      <p:sp>
+        <p:nvSpPr>
+          <p:cNvPr id="9" name="Text 2"/>
+          <p:cNvSpPr txBox="1"/>
+          <p:nvPr/>
+        </p:nvSpPr>
+        <p:spPr>
+          <a:xfrm>
+            <a:off x="3017520" y="1261872"/>
+            <a:ext cx="365760" cy="365760"/>
+          </a:xfrm>
+          <a:prstGeom prst="rect">
+            <a:avLst/>
+          </a:prstGeom>
+          <a:noFill/>
+          <a:ln/>
+        </p:spPr>
+        <p:txBody>
+          <a:bodyPr wrap="square" lIns="0" tIns="0" rIns="0" bIns="0" rtlCol="0" anchor="ctr"/>
+          <a:lstStyle/>
+          <a:p>
+            <a:pPr algn="ctr" indent="0" marL="0">
+              <a:buNone/>
+            </a:pPr>
+            <a:r>
+              <a:rPr lang="en-GB" altLang="en-US" sz="2000" dirty="0">
+                <a:solidFill>
+                  <a:schemeClr val="accent1"/>
+                </a:solidFill>
+              </a:rPr>
+              <a:t>×</a:t>
+            </a:r>
+            <a:endParaRPr lang="en-GB" sz="2000" dirty="0"/>
+          </a:p>
+        </p:txBody>
+      </p:sp>
+      <p:pic>
+        <p:nvPicPr>
+          <p:cNvPr id="10" name="Image 4" descr="Mother Africa Festival">    </p:cNvPr>
+          <p:cNvPicPr>
+            <a:picLocks noChangeAspect="1"/>
+          </p:cNvPicPr>
+          <p:nvPr/>
+        </p:nvPicPr>
+        <p:blipFill>
+          <a:blip r:embed="rId5"/>
+          <a:stretch>
+            <a:fillRect/>
+          </a:stretch>
+        </p:blipFill>
+        <p:spPr>
+          <a:xfrm>
             <a:off x="3474720" y="1005840"/>
             <a:ext cx="1224254" cy="868680"/>
           </a:xfrm>
@@ -3323,7 +3267,82 @@
       </p:pic>
       <p:sp>
         <p:nvSpPr>
-          <p:cNvPr id="12" name="Shape 5"/>
+          <p:cNvPr id="11" name="Text 3"/>
+          <p:cNvSpPr txBox="1"/>
+          <p:nvPr/>
+        </p:nvSpPr>
+        <p:spPr>
+          <a:xfrm>
+            <a:off x="548640" y="4224528"/>
+            <a:ext cx="4480560" cy="868680"/>
+          </a:xfrm>
+          <a:prstGeom prst="rect">
+            <a:avLst/>
+          </a:prstGeom>
+          <a:noFill/>
+          <a:ln/>
+        </p:spPr>
+        <p:txBody>
+          <a:bodyPr wrap="square" lIns="0" tIns="0" rIns="0" bIns="0" rtlCol="0" anchor="t"/>
+          <a:lstStyle/>
+          <a:p>
+            <a:pPr indent="0" marL="0">
+              <a:lnSpc>
+                <a:spcPct val="115000"/>
+              </a:lnSpc>
+              <a:buNone/>
+            </a:pPr>
+            <a:r>
+              <a:rPr lang="en-GB" altLang="en-US" sz="1500" dirty="0">
+                <a:solidFill>
+                  <a:schemeClr val="bg1"/>
+                </a:solidFill>
+              </a:rPr>
+              <a:t>A proposal for the 5th edition of Mother Africa Festival: talent access, creator management on the ground and one visibility report.</a:t>
+            </a:r>
+            <a:endParaRPr lang="en-GB" sz="1500" dirty="0"/>
+          </a:p>
+        </p:txBody>
+      </p:sp>
+      <p:sp>
+        <p:nvSpPr>
+          <p:cNvPr id="12" name="Text 4"/>
+          <p:cNvSpPr txBox="1"/>
+          <p:nvPr/>
+        </p:nvSpPr>
+        <p:spPr>
+          <a:xfrm>
+            <a:off x="548640" y="5138928"/>
+            <a:ext cx="4480560" cy="274320"/>
+          </a:xfrm>
+          <a:prstGeom prst="rect">
+            <a:avLst/>
+          </a:prstGeom>
+          <a:noFill/>
+          <a:ln/>
+        </p:spPr>
+        <p:txBody>
+          <a:bodyPr wrap="square" lIns="0" tIns="0" rIns="0" bIns="0" rtlCol="0" anchor="t"/>
+          <a:lstStyle/>
+          <a:p>
+            <a:pPr indent="0" marL="0">
+              <a:buNone/>
+            </a:pPr>
+            <a:r>
+              <a:rPr lang="en-GB" altLang="en-US" sz="1500" b="1" dirty="0">
+                <a:solidFill>
+                  <a:schemeClr val="accent4"/>
+                </a:solidFill>
+              </a:rPr>
+              <a:t>27 and 28 December 2026, Marcory Zone 4, Abidjan.</a:t>
+            </a:r>
+            <a:endParaRPr lang="en-GB" sz="1500" dirty="0"/>
+          </a:p>
+        </p:txBody>
+      </p:sp>
+      <p:sp>
+        <p:nvSpPr>
+          <p:cNvPr id="13" name="Shape 5"/>
           <p:cNvSpPr/>
           <p:nvPr/>
         </p:nvSpPr>
@@ -3346,7 +3365,7 @@
       </p:sp>
       <p:sp>
         <p:nvSpPr>
-          <p:cNvPr id="13" name="Text 6"/>
+          <p:cNvPr id="14" name="Text 6"/>
           <p:cNvSpPr txBox="1"/>
           <p:nvPr/>
         </p:nvSpPr>
@@ -3377,6 +3396,39 @@
               <a:t>Prepared by Baba Touré, Director  ·  30.10.2026</a:t>
             </a:r>
             <a:endParaRPr lang="en-GB" sz="1200" dirty="0"/>
+          </a:p>
+        </p:txBody>
+      </p:sp>
+      <p:sp>
+        <p:nvSpPr>
+          <p:cNvPr id="15" name="Text 0"/>
+          <p:cNvSpPr/>
+          <p:nvPr>
+            <p:ph idx="101" type="body" hasCustomPrompt="1"/>
+          </p:nvPr>
+        </p:nvSpPr>
+        <p:spPr>
+          <a:xfrm>
+            <a:off x="548640" y="4206240"/>
+            <a:ext cx="5760720" cy="1371600"/>
+          </a:xfrm>
+          <a:prstGeom prst="rect">
+            <a:avLst/>
+          </a:prstGeom>
+          <a:noFill/>
+          <a:ln/>
+        </p:spPr>
+        <p:txBody>
+          <a:bodyPr wrap="square" lIns="0" tIns="0" rIns="0" bIns="0" rtlCol="0" anchor="t"/>
+          <a:lstStyle/>
+          <a:p>
+            <a:pPr algn="l" indent="0" marL="0">
+              <a:lnSpc>
+                <a:spcPct val="115000"/>
+              </a:lnSpc>
+              <a:buNone/>
+            </a:pPr>
+            <a:endParaRPr lang="en-US" sz="1600" dirty="0"/>
           </a:p>
         </p:txBody>
       </p:sp>
@@ -14894,7 +14946,7 @@
         <p:spPr>
           <a:xfrm>
             <a:off x="548640" y="4709160"/>
-            <a:ext cx="5486400" cy="1463040"/>
+            <a:ext cx="4572000" cy="1463040"/>
           </a:xfrm>
           <a:prstGeom prst="roundRect">
             <a:avLst>
@@ -14916,7 +14968,7 @@
         <p:spPr>
           <a:xfrm>
             <a:off x="822960" y="4846320"/>
-            <a:ext cx="4572000" cy="256032"/>
+            <a:ext cx="4023360" cy="256032"/>
           </a:xfrm>
           <a:prstGeom prst="rect">
             <a:avLst/>
@@ -14952,7 +15004,7 @@
         <p:spPr>
           <a:xfrm>
             <a:off x="822960" y="5138928"/>
-            <a:ext cx="5029200" cy="548640"/>
+            <a:ext cx="4160520" cy="548640"/>
           </a:xfrm>
           <a:prstGeom prst="rect">
             <a:avLst/>
@@ -14972,14 +15024,14 @@
               <a:buChar char="•"/>
             </a:pPr>
             <a:r>
-              <a:rPr lang="en-GB" altLang="en-US" sz="1300" dirty="0">
+              <a:rPr lang="en-GB" altLang="en-US" sz="1200" dirty="0">
                 <a:solidFill>
                   <a:schemeClr val="bg1"/>
                 </a:solidFill>
               </a:rPr>
-              <a:t>Every creator checked against the brief within 48 hours</a:t>
-            </a:r>
-            <a:endParaRPr lang="en-GB" sz="1300" dirty="0"/>
+              <a:t>Every creator checked against the brief in 48 hours</a:t>
+            </a:r>
+            <a:endParaRPr lang="en-GB" sz="1200" dirty="0"/>
           </a:p>
           <a:p>
             <a:pPr marL="177800" indent="-177800">
@@ -14990,14 +15042,14 @@
               <a:buChar char="•"/>
             </a:pPr>
             <a:r>
-              <a:rPr lang="en-GB" altLang="en-US" sz="1300" dirty="0">
+              <a:rPr lang="en-GB" altLang="en-US" sz="1200" dirty="0">
                 <a:solidFill>
                   <a:schemeClr val="bg1"/>
                 </a:solidFill>
               </a:rPr>
-              <a:t>Analytics collected by screen recording, not screenshots</a:t>
-            </a:r>
-            <a:endParaRPr lang="en-GB" sz="1300" dirty="0"/>
+              <a:t>Analytics collected by screen recording</a:t>
+            </a:r>
+            <a:endParaRPr lang="en-GB" sz="1200" dirty="0"/>
           </a:p>
         </p:txBody>
       </p:sp>
@@ -15039,7 +15091,7 @@
       </p:sp>
       <p:pic>
         <p:nvPicPr>
-          <p:cNvPr id="46" name="Image 2" descr="preencoded.png">    </p:cNvPr>
+          <p:cNvPr id="46" name="Photo ai_briefing" descr="Illustration: a production manager briefs creators with a tablet backstage before the doors open">    </p:cNvPr>
           <p:cNvPicPr>
             <a:picLocks noChangeAspect="1"/>
           </p:cNvPicPr>
@@ -15053,53 +15105,17 @@
         </p:blipFill>
         <p:spPr>
           <a:xfrm>
-            <a:off x="6355080" y="4818888"/>
-            <a:ext cx="274320" cy="274320"/>
+            <a:off x="5394960" y="4709160"/>
+            <a:ext cx="2599578" cy="1463040"/>
           </a:xfrm>
           <a:prstGeom prst="rect">
             <a:avLst/>
           </a:prstGeom>
         </p:spPr>
       </p:pic>
-      <p:sp>
-        <p:nvSpPr>
-          <p:cNvPr id="47" name="Text 41"/>
-          <p:cNvSpPr txBox="1"/>
-          <p:nvPr/>
-        </p:nvSpPr>
-        <p:spPr>
-          <a:xfrm>
-            <a:off x="6766560" y="4800600"/>
-            <a:ext cx="4846320" cy="365760"/>
-          </a:xfrm>
-          <a:prstGeom prst="rect">
-            <a:avLst/>
-          </a:prstGeom>
-          <a:noFill/>
-          <a:ln/>
-        </p:spPr>
-        <p:txBody>
-          <a:bodyPr wrap="square" lIns="0" tIns="0" rIns="0" bIns="0" rtlCol="0" anchor="t"/>
-          <a:lstStyle/>
-          <a:p>
-            <a:pPr indent="0" marL="0">
-              <a:buNone/>
-            </a:pPr>
-            <a:r>
-              <a:rPr lang="en-GB" altLang="en-US" sz="1400" dirty="0">
-                <a:solidFill>
-                  <a:schemeClr val="tx1"/>
-                </a:solidFill>
-              </a:rPr>
-              <a:t>One point of contact for the festival team</a:t>
-            </a:r>
-            <a:endParaRPr lang="en-GB" sz="1400" dirty="0"/>
-          </a:p>
-        </p:txBody>
-      </p:sp>
       <p:pic>
         <p:nvPicPr>
-          <p:cNvPr id="48" name="Image 3" descr="preencoded.png">    </p:cNvPr>
+          <p:cNvPr id="47" name="Image 3" descr="preencoded.png">    </p:cNvPr>
           <p:cNvPicPr>
             <a:picLocks noChangeAspect="1"/>
           </p:cNvPicPr>
@@ -15113,8 +15129,8 @@
         </p:blipFill>
         <p:spPr>
           <a:xfrm>
-            <a:off x="6355080" y="5294376"/>
-            <a:ext cx="274320" cy="274320"/>
+            <a:off x="8268858" y="4727448"/>
+            <a:ext cx="256032" cy="256032"/>
           </a:xfrm>
           <a:prstGeom prst="rect">
             <a:avLst/>
@@ -15123,14 +15139,14 @@
       </p:pic>
       <p:sp>
         <p:nvSpPr>
-          <p:cNvPr id="49" name="Text 42"/>
-          <p:cNvSpPr txBox="1"/>
-          <p:nvPr/>
-        </p:nvSpPr>
-        <p:spPr>
-          <a:xfrm>
-            <a:off x="6766560" y="5276088"/>
-            <a:ext cx="4846320" cy="365760"/>
+          <p:cNvPr id="48" name="Text 41"/>
+          <p:cNvSpPr txBox="1"/>
+          <p:nvPr/>
+        </p:nvSpPr>
+        <p:spPr>
+          <a:xfrm>
+            <a:off x="8634618" y="4709160"/>
+            <a:ext cx="3008437" cy="438912"/>
           </a:xfrm>
           <a:prstGeom prst="rect">
             <a:avLst/>
@@ -15146,20 +15162,20 @@
               <a:buNone/>
             </a:pPr>
             <a:r>
-              <a:rPr lang="en-GB" altLang="en-US" sz="1400" dirty="0">
+              <a:rPr lang="en-GB" altLang="en-US" sz="1250" dirty="0">
                 <a:solidFill>
                   <a:schemeClr val="tx1"/>
                 </a:solidFill>
               </a:rPr>
-              <a:t>A shared tracker of every creator and every post</a:t>
-            </a:r>
-            <a:endParaRPr lang="en-GB" sz="1400" dirty="0"/>
+              <a:t>One point of contact for the festival team</a:t>
+            </a:r>
+            <a:endParaRPr lang="en-GB" sz="1250" dirty="0"/>
           </a:p>
         </p:txBody>
       </p:sp>
       <p:pic>
         <p:nvPicPr>
-          <p:cNvPr id="50" name="Image 4" descr="preencoded.png">    </p:cNvPr>
+          <p:cNvPr id="49" name="Image 4" descr="preencoded.png">    </p:cNvPr>
           <p:cNvPicPr>
             <a:picLocks noChangeAspect="1"/>
           </p:cNvPicPr>
@@ -15173,8 +15189,8 @@
         </p:blipFill>
         <p:spPr>
           <a:xfrm>
-            <a:off x="6355080" y="5769864"/>
-            <a:ext cx="274320" cy="274320"/>
+            <a:off x="8268858" y="5230368"/>
+            <a:ext cx="256032" cy="256032"/>
           </a:xfrm>
           <a:prstGeom prst="rect">
             <a:avLst/>
@@ -15183,14 +15199,14 @@
       </p:pic>
       <p:sp>
         <p:nvSpPr>
-          <p:cNvPr id="51" name="Text 43"/>
-          <p:cNvSpPr txBox="1"/>
-          <p:nvPr/>
-        </p:nvSpPr>
-        <p:spPr>
-          <a:xfrm>
-            <a:off x="6766560" y="5751576"/>
-            <a:ext cx="4846320" cy="365760"/>
+          <p:cNvPr id="50" name="Text 42"/>
+          <p:cNvSpPr txBox="1"/>
+          <p:nvPr/>
+        </p:nvSpPr>
+        <p:spPr>
+          <a:xfrm>
+            <a:off x="8634618" y="5212080"/>
+            <a:ext cx="3008437" cy="438912"/>
           </a:xfrm>
           <a:prstGeom prst="rect">
             <a:avLst/>
@@ -15206,14 +15222,74 @@
               <a:buNone/>
             </a:pPr>
             <a:r>
-              <a:rPr lang="en-GB" altLang="en-US" sz="1400" dirty="0">
+              <a:rPr lang="en-GB" altLang="en-US" sz="1250" dirty="0">
                 <a:solidFill>
                   <a:schemeClr val="tx1"/>
                 </a:solidFill>
               </a:rPr>
+              <a:t>A shared tracker of every creator and every post</a:t>
+            </a:r>
+            <a:endParaRPr lang="en-GB" sz="1250" dirty="0"/>
+          </a:p>
+        </p:txBody>
+      </p:sp>
+      <p:pic>
+        <p:nvPicPr>
+          <p:cNvPr id="51" name="Image 5" descr="preencoded.png">    </p:cNvPr>
+          <p:cNvPicPr>
+            <a:picLocks noChangeAspect="1"/>
+          </p:cNvPicPr>
+          <p:nvPr/>
+        </p:nvPicPr>
+        <p:blipFill>
+          <a:blip r:embed="rId6"/>
+          <a:stretch>
+            <a:fillRect/>
+          </a:stretch>
+        </p:blipFill>
+        <p:spPr>
+          <a:xfrm>
+            <a:off x="8268858" y="5733288"/>
+            <a:ext cx="256032" cy="256032"/>
+          </a:xfrm>
+          <a:prstGeom prst="rect">
+            <a:avLst/>
+          </a:prstGeom>
+        </p:spPr>
+      </p:pic>
+      <p:sp>
+        <p:nvSpPr>
+          <p:cNvPr id="52" name="Text 43"/>
+          <p:cNvSpPr txBox="1"/>
+          <p:nvPr/>
+        </p:nvSpPr>
+        <p:spPr>
+          <a:xfrm>
+            <a:off x="8634618" y="5715000"/>
+            <a:ext cx="3008437" cy="438912"/>
+          </a:xfrm>
+          <a:prstGeom prst="rect">
+            <a:avLst/>
+          </a:prstGeom>
+          <a:noFill/>
+          <a:ln/>
+        </p:spPr>
+        <p:txBody>
+          <a:bodyPr wrap="square" lIns="0" tIns="0" rIns="0" bIns="0" rtlCol="0" anchor="t"/>
+          <a:lstStyle/>
+          <a:p>
+            <a:pPr indent="0" marL="0">
+              <a:buNone/>
+            </a:pPr>
+            <a:r>
+              <a:rPr lang="en-GB" altLang="en-US" sz="1250" dirty="0">
+                <a:solidFill>
+                  <a:schemeClr val="tx1"/>
+                </a:solidFill>
+              </a:rPr>
               <a:t>Brand safety rules agreed with you before anyone posts</a:t>
             </a:r>
-            <a:endParaRPr lang="en-GB" sz="1400" dirty="0"/>
+            <a:endParaRPr lang="en-GB" sz="1250" dirty="0"/>
           </a:p>
         </p:txBody>
       </p:sp>
@@ -15558,12 +15634,12 @@
         </p:nvSpPr>
         <p:spPr>
           <a:xfrm>
-            <a:off x="548640" y="2286000"/>
-            <a:ext cx="4218127" cy="2971800"/>
+            <a:off x="548640" y="2240280"/>
+            <a:ext cx="4218127" cy="3931920"/>
           </a:xfrm>
           <a:prstGeom prst="roundRect">
             <a:avLst>
-              <a:gd name="adj" fmla="val 3077"/>
+              <a:gd name="adj" fmla="val 2326"/>
             </a:avLst>
           </a:prstGeom>
           <a:solidFill>
@@ -15572,15 +15648,39 @@
           <a:ln/>
         </p:spPr>
       </p:sp>
-      <p:sp>
-        <p:nvSpPr>
-          <p:cNvPr id="13" name="Text 7"/>
-          <p:cNvSpPr txBox="1"/>
-          <p:nvPr/>
-        </p:nvSpPr>
-        <p:spPr>
-          <a:xfrm>
-            <a:off x="822960" y="2542032"/>
+      <p:pic>
+        <p:nvPicPr>
+          <p:cNvPr id="13" name="Photo ai_grwm" descr="Illustration: a creator records a get ready with me video before the festival">    </p:cNvPr>
+          <p:cNvPicPr>
+            <a:picLocks noChangeAspect="1"/>
+          </p:cNvPicPr>
+          <p:nvPr/>
+        </p:nvPicPr>
+        <p:blipFill>
+          <a:blip r:embed="rId4"/>
+          <a:stretch>
+            <a:fillRect/>
+          </a:stretch>
+        </p:blipFill>
+        <p:spPr>
+          <a:xfrm>
+            <a:off x="822960" y="2487168"/>
+            <a:ext cx="1783080" cy="1188720"/>
+          </a:xfrm>
+          <a:prstGeom prst="rect">
+            <a:avLst/>
+          </a:prstGeom>
+        </p:spPr>
+      </p:pic>
+      <p:sp>
+        <p:nvSpPr>
+          <p:cNvPr id="14" name="Text 7"/>
+          <p:cNvSpPr txBox="1"/>
+          <p:nvPr/>
+        </p:nvSpPr>
+        <p:spPr>
+          <a:xfrm>
+            <a:off x="822960" y="3822192"/>
             <a:ext cx="3669487" cy="256032"/>
           </a:xfrm>
           <a:prstGeom prst="rect">
@@ -15610,14 +15710,14 @@
       </p:sp>
       <p:sp>
         <p:nvSpPr>
-          <p:cNvPr id="14" name="Text 8"/>
-          <p:cNvSpPr txBox="1"/>
-          <p:nvPr/>
-        </p:nvSpPr>
-        <p:spPr>
-          <a:xfrm>
-            <a:off x="822960" y="2852928"/>
-            <a:ext cx="3669487" cy="457200"/>
+          <p:cNvPr id="15" name="Text 8"/>
+          <p:cNvSpPr txBox="1"/>
+          <p:nvPr/>
+        </p:nvSpPr>
+        <p:spPr>
+          <a:xfrm>
+            <a:off x="822960" y="4069080"/>
+            <a:ext cx="3669487" cy="411480"/>
           </a:xfrm>
           <a:prstGeom prst="rect">
             <a:avLst/>
@@ -15633,7 +15733,7 @@
               <a:buNone/>
             </a:pPr>
             <a:r>
-              <a:rPr lang="en-GB" altLang="en-US" sz="2600" dirty="0">
+              <a:rPr lang="en-GB" altLang="en-US" sz="2400" dirty="0">
                 <a:solidFill>
                   <a:schemeClr val="bg1"/>
                 </a:solidFill>
@@ -15643,20 +15743,20 @@
               </a:rPr>
               <a:t>Build up</a:t>
             </a:r>
-            <a:endParaRPr lang="en-GB" sz="2600" dirty="0"/>
-          </a:p>
-        </p:txBody>
-      </p:sp>
-      <p:sp>
-        <p:nvSpPr>
-          <p:cNvPr id="15" name="Text 9"/>
-          <p:cNvSpPr txBox="1"/>
-          <p:nvPr/>
-        </p:nvSpPr>
-        <p:spPr>
-          <a:xfrm>
-            <a:off x="822960" y="3383280"/>
-            <a:ext cx="3669487" cy="320040"/>
+            <a:endParaRPr lang="en-GB" sz="2400" dirty="0"/>
+          </a:p>
+        </p:txBody>
+      </p:sp>
+      <p:sp>
+        <p:nvSpPr>
+          <p:cNvPr id="16" name="Text 9"/>
+          <p:cNvSpPr txBox="1"/>
+          <p:nvPr/>
+        </p:nvSpPr>
+        <p:spPr>
+          <a:xfrm>
+            <a:off x="822960" y="4526280"/>
+            <a:ext cx="3669487" cy="292608"/>
           </a:xfrm>
           <a:prstGeom prst="rect">
             <a:avLst/>
@@ -15672,27 +15772,27 @@
               <a:buNone/>
             </a:pPr>
             <a:r>
-              <a:rPr lang="en-GB" altLang="en-US" sz="1400" b="1" dirty="0">
+              <a:rPr lang="en-GB" altLang="en-US" sz="1300" b="1" dirty="0">
                 <a:solidFill>
                   <a:schemeClr val="accent4"/>
                 </a:solidFill>
               </a:rPr>
               <a:t>Goal: awareness and ticket sales</a:t>
             </a:r>
-            <a:endParaRPr lang="en-GB" sz="1400" dirty="0"/>
-          </a:p>
-        </p:txBody>
-      </p:sp>
-      <p:sp>
-        <p:nvSpPr>
-          <p:cNvPr id="16" name="Text 10"/>
-          <p:cNvSpPr txBox="1"/>
-          <p:nvPr/>
-        </p:nvSpPr>
-        <p:spPr>
-          <a:xfrm>
-            <a:off x="822960" y="3840480"/>
-            <a:ext cx="3669487" cy="1325880"/>
+            <a:endParaRPr lang="en-GB" sz="1300" dirty="0"/>
+          </a:p>
+        </p:txBody>
+      </p:sp>
+      <p:sp>
+        <p:nvSpPr>
+          <p:cNvPr id="17" name="Text 10"/>
+          <p:cNvSpPr txBox="1"/>
+          <p:nvPr/>
+        </p:nvSpPr>
+        <p:spPr>
+          <a:xfrm>
+            <a:off x="822960" y="4892040"/>
+            <a:ext cx="3669487" cy="1188720"/>
           </a:xfrm>
           <a:prstGeom prst="rect">
             <a:avLst/>
@@ -15706,80 +15806,80 @@
           <a:p>
             <a:pPr marL="177800" indent="-177800">
               <a:spcAft>
-                <a:spcPts val="600"/>
+                <a:spcPts val="400"/>
               </a:spcAft>
               <a:buSzPct val="100000"/>
               <a:buChar char="•"/>
             </a:pPr>
             <a:r>
-              <a:rPr lang="en-GB" altLang="en-US" sz="1300" dirty="0">
+              <a:rPr lang="en-GB" altLang="en-US" sz="1250" dirty="0">
                 <a:solidFill>
                   <a:schemeClr val="accent5"/>
                 </a:solidFill>
               </a:rPr>
               <a:t>Creator lineup announced</a:t>
             </a:r>
-            <a:endParaRPr lang="en-GB" sz="1300" dirty="0"/>
+            <a:endParaRPr lang="en-GB" sz="1250" dirty="0"/>
           </a:p>
           <a:p>
             <a:pPr marL="177800" indent="-177800">
               <a:spcAft>
-                <a:spcPts val="600"/>
+                <a:spcPts val="400"/>
               </a:spcAft>
               <a:buSzPct val="100000"/>
               <a:buChar char="•"/>
             </a:pPr>
             <a:r>
-              <a:rPr lang="en-GB" altLang="en-US" sz="1300" dirty="0">
+              <a:rPr lang="en-GB" altLang="en-US" sz="1250" dirty="0">
                 <a:solidFill>
                   <a:schemeClr val="accent5"/>
                 </a:solidFill>
               </a:rPr>
               <a:t>Davido countdown</a:t>
             </a:r>
-            <a:endParaRPr lang="en-GB" sz="1300" dirty="0"/>
+            <a:endParaRPr lang="en-GB" sz="1250" dirty="0"/>
           </a:p>
           <a:p>
             <a:pPr marL="177800" indent="-177800">
               <a:spcAft>
-                <a:spcPts val="600"/>
+                <a:spcPts val="400"/>
               </a:spcAft>
               <a:buSzPct val="100000"/>
               <a:buChar char="•"/>
             </a:pPr>
             <a:r>
-              <a:rPr lang="en-GB" altLang="en-US" sz="1300" dirty="0">
+              <a:rPr lang="en-GB" altLang="en-US" sz="1250" dirty="0">
                 <a:solidFill>
                   <a:schemeClr val="accent5"/>
                 </a:solidFill>
               </a:rPr>
               <a:t>Weekly ticket pushes with tracked links</a:t>
             </a:r>
-            <a:endParaRPr lang="en-GB" sz="1300" dirty="0"/>
+            <a:endParaRPr lang="en-GB" sz="1250" dirty="0"/>
           </a:p>
           <a:p>
             <a:pPr marL="177800" indent="-177800">
               <a:spcAft>
-                <a:spcPts val="600"/>
+                <a:spcPts val="400"/>
               </a:spcAft>
               <a:buSzPct val="100000"/>
               <a:buChar char="•"/>
             </a:pPr>
             <a:r>
-              <a:rPr lang="en-GB" altLang="en-US" sz="1300" dirty="0">
+              <a:rPr lang="en-GB" altLang="en-US" sz="1250" dirty="0">
                 <a:solidFill>
                   <a:schemeClr val="accent5"/>
                 </a:solidFill>
               </a:rPr>
               <a:t>A last call before Christmas</a:t>
             </a:r>
-            <a:endParaRPr lang="en-GB" sz="1300" dirty="0"/>
-          </a:p>
-        </p:txBody>
-      </p:sp>
-      <p:sp>
-        <p:nvSpPr>
-          <p:cNvPr id="17" name="Shape 11"/>
+            <a:endParaRPr lang="en-GB" sz="1250" dirty="0"/>
+          </a:p>
+        </p:txBody>
+      </p:sp>
+      <p:sp>
+        <p:nvSpPr>
+          <p:cNvPr id="18" name="Shape 11"/>
           <p:cNvSpPr/>
           <p:nvPr/>
         </p:nvSpPr>
@@ -15799,18 +15899,18 @@
       </p:sp>
       <p:sp>
         <p:nvSpPr>
-          <p:cNvPr id="18" name="Shape 12"/>
+          <p:cNvPr id="19" name="Shape 12"/>
           <p:cNvSpPr/>
           <p:nvPr/>
         </p:nvSpPr>
         <p:spPr>
           <a:xfrm>
-            <a:off x="5041087" y="2286000"/>
-            <a:ext cx="3163824" cy="2971800"/>
+            <a:off x="5041087" y="2240280"/>
+            <a:ext cx="3163824" cy="3931920"/>
           </a:xfrm>
           <a:prstGeom prst="roundRect">
             <a:avLst>
-              <a:gd name="adj" fmla="val 3077"/>
+              <a:gd name="adj" fmla="val 2890"/>
             </a:avLst>
           </a:prstGeom>
           <a:solidFill>
@@ -15819,15 +15919,39 @@
           <a:ln/>
         </p:spPr>
       </p:sp>
-      <p:sp>
-        <p:nvSpPr>
-          <p:cNvPr id="19" name="Text 13"/>
-          <p:cNvSpPr txBox="1"/>
-          <p:nvPr/>
-        </p:nvSpPr>
-        <p:spPr>
-          <a:xfrm>
-            <a:off x="5315407" y="2542032"/>
+      <p:pic>
+        <p:nvPicPr>
+          <p:cNvPr id="20" name="Photo ai_floor" descr="Illustration: a creator films himself on a gimbal in the festival crowd">    </p:cNvPr>
+          <p:cNvPicPr>
+            <a:picLocks noChangeAspect="1"/>
+          </p:cNvPicPr>
+          <p:nvPr/>
+        </p:nvPicPr>
+        <p:blipFill>
+          <a:blip r:embed="rId5"/>
+          <a:stretch>
+            <a:fillRect/>
+          </a:stretch>
+        </p:blipFill>
+        <p:spPr>
+          <a:xfrm>
+            <a:off x="5315407" y="2487168"/>
+            <a:ext cx="2114404" cy="1188720"/>
+          </a:xfrm>
+          <a:prstGeom prst="rect">
+            <a:avLst/>
+          </a:prstGeom>
+        </p:spPr>
+      </p:pic>
+      <p:sp>
+        <p:nvSpPr>
+          <p:cNvPr id="21" name="Text 13"/>
+          <p:cNvSpPr txBox="1"/>
+          <p:nvPr/>
+        </p:nvSpPr>
+        <p:spPr>
+          <a:xfrm>
+            <a:off x="5315407" y="3822192"/>
             <a:ext cx="2615184" cy="256032"/>
           </a:xfrm>
           <a:prstGeom prst="rect">
@@ -15857,14 +15981,14 @@
       </p:sp>
       <p:sp>
         <p:nvSpPr>
-          <p:cNvPr id="20" name="Text 14"/>
-          <p:cNvSpPr txBox="1"/>
-          <p:nvPr/>
-        </p:nvSpPr>
-        <p:spPr>
-          <a:xfrm>
-            <a:off x="5315407" y="2852928"/>
-            <a:ext cx="2615184" cy="457200"/>
+          <p:cNvPr id="22" name="Text 14"/>
+          <p:cNvSpPr txBox="1"/>
+          <p:nvPr/>
+        </p:nvSpPr>
+        <p:spPr>
+          <a:xfrm>
+            <a:off x="5315407" y="4069080"/>
+            <a:ext cx="2615184" cy="411480"/>
           </a:xfrm>
           <a:prstGeom prst="rect">
             <a:avLst/>
@@ -15880,7 +16004,7 @@
               <a:buNone/>
             </a:pPr>
             <a:r>
-              <a:rPr lang="en-GB" altLang="en-US" sz="2600" dirty="0">
+              <a:rPr lang="en-GB" altLang="en-US" sz="2400" dirty="0">
                 <a:solidFill>
                   <a:schemeClr val="tx1"/>
                 </a:solidFill>
@@ -15890,20 +16014,20 @@
               </a:rPr>
               <a:t>Festival nights</a:t>
             </a:r>
-            <a:endParaRPr lang="en-GB" sz="2600" dirty="0"/>
-          </a:p>
-        </p:txBody>
-      </p:sp>
-      <p:sp>
-        <p:nvSpPr>
-          <p:cNvPr id="21" name="Text 15"/>
-          <p:cNvSpPr txBox="1"/>
-          <p:nvPr/>
-        </p:nvSpPr>
-        <p:spPr>
-          <a:xfrm>
-            <a:off x="5315407" y="3383280"/>
-            <a:ext cx="2615184" cy="320040"/>
+            <a:endParaRPr lang="en-GB" sz="2400" dirty="0"/>
+          </a:p>
+        </p:txBody>
+      </p:sp>
+      <p:sp>
+        <p:nvSpPr>
+          <p:cNvPr id="23" name="Text 15"/>
+          <p:cNvSpPr txBox="1"/>
+          <p:nvPr/>
+        </p:nvSpPr>
+        <p:spPr>
+          <a:xfrm>
+            <a:off x="5315407" y="4526280"/>
+            <a:ext cx="2615184" cy="292608"/>
           </a:xfrm>
           <a:prstGeom prst="rect">
             <a:avLst/>
@@ -15919,27 +16043,27 @@
               <a:buNone/>
             </a:pPr>
             <a:r>
-              <a:rPr lang="en-GB" altLang="en-US" sz="1400" b="1" dirty="0">
+              <a:rPr lang="en-GB" altLang="en-US" sz="1300" b="1" dirty="0">
                 <a:solidFill>
                   <a:schemeClr val="tx1"/>
                 </a:solidFill>
               </a:rPr>
               <a:t>Goal: live attention</a:t>
             </a:r>
-            <a:endParaRPr lang="en-GB" sz="1400" dirty="0"/>
-          </a:p>
-        </p:txBody>
-      </p:sp>
-      <p:sp>
-        <p:nvSpPr>
-          <p:cNvPr id="22" name="Text 16"/>
-          <p:cNvSpPr txBox="1"/>
-          <p:nvPr/>
-        </p:nvSpPr>
-        <p:spPr>
-          <a:xfrm>
-            <a:off x="5315407" y="3840480"/>
-            <a:ext cx="2615184" cy="1325880"/>
+            <a:endParaRPr lang="en-GB" sz="1300" dirty="0"/>
+          </a:p>
+        </p:txBody>
+      </p:sp>
+      <p:sp>
+        <p:nvSpPr>
+          <p:cNvPr id="24" name="Text 16"/>
+          <p:cNvSpPr txBox="1"/>
+          <p:nvPr/>
+        </p:nvSpPr>
+        <p:spPr>
+          <a:xfrm>
+            <a:off x="5315407" y="4892040"/>
+            <a:ext cx="2615184" cy="1188720"/>
           </a:xfrm>
           <a:prstGeom prst="rect">
             <a:avLst/>
@@ -15953,80 +16077,80 @@
           <a:p>
             <a:pPr marL="177800" indent="-177800">
               <a:spcAft>
-                <a:spcPts val="600"/>
+                <a:spcPts val="400"/>
               </a:spcAft>
               <a:buSzPct val="100000"/>
               <a:buChar char="•"/>
             </a:pPr>
             <a:r>
-              <a:rPr lang="en-GB" altLang="en-US" sz="1300" dirty="0">
+              <a:rPr lang="en-GB" altLang="en-US" sz="1250" dirty="0">
                 <a:solidFill>
                   <a:schemeClr val="tx1"/>
                 </a:solidFill>
               </a:rPr>
               <a:t>Arrivals and festival looks</a:t>
             </a:r>
-            <a:endParaRPr lang="en-GB" sz="1300" dirty="0"/>
+            <a:endParaRPr lang="en-GB" sz="1250" dirty="0"/>
           </a:p>
           <a:p>
             <a:pPr marL="177800" indent="-177800">
               <a:spcAft>
-                <a:spcPts val="600"/>
+                <a:spcPts val="400"/>
               </a:spcAft>
               <a:buSzPct val="100000"/>
               <a:buChar char="•"/>
             </a:pPr>
             <a:r>
-              <a:rPr lang="en-GB" altLang="en-US" sz="1300" dirty="0">
+              <a:rPr lang="en-GB" altLang="en-US" sz="1250" dirty="0">
                 <a:solidFill>
                   <a:schemeClr val="tx1"/>
                 </a:solidFill>
               </a:rPr>
               <a:t>Crowd POV during headline sets</a:t>
             </a:r>
-            <a:endParaRPr lang="en-GB" sz="1300" dirty="0"/>
+            <a:endParaRPr lang="en-GB" sz="1250" dirty="0"/>
           </a:p>
           <a:p>
             <a:pPr marL="177800" indent="-177800">
               <a:spcAft>
-                <a:spcPts val="600"/>
+                <a:spcPts val="400"/>
               </a:spcAft>
               <a:buSzPct val="100000"/>
               <a:buChar char="•"/>
             </a:pPr>
             <a:r>
-              <a:rPr lang="en-GB" altLang="en-US" sz="1300" dirty="0">
+              <a:rPr lang="en-GB" altLang="en-US" sz="1250" dirty="0">
                 <a:solidFill>
                   <a:schemeClr val="tx1"/>
                 </a:solidFill>
               </a:rPr>
               <a:t>Sponsor activations in shot</a:t>
             </a:r>
-            <a:endParaRPr lang="en-GB" sz="1300" dirty="0"/>
+            <a:endParaRPr lang="en-GB" sz="1250" dirty="0"/>
           </a:p>
           <a:p>
             <a:pPr marL="177800" indent="-177800">
               <a:spcAft>
-                <a:spcPts val="600"/>
+                <a:spcPts val="400"/>
               </a:spcAft>
               <a:buSzPct val="100000"/>
               <a:buChar char="•"/>
             </a:pPr>
             <a:r>
-              <a:rPr lang="en-GB" altLang="en-US" sz="1300" dirty="0">
+              <a:rPr lang="en-GB" altLang="en-US" sz="1250" dirty="0">
                 <a:solidFill>
                   <a:schemeClr val="tx1"/>
                 </a:solidFill>
               </a:rPr>
               <a:t>A recap each night</a:t>
             </a:r>
-            <a:endParaRPr lang="en-GB" sz="1300" dirty="0"/>
-          </a:p>
-        </p:txBody>
-      </p:sp>
-      <p:sp>
-        <p:nvSpPr>
-          <p:cNvPr id="23" name="Shape 17"/>
+            <a:endParaRPr lang="en-GB" sz="1250" dirty="0"/>
+          </a:p>
+        </p:txBody>
+      </p:sp>
+      <p:sp>
+        <p:nvSpPr>
+          <p:cNvPr id="25" name="Shape 17"/>
           <p:cNvSpPr/>
           <p:nvPr/>
         </p:nvSpPr>
@@ -16046,18 +16170,18 @@
       </p:sp>
       <p:sp>
         <p:nvSpPr>
-          <p:cNvPr id="24" name="Shape 18"/>
+          <p:cNvPr id="26" name="Shape 18"/>
           <p:cNvSpPr/>
           <p:nvPr/>
         </p:nvSpPr>
         <p:spPr>
           <a:xfrm>
-            <a:off x="8479231" y="2286000"/>
-            <a:ext cx="3163824" cy="2971800"/>
+            <a:off x="8479231" y="2240280"/>
+            <a:ext cx="3163824" cy="3931920"/>
           </a:xfrm>
           <a:prstGeom prst="roundRect">
             <a:avLst>
-              <a:gd name="adj" fmla="val 3077"/>
+              <a:gd name="adj" fmla="val 2890"/>
             </a:avLst>
           </a:prstGeom>
           <a:solidFill>
@@ -16066,15 +16190,39 @@
           <a:ln/>
         </p:spPr>
       </p:sp>
-      <p:sp>
-        <p:nvSpPr>
-          <p:cNvPr id="25" name="Text 19"/>
-          <p:cNvSpPr txBox="1"/>
-          <p:nvPr/>
-        </p:nvSpPr>
-        <p:spPr>
-          <a:xfrm>
-            <a:off x="8753551" y="2542032"/>
+      <p:pic>
+        <p:nvPicPr>
+          <p:cNvPr id="27" name="Photo ai_afterglow" descr="Illustration: a creator edits a recap reel on a balcony the morning after">    </p:cNvPr>
+          <p:cNvPicPr>
+            <a:picLocks noChangeAspect="1"/>
+          </p:cNvPicPr>
+          <p:nvPr/>
+        </p:nvPicPr>
+        <p:blipFill>
+          <a:blip r:embed="rId6"/>
+          <a:stretch>
+            <a:fillRect/>
+          </a:stretch>
+        </p:blipFill>
+        <p:spPr>
+          <a:xfrm>
+            <a:off x="8753551" y="2487168"/>
+            <a:ext cx="1559321" cy="1188720"/>
+          </a:xfrm>
+          <a:prstGeom prst="rect">
+            <a:avLst/>
+          </a:prstGeom>
+        </p:spPr>
+      </p:pic>
+      <p:sp>
+        <p:nvSpPr>
+          <p:cNvPr id="28" name="Text 19"/>
+          <p:cNvSpPr txBox="1"/>
+          <p:nvPr/>
+        </p:nvSpPr>
+        <p:spPr>
+          <a:xfrm>
+            <a:off x="8753551" y="3822192"/>
             <a:ext cx="2615184" cy="256032"/>
           </a:xfrm>
           <a:prstGeom prst="rect">
@@ -16104,14 +16252,14 @@
       </p:sp>
       <p:sp>
         <p:nvSpPr>
-          <p:cNvPr id="26" name="Text 20"/>
-          <p:cNvSpPr txBox="1"/>
-          <p:nvPr/>
-        </p:nvSpPr>
-        <p:spPr>
-          <a:xfrm>
-            <a:off x="8753551" y="2852928"/>
-            <a:ext cx="2615184" cy="457200"/>
+          <p:cNvPr id="29" name="Text 20"/>
+          <p:cNvSpPr txBox="1"/>
+          <p:nvPr/>
+        </p:nvSpPr>
+        <p:spPr>
+          <a:xfrm>
+            <a:off x="8753551" y="4069080"/>
+            <a:ext cx="2615184" cy="411480"/>
           </a:xfrm>
           <a:prstGeom prst="rect">
             <a:avLst/>
@@ -16127,7 +16275,7 @@
               <a:buNone/>
             </a:pPr>
             <a:r>
-              <a:rPr lang="en-GB" altLang="en-US" sz="2600" dirty="0">
+              <a:rPr lang="en-GB" altLang="en-US" sz="2400" dirty="0">
                 <a:solidFill>
                   <a:schemeClr val="bg1"/>
                 </a:solidFill>
@@ -16137,20 +16285,20 @@
               </a:rPr>
               <a:t>Afterglow</a:t>
             </a:r>
-            <a:endParaRPr lang="en-GB" sz="2600" dirty="0"/>
-          </a:p>
-        </p:txBody>
-      </p:sp>
-      <p:sp>
-        <p:nvSpPr>
-          <p:cNvPr id="27" name="Text 21"/>
-          <p:cNvSpPr txBox="1"/>
-          <p:nvPr/>
-        </p:nvSpPr>
-        <p:spPr>
-          <a:xfrm>
-            <a:off x="8753551" y="3383280"/>
-            <a:ext cx="2615184" cy="320040"/>
+            <a:endParaRPr lang="en-GB" sz="2400" dirty="0"/>
+          </a:p>
+        </p:txBody>
+      </p:sp>
+      <p:sp>
+        <p:nvSpPr>
+          <p:cNvPr id="30" name="Text 21"/>
+          <p:cNvSpPr txBox="1"/>
+          <p:nvPr/>
+        </p:nvSpPr>
+        <p:spPr>
+          <a:xfrm>
+            <a:off x="8753551" y="4526280"/>
+            <a:ext cx="2615184" cy="292608"/>
           </a:xfrm>
           <a:prstGeom prst="rect">
             <a:avLst/>
@@ -16166,27 +16314,27 @@
               <a:buNone/>
             </a:pPr>
             <a:r>
-              <a:rPr lang="en-GB" altLang="en-US" sz="1400" b="1" dirty="0">
+              <a:rPr lang="en-GB" altLang="en-US" sz="1300" b="1" dirty="0">
                 <a:solidFill>
                   <a:schemeClr val="accent4"/>
                 </a:solidFill>
               </a:rPr>
               <a:t>Goal: keep the story alive</a:t>
             </a:r>
-            <a:endParaRPr lang="en-GB" sz="1400" dirty="0"/>
-          </a:p>
-        </p:txBody>
-      </p:sp>
-      <p:sp>
-        <p:nvSpPr>
-          <p:cNvPr id="28" name="Text 22"/>
-          <p:cNvSpPr txBox="1"/>
-          <p:nvPr/>
-        </p:nvSpPr>
-        <p:spPr>
-          <a:xfrm>
-            <a:off x="8753551" y="3840480"/>
-            <a:ext cx="2615184" cy="1325880"/>
+            <a:endParaRPr lang="en-GB" sz="1300" dirty="0"/>
+          </a:p>
+        </p:txBody>
+      </p:sp>
+      <p:sp>
+        <p:nvSpPr>
+          <p:cNvPr id="31" name="Text 22"/>
+          <p:cNvSpPr txBox="1"/>
+          <p:nvPr/>
+        </p:nvSpPr>
+        <p:spPr>
+          <a:xfrm>
+            <a:off x="8753551" y="4892040"/>
+            <a:ext cx="2615184" cy="1188720"/>
           </a:xfrm>
           <a:prstGeom prst="rect">
             <a:avLst/>
@@ -16200,133 +16348,74 @@
           <a:p>
             <a:pPr marL="177800" indent="-177800">
               <a:spcAft>
-                <a:spcPts val="600"/>
+                <a:spcPts val="400"/>
               </a:spcAft>
               <a:buSzPct val="100000"/>
               <a:buChar char="•"/>
             </a:pPr>
             <a:r>
-              <a:rPr lang="en-GB" altLang="en-US" sz="1300" dirty="0">
+              <a:rPr lang="en-GB" altLang="en-US" sz="1250" dirty="0">
                 <a:solidFill>
                   <a:schemeClr val="accent5"/>
                 </a:solidFill>
               </a:rPr>
               <a:t>Recap reels and best of edits</a:t>
             </a:r>
-            <a:endParaRPr lang="en-GB" sz="1300" dirty="0"/>
+            <a:endParaRPr lang="en-GB" sz="1250" dirty="0"/>
           </a:p>
           <a:p>
             <a:pPr marL="177800" indent="-177800">
               <a:spcAft>
-                <a:spcPts val="600"/>
+                <a:spcPts val="400"/>
               </a:spcAft>
               <a:buSzPct val="100000"/>
               <a:buChar char="•"/>
             </a:pPr>
             <a:r>
-              <a:rPr lang="en-GB" altLang="en-US" sz="1300" dirty="0">
+              <a:rPr lang="en-GB" altLang="en-US" sz="1250" dirty="0">
                 <a:solidFill>
                   <a:schemeClr val="accent5"/>
                 </a:solidFill>
               </a:rPr>
               <a:t>Creator thank you posts</a:t>
             </a:r>
-            <a:endParaRPr lang="en-GB" sz="1300" dirty="0"/>
+            <a:endParaRPr lang="en-GB" sz="1250" dirty="0"/>
           </a:p>
           <a:p>
             <a:pPr marL="177800" indent="-177800">
               <a:spcAft>
-                <a:spcPts val="600"/>
+                <a:spcPts val="400"/>
               </a:spcAft>
               <a:buSzPct val="100000"/>
               <a:buChar char="•"/>
             </a:pPr>
             <a:r>
-              <a:rPr lang="en-GB" altLang="en-US" sz="1300" dirty="0">
+              <a:rPr lang="en-GB" altLang="en-US" sz="1250" dirty="0">
                 <a:solidFill>
                   <a:schemeClr val="accent5"/>
                 </a:solidFill>
               </a:rPr>
-              <a:t>Results shared with fans and partners</a:t>
-            </a:r>
-            <a:endParaRPr lang="en-GB" sz="1300" dirty="0"/>
+              <a:t>Results shared with partners</a:t>
+            </a:r>
+            <a:endParaRPr lang="en-GB" sz="1250" dirty="0"/>
           </a:p>
           <a:p>
             <a:pPr marL="177800" indent="-177800">
               <a:spcAft>
-                <a:spcPts val="600"/>
+                <a:spcPts val="400"/>
               </a:spcAft>
               <a:buSzPct val="100000"/>
               <a:buChar char="•"/>
             </a:pPr>
             <a:r>
-              <a:rPr lang="en-GB" altLang="en-US" sz="1300" dirty="0">
+              <a:rPr lang="en-GB" altLang="en-US" sz="1250" dirty="0">
                 <a:solidFill>
                   <a:schemeClr val="accent5"/>
                 </a:solidFill>
               </a:rPr>
-              <a:t>A 2027 save the date, if planned</a:t>
-            </a:r>
-            <a:endParaRPr lang="en-GB" sz="1300" dirty="0"/>
-          </a:p>
-        </p:txBody>
-      </p:sp>
-      <p:sp>
-        <p:nvSpPr>
-          <p:cNvPr id="29" name="Shape 23"/>
-          <p:cNvSpPr/>
-          <p:nvPr/>
-        </p:nvSpPr>
-        <p:spPr>
-          <a:xfrm>
-            <a:off x="548640" y="5532120"/>
-            <a:ext cx="54864" cy="548640"/>
-          </a:xfrm>
-          <a:prstGeom prst="rect">
-            <a:avLst/>
-          </a:prstGeom>
-          <a:solidFill>
-            <a:schemeClr val="accent1"/>
-          </a:solidFill>
-          <a:ln/>
-        </p:spPr>
-      </p:sp>
-      <p:sp>
-        <p:nvSpPr>
-          <p:cNvPr id="30" name="Text 24"/>
-          <p:cNvSpPr txBox="1"/>
-          <p:nvPr/>
-        </p:nvSpPr>
-        <p:spPr>
-          <a:xfrm>
-            <a:off x="777240" y="5532120"/>
-            <a:ext cx="10789920" cy="548640"/>
-          </a:xfrm>
-          <a:prstGeom prst="rect">
-            <a:avLst/>
-          </a:prstGeom>
-          <a:noFill/>
-          <a:ln/>
-        </p:spPr>
-        <p:txBody>
-          <a:bodyPr wrap="square" lIns="0" tIns="0" rIns="0" bIns="0" rtlCol="0" anchor="ctr"/>
-          <a:lstStyle/>
-          <a:p>
-            <a:pPr indent="0" marL="0">
-              <a:buNone/>
-            </a:pPr>
-            <a:r>
-              <a:rPr lang="en-GB" altLang="en-US" sz="2000" dirty="0">
-                <a:solidFill>
-                  <a:schemeClr val="bg1"/>
-                </a:solidFill>
-                <a:latin typeface="+mj-lt" pitchFamily="34" charset="0"/>
-                <a:ea typeface="+mj-lt" pitchFamily="34" charset="-122"/>
-                <a:cs typeface="+mj-lt" pitchFamily="34" charset="-120"/>
-              </a:rPr>
-              <a:t>Every wave sits in one content calendar, approved by the festival before anything goes live.</a:t>
-            </a:r>
-            <a:endParaRPr lang="en-GB" sz="2000" dirty="0"/>
+              <a:t>A 2027 save the date</a:t>
+            </a:r>
+            <a:endParaRPr lang="en-GB" sz="1250" dirty="0"/>
           </a:p>
         </p:txBody>
       </p:sp>
@@ -19861,31 +19950,9 @@
           </a:p>
         </p:txBody>
       </p:sp>
-      <p:sp>
-        <p:nvSpPr>
-          <p:cNvPr id="18" name="Shape 13"/>
-          <p:cNvSpPr/>
-          <p:nvPr/>
-        </p:nvSpPr>
-        <p:spPr>
-          <a:xfrm>
-            <a:off x="7452360" y="1783080"/>
-            <a:ext cx="4190695" cy="4251960"/>
-          </a:xfrm>
-          <a:prstGeom prst="roundRect">
-            <a:avLst>
-              <a:gd name="adj" fmla="val 2182"/>
-            </a:avLst>
-          </a:prstGeom>
-          <a:solidFill>
-            <a:schemeClr val="tx1"/>
-          </a:solidFill>
-          <a:ln/>
-        </p:spPr>
-      </p:sp>
       <p:pic>
         <p:nvPicPr>
-          <p:cNvPr id="19" name="Image 2" descr="Mother Africa Festival">    </p:cNvPr>
+          <p:cNvPr id="18" name="Photo ai_pass" descr="Illustration: a Mother Africa Festival creator accreditation pass on a lanyard">    </p:cNvPr>
           <p:cNvPicPr>
             <a:picLocks noChangeAspect="1"/>
           </p:cNvPicPr>
@@ -19899,8 +19966,8 @@
         </p:blipFill>
         <p:spPr>
           <a:xfrm>
-            <a:off x="8548974" y="2240280"/>
-            <a:ext cx="1997467" cy="1417320"/>
+            <a:off x="7452360" y="1783080"/>
+            <a:ext cx="4190695" cy="3143021"/>
           </a:xfrm>
           <a:prstGeom prst="rect">
             <a:avLst/>
@@ -19909,43 +19976,29 @@
       </p:pic>
       <p:sp>
         <p:nvSpPr>
-          <p:cNvPr id="20" name="Text 14"/>
-          <p:cNvSpPr txBox="1"/>
-          <p:nvPr/>
-        </p:nvSpPr>
-        <p:spPr>
-          <a:xfrm>
-            <a:off x="7452360" y="3749040"/>
-            <a:ext cx="4190695" cy="548640"/>
-          </a:xfrm>
-          <a:prstGeom prst="rect">
-            <a:avLst/>
-          </a:prstGeom>
-          <a:noFill/>
-          <a:ln/>
-        </p:spPr>
-        <p:txBody>
-          <a:bodyPr wrap="square" lIns="0" tIns="0" rIns="0" bIns="0" rtlCol="0" anchor="ctr"/>
-          <a:lstStyle/>
-          <a:p>
-            <a:pPr algn="ctr" indent="0" marL="0">
-              <a:buNone/>
-            </a:pPr>
-            <a:r>
-              <a:rPr lang="en-GB" altLang="en-US" sz="3000" dirty="0">
-                <a:solidFill>
-                  <a:schemeClr val="accent1"/>
-                </a:solidFill>
-              </a:rPr>
-              <a:t>×</a:t>
-            </a:r>
-            <a:endParaRPr lang="en-GB" sz="3000" dirty="0"/>
-          </a:p>
-        </p:txBody>
+          <p:cNvPr id="19" name="Shape 13"/>
+          <p:cNvSpPr/>
+          <p:nvPr/>
+        </p:nvSpPr>
+        <p:spPr>
+          <a:xfrm>
+            <a:off x="7452360" y="5063261"/>
+            <a:ext cx="4190695" cy="971779"/>
+          </a:xfrm>
+          <a:prstGeom prst="roundRect">
+            <a:avLst>
+              <a:gd name="adj" fmla="val 7528"/>
+            </a:avLst>
+          </a:prstGeom>
+          <a:solidFill>
+            <a:schemeClr val="tx1"/>
+          </a:solidFill>
+          <a:ln/>
+        </p:spPr>
       </p:sp>
       <p:pic>
         <p:nvPicPr>
-          <p:cNvPr id="21" name="Image 3" descr="AToure Management &amp; Consulting">    </p:cNvPr>
+          <p:cNvPr id="20" name="Image 3" descr="Mother Africa Festival">    </p:cNvPr>
           <p:cNvPicPr>
             <a:picLocks noChangeAspect="1"/>
           </p:cNvPicPr>
@@ -19959,8 +20012,8 @@
         </p:blipFill>
         <p:spPr>
           <a:xfrm>
-            <a:off x="7993228" y="4480560"/>
-            <a:ext cx="3108960" cy="497434"/>
+            <a:off x="7726680" y="5265687"/>
+            <a:ext cx="798987" cy="566928"/>
           </a:xfrm>
           <a:prstGeom prst="rect">
             <a:avLst/>
@@ -19969,40 +20022,64 @@
       </p:pic>
       <p:sp>
         <p:nvSpPr>
-          <p:cNvPr id="22" name="Text 15"/>
-          <p:cNvSpPr txBox="1"/>
-          <p:nvPr/>
-        </p:nvSpPr>
-        <p:spPr>
-          <a:xfrm>
-            <a:off x="7452360" y="5349240"/>
-            <a:ext cx="4190695" cy="274320"/>
-          </a:xfrm>
-          <a:prstGeom prst="rect">
-            <a:avLst/>
-          </a:prstGeom>
-          <a:noFill/>
-          <a:ln/>
-        </p:spPr>
-        <p:txBody>
-          <a:bodyPr wrap="square" lIns="0" tIns="0" rIns="0" bIns="0" rtlCol="0" anchor="t"/>
+          <p:cNvPr id="21" name="Text 14"/>
+          <p:cNvSpPr txBox="1"/>
+          <p:nvPr/>
+        </p:nvSpPr>
+        <p:spPr>
+          <a:xfrm>
+            <a:off x="8595360" y="5063261"/>
+            <a:ext cx="365760" cy="971779"/>
+          </a:xfrm>
+          <a:prstGeom prst="rect">
+            <a:avLst/>
+          </a:prstGeom>
+          <a:noFill/>
+          <a:ln/>
+        </p:spPr>
+        <p:txBody>
+          <a:bodyPr wrap="square" lIns="0" tIns="0" rIns="0" bIns="0" rtlCol="0" anchor="ctr"/>
           <a:lstStyle/>
           <a:p>
             <a:pPr algn="ctr" indent="0" marL="0">
               <a:buNone/>
             </a:pPr>
             <a:r>
-              <a:rPr lang="en-GB" altLang="en-US" sz="1100" dirty="0">
-                <a:solidFill>
-                  <a:schemeClr val="accent4"/>
-                </a:solidFill>
-              </a:rPr>
-              <a:t>27 and 28 December 2026  ·  Marcory Zone 4</a:t>
-            </a:r>
-            <a:endParaRPr lang="en-GB" sz="1100" dirty="0"/>
-          </a:p>
-        </p:txBody>
-      </p:sp>
+              <a:rPr lang="en-GB" altLang="en-US" sz="2000" dirty="0">
+                <a:solidFill>
+                  <a:schemeClr val="accent1"/>
+                </a:solidFill>
+              </a:rPr>
+              <a:t>×</a:t>
+            </a:r>
+            <a:endParaRPr lang="en-GB" sz="2000" dirty="0"/>
+          </a:p>
+        </p:txBody>
+      </p:sp>
+      <p:pic>
+        <p:nvPicPr>
+          <p:cNvPr id="22" name="Image 4" descr="AToure Management &amp; Consulting">    </p:cNvPr>
+          <p:cNvPicPr>
+            <a:picLocks noChangeAspect="1"/>
+          </p:cNvPicPr>
+          <p:nvPr/>
+        </p:nvPicPr>
+        <p:blipFill>
+          <a:blip r:embed="rId5"/>
+          <a:stretch>
+            <a:fillRect/>
+          </a:stretch>
+        </p:blipFill>
+        <p:spPr>
+          <a:xfrm>
+            <a:off x="9098280" y="5366271"/>
+            <a:ext cx="2286000" cy="365760"/>
+          </a:xfrm>
+          <a:prstGeom prst="rect">
+            <a:avLst/>
+          </a:prstGeom>
+        </p:spPr>
+      </p:pic>
       <p:sp>
         <p:nvSpPr>
           <p:cNvPr id="25" name="Slide Number Placeholder 0"/>

</xml_diff>